<commit_message>
World Animal Day v2 to the updated brief: first-version photos only (new downloads removed), cow cover, flux-2-pro line icons in assets/icons, new copy, labels and sources
Co-Authored-By: Claude Opus 5.5 <noreply@anthropic.com>
Claude-Session: https://claude.ai/code/session_014HGzAbxBh54nuyJHG7tse8
</commit_message>
<xml_diff>
--- a/templates/posts/october/04-10-2026-sun-ig-world-animal-day-v2.pptx
+++ b/templates/posts/october/04-10-2026-sun-ig-world-animal-day-v2.pptx
@@ -508,7 +508,7 @@
           <a:lstStyle/>
           <a:p>
             <a:r>
-              <a:t>Cover. Trifold-style v2. Sources: Soil Food Web School, Compost Manual: [LINK FROM CARLA]. Miller et al. (2015). Ascariasis in humans and pigs on small-scale farms, Maine, USA, 2010 to 2013. Emerging Infectious Diseases, 21(2): https://doi.org/10.3201/eid2102.140048. USDA NRCS and Fairbanks Soil and Water Conservation District (2005). Composting Dog Waste: https://www.epa.gov/system/files/documents/2022-11/Composting-Dog-Waste-Booklet-Alaska.pdf. CDC (2025). About Toxoplasmosis: https://www.cdc.gov/toxoplasmosis/about/index.html. Course: https://school.soilfoodweb.com/bundles/advanced-biocomplete-compost-production Photo barnyard.jpg: Stephen Mease on Unsplash, https://unsplash.com/photos/a-group-of-chickens-and-sheep-in-a-barn-l4Pkxre1GiE.</a:t>
+              <a:t>Cover. Trifold-style v2. Sources: Soil Food Web School, Compost Manual: [LINK FROM CARLA]. Soil Food Web School, BioComplete Compost, Lecture 4: Thermophilic Composting (Part 2): https://pt.soilfoodweb.com/?p=2067. Miller et al. (2015). Ascariasis in humans and pigs on small-scale farms, Maine, USA, 2010 to 2013. Emerging Infectious Diseases, 21(2): https://doi.org/10.3201/eid2102.140048. USDA NRCS and Fairbanks Soil and Water Conservation District (2005). Composting Dog Waste: https://www.epa.gov/system/files/documents/2022-11/Composting-Dog-Waste-Booklet-Alaska.pdf. CDC (2025). About Toxoplasmosis: https://www.cdc.gov/toxoplasmosis/about/index.html. Course: https://school.soilfoodweb.com/bundles/advanced-biocomplete-compost-production Photo cow.jpg: Diana Shchurova on Unsplash, https://unsplash.com/photos/a-brown-and-white-cow-standing-on-top-of-a-grass-covered-field-tDRZNFrz9yA.</a:t>
             </a:r>
           </a:p>
         </p:txBody>
@@ -578,7 +578,7 @@
           <a:lstStyle/>
           <a:p>
             <a:r>
-              <a:t>Three ingredient tiles. Photo manure.jpg: Wolfgang Weiser on Unsplash, https://unsplash.com/photos/large-manure-piles-in-a-golden-harvested-field-6iG19RE7Nic. Photo grass-clippings.jpg: Roger Starnes Sr on Unsplash, https://unsplash.com/photos/freshly-cut-grass-lies-on-the-lawn-8T7ebXcPYHg. Photo wood-chips.jpg: John Kinnander on Unsplash, https://unsplash.com/photos/brown-wood-logs-in-close-up-photography-6H-Bt7kMYHA.</a:t>
+              <a:t>Three feedstock tiles with line icons from assets/icons/ (generated with flux-2-pro, no photos on this slide).</a:t>
             </a:r>
           </a:p>
         </p:txBody>
@@ -858,7 +858,7 @@
           <a:lstStyle/>
           <a:p>
             <a:r>
-              <a:t>Two panels with a Food Web Green rule on the left edge, then a compost pile photo. No steaming pile or compost thermometer was found on Unsplash; a garden fork in a compost pile is used instead. Photo compost-fork.jpg: Roberto Catarinicchia on Unsplash, https://unsplash.com/photos/a-garden-fork-stuck-in-a-pile-of-dirt-eNMvmX0c_vQ.</a:t>
+              <a:t>Two panels with a Food Web Green rule on the left edge, then the compost bin photo from the first version. Thermometer icon: assets/icons/icon-compost-thermometer-green.png. Photo compost-4.jpg: Frank Thiemonge on Unsplash, https://unsplash.com/photos/a-couple-of-wooden-boxes-filled-with-dirt-GXEPGA3k7N0.</a:t>
             </a:r>
           </a:p>
         </p:txBody>
@@ -3936,7 +3936,7 @@
       <p:grpSpPr/>
       <p:pic>
         <p:nvPicPr>
-          <p:cNvPr id="2" name="Picture 1" descr="7097252766454217074.jpg"/>
+          <p:cNvPr id="2" name="Picture 1" descr="369434124111978967.jpg"/>
           <p:cNvPicPr>
             <a:picLocks noChangeAspect="1"/>
           </p:cNvPicPr>
@@ -4118,7 +4118,7 @@
                 </a:solidFill>
                 <a:latin typeface="Source Sans 3"/>
               </a:rPr>
-              <a:t>Photo: Stephen Mease on Unsplash</a:t>
+              <a:t>Photo: Diana Shchurova on Unsplash</a:t>
             </a:r>
           </a:p>
         </p:txBody>
@@ -4182,7 +4182,7 @@
         <p:spPr>
           <a:xfrm>
             <a:off x="762000" y="952500"/>
-            <a:ext cx="8763000" cy="1831804"/>
+            <a:ext cx="8763000" cy="2709606"/>
           </a:xfrm>
           <a:prstGeom prst="rect">
             <a:avLst/>
@@ -4207,23 +4207,7 @@
                 </a:solidFill>
                 <a:latin typeface="Montserrat"/>
               </a:rPr>
-              <a:t>Manure is one</a:t>
-            </a:r>
-          </a:p>
-          <a:p>
-            <a:pPr algn="l">
-              <a:lnSpc>
-                <a:spcPct val="105000"/>
-              </a:lnSpc>
-            </a:pPr>
-            <a:r>
-              <a:rPr sz="6400" b="1" i="0">
-                <a:solidFill>
-                  <a:srgbClr val="22371F"/>
-                </a:solidFill>
-                <a:latin typeface="Montserrat"/>
-              </a:rPr>
-              <a:t>ingredient.</a:t>
+              <a:t>Manure: a high-nitrogen feedstock</a:t>
             </a:r>
           </a:p>
         </p:txBody>
@@ -4236,8 +4220,8 @@
         </p:nvSpPr>
         <p:spPr>
           <a:xfrm>
-            <a:off x="762000" y="2936704"/>
-            <a:ext cx="8763000" cy="2286000"/>
+            <a:off x="762000" y="3067050"/>
+            <a:ext cx="8763000" cy="3429000"/>
           </a:xfrm>
           <a:prstGeom prst="rect">
             <a:avLst/>
@@ -4262,7 +4246,7 @@
                 </a:solidFill>
                 <a:latin typeface="Source Sans 3"/>
               </a:rPr>
-              <a:t>In a Soil Food Web compost pile, manure is the high-nitrogen part. It goes in with green plant material and woody material. Bedding counts as woody material.</a:t>
+              <a:t>A Soil Food Web thermophilic compost recipe combines three feedstocks: high-nitrogen material such as manure (about 10% in summer), green plant material (about 30%) and woody material (about 60%). Bedding, such as straw or wood shavings, counts toward the woody share.</a:t>
             </a:r>
           </a:p>
         </p:txBody>
@@ -4275,19 +4259,17 @@
         </p:nvSpPr>
         <p:spPr>
           <a:xfrm>
-            <a:off x="762000" y="5829300"/>
-            <a:ext cx="8763000" cy="19050"/>
-          </a:xfrm>
-          <a:prstGeom prst="rect">
-            <a:avLst/>
-          </a:prstGeom>
-          <a:solidFill>
-            <a:srgbClr val="4F3433">
-              <a:alpha val="22000"/>
-            </a:srgbClr>
-          </a:solidFill>
-          <a:ln>
-            <a:noFill/>
+            <a:off x="762000" y="7620000"/>
+            <a:ext cx="2717800" cy="2190750"/>
+          </a:xfrm>
+          <a:prstGeom prst="rect">
+            <a:avLst/>
+          </a:prstGeom>
+          <a:noFill/>
+          <a:ln w="19050">
+            <a:solidFill>
+              <a:srgbClr val="4F3433"/>
+            </a:solidFill>
           </a:ln>
           <a:effectLst/>
         </p:spPr>
@@ -4315,7 +4297,7 @@
       </p:sp>
       <p:pic>
         <p:nvPicPr>
-          <p:cNvPr id="5" name="Picture 4" descr="1725951667796843166.jpg"/>
+          <p:cNvPr id="5" name="Picture 4" descr="icon-manure-fork-deep.png"/>
           <p:cNvPicPr>
             <a:picLocks noChangeAspect="1"/>
           </p:cNvPicPr>
@@ -4329,8 +4311,8 @@
         </p:blipFill>
         <p:spPr>
           <a:xfrm>
-            <a:off x="762000" y="6210300"/>
-            <a:ext cx="2768600" cy="2768600"/>
+            <a:off x="1502898" y="8096250"/>
+            <a:ext cx="1236002" cy="1238250"/>
           </a:xfrm>
           <a:prstGeom prst="rect">
             <a:avLst/>
@@ -4345,8 +4327,8 @@
         </p:nvSpPr>
         <p:spPr>
           <a:xfrm>
-            <a:off x="762000" y="9131300"/>
-            <a:ext cx="2768600" cy="342900"/>
+            <a:off x="609600" y="9963150"/>
+            <a:ext cx="3022600" cy="342900"/>
           </a:xfrm>
           <a:prstGeom prst="rect">
             <a:avLst/>
@@ -4359,7 +4341,7 @@
           </a:bodyPr>
           <a:lstStyle/>
           <a:p>
-            <a:pPr algn="l">
+            <a:pPr algn="ctr">
               <a:lnSpc>
                 <a:spcPct val="120000"/>
               </a:lnSpc>
@@ -4371,14 +4353,58 @@
                 </a:solidFill>
                 <a:latin typeface="Montserrat"/>
               </a:rPr>
-              <a:t>High nitrogen</a:t>
-            </a:r>
+              <a:t>High nitrogen, 10%</a:t>
+            </a:r>
+          </a:p>
+        </p:txBody>
+      </p:sp>
+      <p:sp>
+        <p:nvSpPr>
+          <p:cNvPr id="7" name="Rectangle 6"/>
+          <p:cNvSpPr/>
+          <p:nvPr/>
+        </p:nvSpPr>
+        <p:spPr>
+          <a:xfrm>
+            <a:off x="3784600" y="7620000"/>
+            <a:ext cx="2717800" cy="2190750"/>
+          </a:xfrm>
+          <a:prstGeom prst="rect">
+            <a:avLst/>
+          </a:prstGeom>
+          <a:noFill/>
+          <a:ln w="19050">
+            <a:solidFill>
+              <a:srgbClr val="4F3433"/>
+            </a:solidFill>
+          </a:ln>
+          <a:effectLst/>
+        </p:spPr>
+        <p:style>
+          <a:lnRef idx="1">
+            <a:schemeClr val="accent1"/>
+          </a:lnRef>
+          <a:fillRef idx="3">
+            <a:schemeClr val="accent1"/>
+          </a:fillRef>
+          <a:effectRef idx="2">
+            <a:schemeClr val="accent1"/>
+          </a:effectRef>
+          <a:fontRef idx="minor">
+            <a:schemeClr val="lt1"/>
+          </a:fontRef>
+        </p:style>
+        <p:txBody>
+          <a:bodyPr rtlCol="0" anchor="ctr"/>
+          <a:lstStyle/>
+          <a:p>
+            <a:pPr algn="ctr"/>
           </a:p>
         </p:txBody>
       </p:sp>
       <p:pic>
         <p:nvPicPr>
-          <p:cNvPr id="7" name="Picture 6" descr="6096881470825408936.jpg"/>
+          <p:cNvPr id="8" name="Picture 7" descr="icon-leaf-deep.png"/>
           <p:cNvPicPr>
             <a:picLocks noChangeAspect="1"/>
           </p:cNvPicPr>
@@ -4392,8 +4418,8 @@
         </p:blipFill>
         <p:spPr>
           <a:xfrm>
-            <a:off x="3759200" y="6210300"/>
-            <a:ext cx="2768600" cy="2768600"/>
+            <a:off x="4687755" y="8096250"/>
+            <a:ext cx="911489" cy="1238250"/>
           </a:xfrm>
           <a:prstGeom prst="rect">
             <a:avLst/>
@@ -4402,14 +4428,14 @@
       </p:pic>
       <p:sp>
         <p:nvSpPr>
-          <p:cNvPr id="8" name="TextBox 7"/>
+          <p:cNvPr id="9" name="TextBox 8"/>
           <p:cNvSpPr txBox="1"/>
           <p:nvPr/>
         </p:nvSpPr>
         <p:spPr>
           <a:xfrm>
-            <a:off x="3759200" y="9131300"/>
-            <a:ext cx="2768600" cy="342900"/>
+            <a:off x="3632200" y="9963150"/>
+            <a:ext cx="3022600" cy="342900"/>
           </a:xfrm>
           <a:prstGeom prst="rect">
             <a:avLst/>
@@ -4422,7 +4448,7 @@
           </a:bodyPr>
           <a:lstStyle/>
           <a:p>
-            <a:pPr algn="l">
+            <a:pPr algn="ctr">
               <a:lnSpc>
                 <a:spcPct val="120000"/>
               </a:lnSpc>
@@ -4434,14 +4460,58 @@
                 </a:solidFill>
                 <a:latin typeface="Montserrat"/>
               </a:rPr>
-              <a:t>Green</a:t>
-            </a:r>
+              <a:t>Green, 30%</a:t>
+            </a:r>
+          </a:p>
+        </p:txBody>
+      </p:sp>
+      <p:sp>
+        <p:nvSpPr>
+          <p:cNvPr id="10" name="Rectangle 9"/>
+          <p:cNvSpPr/>
+          <p:nvPr/>
+        </p:nvSpPr>
+        <p:spPr>
+          <a:xfrm>
+            <a:off x="6807200" y="7620000"/>
+            <a:ext cx="2717800" cy="2190750"/>
+          </a:xfrm>
+          <a:prstGeom prst="rect">
+            <a:avLst/>
+          </a:prstGeom>
+          <a:noFill/>
+          <a:ln w="19050">
+            <a:solidFill>
+              <a:srgbClr val="4F3433"/>
+            </a:solidFill>
+          </a:ln>
+          <a:effectLst/>
+        </p:spPr>
+        <p:style>
+          <a:lnRef idx="1">
+            <a:schemeClr val="accent1"/>
+          </a:lnRef>
+          <a:fillRef idx="3">
+            <a:schemeClr val="accent1"/>
+          </a:fillRef>
+          <a:effectRef idx="2">
+            <a:schemeClr val="accent1"/>
+          </a:effectRef>
+          <a:fontRef idx="minor">
+            <a:schemeClr val="lt1"/>
+          </a:fontRef>
+        </p:style>
+        <p:txBody>
+          <a:bodyPr rtlCol="0" anchor="ctr"/>
+          <a:lstStyle/>
+          <a:p>
+            <a:pPr algn="ctr"/>
           </a:p>
         </p:txBody>
       </p:sp>
       <p:pic>
         <p:nvPicPr>
-          <p:cNvPr id="9" name="Picture 8" descr="2102583727324292759.jpg"/>
+          <p:cNvPr id="11" name="Picture 10" descr="icon-wood-log-deep.png"/>
           <p:cNvPicPr>
             <a:picLocks noChangeAspect="1"/>
           </p:cNvPicPr>
@@ -4455,8 +4525,8 @@
         </p:blipFill>
         <p:spPr>
           <a:xfrm>
-            <a:off x="6756400" y="6210300"/>
-            <a:ext cx="2768600" cy="2768600"/>
+            <a:off x="7172130" y="8096250"/>
+            <a:ext cx="1987938" cy="1238250"/>
           </a:xfrm>
           <a:prstGeom prst="rect">
             <a:avLst/>
@@ -4465,14 +4535,14 @@
       </p:pic>
       <p:sp>
         <p:nvSpPr>
-          <p:cNvPr id="10" name="TextBox 9"/>
+          <p:cNvPr id="12" name="TextBox 11"/>
           <p:cNvSpPr txBox="1"/>
           <p:nvPr/>
         </p:nvSpPr>
         <p:spPr>
           <a:xfrm>
-            <a:off x="6756400" y="9131300"/>
-            <a:ext cx="2768600" cy="342900"/>
+            <a:off x="6654800" y="9963150"/>
+            <a:ext cx="3022600" cy="342900"/>
           </a:xfrm>
           <a:prstGeom prst="rect">
             <a:avLst/>
@@ -4485,7 +4555,7 @@
           </a:bodyPr>
           <a:lstStyle/>
           <a:p>
-            <a:pPr algn="l">
+            <a:pPr algn="ctr">
               <a:lnSpc>
                 <a:spcPct val="120000"/>
               </a:lnSpc>
@@ -4497,53 +4567,14 @@
                 </a:solidFill>
                 <a:latin typeface="Montserrat"/>
               </a:rPr>
-              <a:t>Woody</a:t>
-            </a:r>
-          </a:p>
-        </p:txBody>
-      </p:sp>
-      <p:sp>
-        <p:nvSpPr>
-          <p:cNvPr id="11" name="TextBox 10"/>
-          <p:cNvSpPr txBox="1"/>
-          <p:nvPr/>
-        </p:nvSpPr>
-        <p:spPr>
-          <a:xfrm>
-            <a:off x="762000" y="9550400"/>
-            <a:ext cx="8763000" cy="228600"/>
-          </a:xfrm>
-          <a:prstGeom prst="rect">
-            <a:avLst/>
-          </a:prstGeom>
-          <a:noFill/>
-        </p:spPr>
-        <p:txBody>
-          <a:bodyPr wrap="square" lIns="0" rIns="0" tIns="0" bIns="0" anchor="t">
-            <a:spAutoFit/>
-          </a:bodyPr>
-          <a:lstStyle/>
-          <a:p>
-            <a:pPr algn="l">
-              <a:lnSpc>
-                <a:spcPct val="120000"/>
-              </a:lnSpc>
-            </a:pPr>
-            <a:r>
-              <a:rPr sz="1400" b="0" i="0">
-                <a:solidFill>
-                  <a:srgbClr val="6A665C"/>
-                </a:solidFill>
-                <a:latin typeface="Source Sans 3"/>
-              </a:rPr>
-              <a:t>Photo: Wolfgang Weiser, Roger Starnes Sr, John Kinnander on Unsplash</a:t>
-            </a:r>
-          </a:p>
-        </p:txBody>
-      </p:sp>
-      <p:sp>
-        <p:nvSpPr>
-          <p:cNvPr id="12" name="TextBox 11"/>
+              <a:t>Woody, 60%</a:t>
+            </a:r>
+          </a:p>
+        </p:txBody>
+      </p:sp>
+      <p:sp>
+        <p:nvSpPr>
+          <p:cNvPr id="13" name="TextBox 12"/>
           <p:cNvSpPr txBox="1"/>
           <p:nvPr/>
         </p:nvSpPr>
@@ -4577,14 +4608,14 @@
                 </a:solidFill>
                 <a:latin typeface="Source Sans 3"/>
               </a:rPr>
-              <a:t>Soil Food Web School, Compost Manual</a:t>
+              <a:t>Soil Food Web School, BioComplete Compost, Lecture 4</a:t>
             </a:r>
           </a:p>
         </p:txBody>
       </p:sp>
       <p:pic>
         <p:nvPicPr>
-          <p:cNvPr id="13" name="Picture 12" descr="foundation-logo-color.png"/>
+          <p:cNvPr id="14" name="Picture 13" descr="foundation-logo-color.png"/>
           <p:cNvPicPr>
             <a:picLocks noChangeAspect="1"/>
           </p:cNvPicPr>
@@ -4634,7 +4665,7 @@
       <p:grpSpPr/>
       <p:pic>
         <p:nvPicPr>
-          <p:cNvPr id="2" name="Picture 1" descr="5805007968866421998.jpg"/>
+          <p:cNvPr id="2" name="Picture 1" descr="546581237659234887.jpg"/>
           <p:cNvPicPr>
             <a:picLocks noChangeAspect="1"/>
           </p:cNvPicPr>
@@ -4658,7 +4689,7 @@
       </p:pic>
       <p:pic>
         <p:nvPicPr>
-          <p:cNvPr id="3" name="Picture 2" descr="2985235059126110614.jpg"/>
+          <p:cNvPr id="3" name="Picture 2" descr="4765233650621933955.jpg"/>
           <p:cNvPicPr>
             <a:picLocks noChangeAspect="1"/>
           </p:cNvPicPr>
@@ -4682,7 +4713,7 @@
       </p:pic>
       <p:pic>
         <p:nvPicPr>
-          <p:cNvPr id="4" name="Picture 3" descr="9066830273513557362.jpg"/>
+          <p:cNvPr id="4" name="Picture 3" descr="8140497641940442800.jpg"/>
           <p:cNvPicPr>
             <a:picLocks noChangeAspect="1"/>
           </p:cNvPicPr>
@@ -4706,7 +4737,7 @@
       </p:pic>
       <p:pic>
         <p:nvPicPr>
-          <p:cNvPr id="5" name="Picture 4" descr="5501231099781258804.jpg"/>
+          <p:cNvPr id="5" name="Picture 4" descr="2694705189190117772.jpg"/>
           <p:cNvPicPr>
             <a:picLocks noChangeAspect="1"/>
           </p:cNvPicPr>
@@ -4730,7 +4761,7 @@
       </p:pic>
       <p:pic>
         <p:nvPicPr>
-          <p:cNvPr id="6" name="Picture 5" descr="2566164750923129370.jpg"/>
+          <p:cNvPr id="6" name="Picture 5" descr="7636371598321208956.jpg"/>
           <p:cNvPicPr>
             <a:picLocks noChangeAspect="1"/>
           </p:cNvPicPr>
@@ -4754,7 +4785,7 @@
       </p:pic>
       <p:pic>
         <p:nvPicPr>
-          <p:cNvPr id="7" name="Picture 6" descr="2715986586049347701.jpg"/>
+          <p:cNvPr id="7" name="Picture 6" descr="9172219671786454266.jpg"/>
           <p:cNvPicPr>
             <a:picLocks noChangeAspect="1"/>
           </p:cNvPicPr>
@@ -4778,7 +4809,7 @@
       </p:pic>
       <p:pic>
         <p:nvPicPr>
-          <p:cNvPr id="8" name="Picture 7" descr="1943938979895802509.jpg"/>
+          <p:cNvPr id="8" name="Picture 7" descr="5633042366447472140.jpg"/>
           <p:cNvPicPr>
             <a:picLocks noChangeAspect="1"/>
           </p:cNvPicPr>
@@ -4802,7 +4833,7 @@
       </p:pic>
       <p:pic>
         <p:nvPicPr>
-          <p:cNvPr id="9" name="Picture 8" descr="3038884582975322919.jpg"/>
+          <p:cNvPr id="9" name="Picture 8" descr="5841509971010880559.jpg"/>
           <p:cNvPicPr>
             <a:picLocks noChangeAspect="1"/>
           </p:cNvPicPr>
@@ -4872,7 +4903,7 @@
         <p:spPr>
           <a:xfrm>
             <a:off x="762000" y="5905500"/>
-            <a:ext cx="3556935" cy="381000"/>
+            <a:ext cx="1812768" cy="419100"/>
           </a:xfrm>
           <a:prstGeom prst="rect">
             <a:avLst/>
@@ -4907,16 +4938,40 @@
           </a:p>
         </p:txBody>
       </p:sp>
-      <p:sp>
-        <p:nvSpPr>
-          <p:cNvPr id="12" name="TextBox 11"/>
+      <p:pic>
+        <p:nvPicPr>
+          <p:cNvPr id="12" name="Picture 11" descr="icon-check-mark-cream.png"/>
+          <p:cNvPicPr>
+            <a:picLocks noChangeAspect="1"/>
+          </p:cNvPicPr>
+          <p:nvPr/>
+        </p:nvPicPr>
+        <p:blipFill>
+          <a:blip r:embed="rId11"/>
+          <a:stretch>
+            <a:fillRect/>
+          </a:stretch>
+        </p:blipFill>
+        <p:spPr>
+          <a:xfrm>
+            <a:off x="914400" y="6000750"/>
+            <a:ext cx="282022" cy="228600"/>
+          </a:xfrm>
+          <a:prstGeom prst="rect">
+            <a:avLst/>
+          </a:prstGeom>
+        </p:spPr>
+      </p:pic>
+      <p:sp>
+        <p:nvSpPr>
+          <p:cNvPr id="13" name="TextBox 12"/>
           <p:cNvSpPr txBox="1"/>
           <p:nvPr/>
         </p:nvSpPr>
         <p:spPr>
           <a:xfrm>
-            <a:off x="762000" y="5905500"/>
-            <a:ext cx="3556935" cy="381000"/>
+            <a:off x="1238250" y="5905500"/>
+            <a:ext cx="1336518" cy="419100"/>
           </a:xfrm>
           <a:prstGeom prst="rect">
             <a:avLst/>
@@ -4929,7 +4984,7 @@
           </a:bodyPr>
           <a:lstStyle/>
           <a:p>
-            <a:pPr algn="ctr">
+            <a:pPr algn="l">
               <a:lnSpc>
                 <a:spcPct val="120000"/>
               </a:lnSpc>
@@ -4941,20 +4996,20 @@
                 </a:solidFill>
                 <a:latin typeface="Montserrat"/>
               </a:rPr>
-              <a:t>WELCOME IN THE PILE</a:t>
-            </a:r>
-          </a:p>
-        </p:txBody>
-      </p:sp>
-      <p:sp>
-        <p:nvSpPr>
-          <p:cNvPr id="13" name="TextBox 12"/>
+              <a:t>GOES IN</a:t>
+            </a:r>
+          </a:p>
+        </p:txBody>
+      </p:sp>
+      <p:sp>
+        <p:nvSpPr>
+          <p:cNvPr id="14" name="TextBox 13"/>
           <p:cNvSpPr txBox="1"/>
           <p:nvPr/>
         </p:nvSpPr>
         <p:spPr>
           <a:xfrm>
-            <a:off x="762000" y="6457950"/>
+            <a:off x="762000" y="6496050"/>
             <a:ext cx="8763000" cy="1722078"/>
           </a:xfrm>
           <a:prstGeom prst="rect">
@@ -4987,13 +5042,13 @@
       </p:sp>
       <p:sp>
         <p:nvSpPr>
-          <p:cNvPr id="14" name="TextBox 13"/>
+          <p:cNvPr id="15" name="TextBox 14"/>
           <p:cNvSpPr txBox="1"/>
           <p:nvPr/>
         </p:nvSpPr>
         <p:spPr>
           <a:xfrm>
-            <a:off x="762000" y="8294328"/>
+            <a:off x="762000" y="8332428"/>
             <a:ext cx="8763000" cy="2476500"/>
           </a:xfrm>
           <a:prstGeom prst="rect">
@@ -5026,7 +5081,7 @@
       </p:sp>
       <p:sp>
         <p:nvSpPr>
-          <p:cNvPr id="15" name="TextBox 14"/>
+          <p:cNvPr id="16" name="TextBox 15"/>
           <p:cNvSpPr txBox="1"/>
           <p:nvPr/>
         </p:nvSpPr>
@@ -5067,14 +5122,14 @@
       </p:sp>
       <p:pic>
         <p:nvPicPr>
-          <p:cNvPr id="16" name="Picture 15" descr="foundation-logo-color.png"/>
+          <p:cNvPr id="17" name="Picture 16" descr="foundation-logo-color.png"/>
           <p:cNvPicPr>
             <a:picLocks noChangeAspect="1"/>
           </p:cNvPicPr>
           <p:nvPr/>
         </p:nvPicPr>
         <p:blipFill>
-          <a:blip r:embed="rId11"/>
+          <a:blip r:embed="rId12"/>
           <a:stretch>
             <a:fillRect/>
           </a:stretch>
@@ -5117,7 +5172,7 @@
       <p:grpSpPr/>
       <p:pic>
         <p:nvPicPr>
-          <p:cNvPr id="2" name="Picture 1" descr="7966134234242429384.jpg"/>
+          <p:cNvPr id="2" name="Picture 1" descr="7221287059627112604.jpg"/>
           <p:cNvPicPr>
             <a:picLocks noChangeAspect="1"/>
           </p:cNvPicPr>
@@ -5132,7 +5187,7 @@
         <p:spPr>
           <a:xfrm>
             <a:off x="762000" y="762000"/>
-            <a:ext cx="8763000" cy="6667500"/>
+            <a:ext cx="8763000" cy="5715000"/>
           </a:xfrm>
           <a:prstGeom prst="rect">
             <a:avLst/>
@@ -5147,7 +5202,7 @@
         </p:nvSpPr>
         <p:spPr>
           <a:xfrm>
-            <a:off x="762000" y="7543800"/>
+            <a:off x="762000" y="6591300"/>
             <a:ext cx="8763000" cy="228600"/>
           </a:xfrm>
           <a:prstGeom prst="rect">
@@ -5186,8 +5241,8 @@
         </p:nvSpPr>
         <p:spPr>
           <a:xfrm>
-            <a:off x="762000" y="7962900"/>
-            <a:ext cx="2880296" cy="381000"/>
+            <a:off x="762000" y="7048500"/>
+            <a:ext cx="2827727" cy="419100"/>
           </a:xfrm>
           <a:prstGeom prst="rect">
             <a:avLst/>
@@ -5222,16 +5277,40 @@
           </a:p>
         </p:txBody>
       </p:sp>
-      <p:sp>
-        <p:nvSpPr>
-          <p:cNvPr id="5" name="TextBox 4"/>
+      <p:pic>
+        <p:nvPicPr>
+          <p:cNvPr id="5" name="Picture 4" descr="icon-flame-deep.png"/>
+          <p:cNvPicPr>
+            <a:picLocks noChangeAspect="1"/>
+          </p:cNvPicPr>
+          <p:nvPr/>
+        </p:nvPicPr>
+        <p:blipFill>
+          <a:blip r:embed="rId4"/>
+          <a:stretch>
+            <a:fillRect/>
+          </a:stretch>
+        </p:blipFill>
+        <p:spPr>
+          <a:xfrm>
+            <a:off x="914400" y="7143750"/>
+            <a:ext cx="169528" cy="228600"/>
+          </a:xfrm>
+          <a:prstGeom prst="rect">
+            <a:avLst/>
+          </a:prstGeom>
+        </p:spPr>
+      </p:pic>
+      <p:sp>
+        <p:nvSpPr>
+          <p:cNvPr id="6" name="TextBox 5"/>
           <p:cNvSpPr txBox="1"/>
           <p:nvPr/>
         </p:nvSpPr>
         <p:spPr>
           <a:xfrm>
-            <a:off x="762000" y="7962900"/>
-            <a:ext cx="2880296" cy="381000"/>
+            <a:off x="1238250" y="7048500"/>
+            <a:ext cx="2351477" cy="419100"/>
           </a:xfrm>
           <a:prstGeom prst="rect">
             <a:avLst/>
@@ -5244,7 +5323,7 @@
           </a:bodyPr>
           <a:lstStyle/>
           <a:p>
-            <a:pPr algn="ctr">
+            <a:pPr algn="l">
               <a:lnSpc>
                 <a:spcPct val="120000"/>
               </a:lnSpc>
@@ -5256,20 +5335,20 @@
                 </a:solidFill>
                 <a:latin typeface="Montserrat"/>
               </a:rPr>
-              <a:t>TAKE EXTRA CARE</a:t>
-            </a:r>
-          </a:p>
-        </p:txBody>
-      </p:sp>
-      <p:sp>
-        <p:nvSpPr>
-          <p:cNvPr id="6" name="TextBox 5"/>
+              <a:t>HOT PILE ONLY</a:t>
+            </a:r>
+          </a:p>
+        </p:txBody>
+      </p:sp>
+      <p:sp>
+        <p:nvSpPr>
+          <p:cNvPr id="7" name="TextBox 6"/>
           <p:cNvSpPr txBox="1"/>
           <p:nvPr/>
         </p:nvSpPr>
         <p:spPr>
           <a:xfrm>
-            <a:off x="762000" y="8515350"/>
+            <a:off x="762000" y="7639050"/>
             <a:ext cx="8763000" cy="899139"/>
           </a:xfrm>
           <a:prstGeom prst="rect">
@@ -5302,13 +5381,13 @@
       </p:sp>
       <p:sp>
         <p:nvSpPr>
-          <p:cNvPr id="7" name="TextBox 6"/>
+          <p:cNvPr id="8" name="TextBox 7"/>
           <p:cNvSpPr txBox="1"/>
           <p:nvPr/>
         </p:nvSpPr>
         <p:spPr>
           <a:xfrm>
-            <a:off x="762000" y="9410700"/>
+            <a:off x="762000" y="8633439"/>
             <a:ext cx="8763000" cy="2286000"/>
           </a:xfrm>
           <a:prstGeom prst="rect">
@@ -5341,7 +5420,7 @@
       </p:sp>
       <p:sp>
         <p:nvSpPr>
-          <p:cNvPr id="8" name="TextBox 7"/>
+          <p:cNvPr id="9" name="TextBox 8"/>
           <p:cNvSpPr txBox="1"/>
           <p:nvPr/>
         </p:nvSpPr>
@@ -5382,14 +5461,14 @@
       </p:sp>
       <p:pic>
         <p:nvPicPr>
-          <p:cNvPr id="9" name="Picture 8" descr="foundation-logo-color.png"/>
+          <p:cNvPr id="10" name="Picture 9" descr="foundation-logo-color.png"/>
           <p:cNvPicPr>
             <a:picLocks noChangeAspect="1"/>
           </p:cNvPicPr>
           <p:nvPr/>
         </p:nvPicPr>
         <p:blipFill>
-          <a:blip r:embed="rId4"/>
+          <a:blip r:embed="rId5"/>
           <a:stretch>
             <a:fillRect/>
           </a:stretch>
@@ -5432,7 +5511,7 @@
       <p:grpSpPr/>
       <p:pic>
         <p:nvPicPr>
-          <p:cNvPr id="2" name="Picture 1" descr="2412764120711799061.jpg"/>
+          <p:cNvPr id="2" name="Picture 1" descr="6960754871847846390.jpg"/>
           <p:cNvPicPr>
             <a:picLocks noChangeAspect="1"/>
           </p:cNvPicPr>
@@ -5447,7 +5526,7 @@
         <p:spPr>
           <a:xfrm>
             <a:off x="762000" y="762000"/>
-            <a:ext cx="4305300" cy="6667500"/>
+            <a:ext cx="4305300" cy="4000500"/>
           </a:xfrm>
           <a:prstGeom prst="rect">
             <a:avLst/>
@@ -5456,7 +5535,7 @@
       </p:pic>
       <p:pic>
         <p:nvPicPr>
-          <p:cNvPr id="3" name="Picture 2" descr="7059665383554596994.jpg"/>
+          <p:cNvPr id="3" name="Picture 2" descr="647277320321288501.jpg"/>
           <p:cNvPicPr>
             <a:picLocks noChangeAspect="1"/>
           </p:cNvPicPr>
@@ -5471,7 +5550,7 @@
         <p:spPr>
           <a:xfrm>
             <a:off x="5219700" y="762000"/>
-            <a:ext cx="4305300" cy="6667500"/>
+            <a:ext cx="4305300" cy="4000500"/>
           </a:xfrm>
           <a:prstGeom prst="rect">
             <a:avLst/>
@@ -5486,7 +5565,7 @@
         </p:nvSpPr>
         <p:spPr>
           <a:xfrm>
-            <a:off x="762000" y="7543800"/>
+            <a:off x="762000" y="4876800"/>
             <a:ext cx="8763000" cy="228600"/>
           </a:xfrm>
           <a:prstGeom prst="rect">
@@ -5525,8 +5604,8 @@
         </p:nvSpPr>
         <p:spPr>
           <a:xfrm>
-            <a:off x="762000" y="7962900"/>
-            <a:ext cx="4910213" cy="381000"/>
+            <a:off x="762000" y="5295900"/>
+            <a:ext cx="2151087" cy="419100"/>
           </a:xfrm>
           <a:prstGeom prst="rect">
             <a:avLst/>
@@ -5561,16 +5640,40 @@
           </a:p>
         </p:txBody>
       </p:sp>
-      <p:sp>
-        <p:nvSpPr>
-          <p:cNvPr id="6" name="TextBox 5"/>
+      <p:pic>
+        <p:nvPicPr>
+          <p:cNvPr id="6" name="Picture 5" descr="icon-crossed-circle-cream.png"/>
+          <p:cNvPicPr>
+            <a:picLocks noChangeAspect="1"/>
+          </p:cNvPicPr>
+          <p:nvPr/>
+        </p:nvPicPr>
+        <p:blipFill>
+          <a:blip r:embed="rId5"/>
+          <a:stretch>
+            <a:fillRect/>
+          </a:stretch>
+        </p:blipFill>
+        <p:spPr>
+          <a:xfrm>
+            <a:off x="914400" y="5391150"/>
+            <a:ext cx="229022" cy="228600"/>
+          </a:xfrm>
+          <a:prstGeom prst="rect">
+            <a:avLst/>
+          </a:prstGeom>
+        </p:spPr>
+      </p:pic>
+      <p:sp>
+        <p:nvSpPr>
+          <p:cNvPr id="7" name="TextBox 6"/>
           <p:cNvSpPr txBox="1"/>
           <p:nvPr/>
         </p:nvSpPr>
         <p:spPr>
           <a:xfrm>
-            <a:off x="762000" y="7962900"/>
-            <a:ext cx="4910213" cy="381000"/>
+            <a:off x="1238250" y="5295900"/>
+            <a:ext cx="1674837" cy="419100"/>
           </a:xfrm>
           <a:prstGeom prst="rect">
             <a:avLst/>
@@ -5583,7 +5686,7 @@
           </a:bodyPr>
           <a:lstStyle/>
           <a:p>
-            <a:pPr algn="ctr">
+            <a:pPr algn="l">
               <a:lnSpc>
                 <a:spcPct val="120000"/>
               </a:lnSpc>
@@ -5595,20 +5698,20 @@
                 </a:solidFill>
                 <a:latin typeface="Montserrat"/>
               </a:rPr>
-              <a:t>KEEP OUT OF FOOD PRODUCTION</a:t>
-            </a:r>
-          </a:p>
-        </p:txBody>
-      </p:sp>
-      <p:sp>
-        <p:nvSpPr>
-          <p:cNvPr id="7" name="TextBox 6"/>
+              <a:t>STAYS OUT</a:t>
+            </a:r>
+          </a:p>
+        </p:txBody>
+      </p:sp>
+      <p:sp>
+        <p:nvSpPr>
+          <p:cNvPr id="8" name="TextBox 7"/>
           <p:cNvSpPr txBox="1"/>
           <p:nvPr/>
         </p:nvSpPr>
         <p:spPr>
           <a:xfrm>
-            <a:off x="762000" y="8515350"/>
+            <a:off x="762000" y="5886450"/>
             <a:ext cx="8763000" cy="899139"/>
           </a:xfrm>
           <a:prstGeom prst="rect">
@@ -5641,14 +5744,14 @@
       </p:sp>
       <p:sp>
         <p:nvSpPr>
-          <p:cNvPr id="8" name="TextBox 7"/>
+          <p:cNvPr id="9" name="TextBox 8"/>
           <p:cNvSpPr txBox="1"/>
           <p:nvPr/>
         </p:nvSpPr>
         <p:spPr>
           <a:xfrm>
-            <a:off x="762000" y="9410700"/>
-            <a:ext cx="8763000" cy="2286000"/>
+            <a:off x="762000" y="6880839"/>
+            <a:ext cx="8763000" cy="3619500"/>
           </a:xfrm>
           <a:prstGeom prst="rect">
             <a:avLst/>
@@ -5673,14 +5776,14 @@
                 </a:solidFill>
                 <a:latin typeface="Source Sans 3"/>
               </a:rPr>
-              <a:t>Dog poop can carry roundworm, and cat poop can carry Toxoplasma. Keep both out of compost for food production.</a:t>
-            </a:r>
-          </a:p>
-        </p:txBody>
-      </p:sp>
-      <p:sp>
-        <p:nvSpPr>
-          <p:cNvPr id="9" name="TextBox 8"/>
+              <a:t>Dog feces can carry roundworm (Toxocara) eggs. If swallowed, the larvae can migrate to the liver, lungs and eyes. Cat feces can carry Toxoplasma gondii, which people can also pick up from contaminated soil. USDA advises against using dog waste compost on food crops, even after hot composting, and against composting cat waste or litter at all.</a:t>
+            </a:r>
+          </a:p>
+        </p:txBody>
+      </p:sp>
+      <p:sp>
+        <p:nvSpPr>
+          <p:cNvPr id="10" name="TextBox 9"/>
           <p:cNvSpPr txBox="1"/>
           <p:nvPr/>
         </p:nvSpPr>
@@ -5721,14 +5824,14 @@
       </p:sp>
       <p:pic>
         <p:nvPicPr>
-          <p:cNvPr id="10" name="Picture 9" descr="foundation-logo-color.png"/>
+          <p:cNvPr id="11" name="Picture 10" descr="foundation-logo-color.png"/>
           <p:cNvPicPr>
             <a:picLocks noChangeAspect="1"/>
           </p:cNvPicPr>
           <p:nvPr/>
         </p:nvPicPr>
         <p:blipFill>
-          <a:blip r:embed="rId5"/>
+          <a:blip r:embed="rId6"/>
           <a:stretch>
             <a:fillRect/>
           </a:stretch>
@@ -5778,7 +5881,7 @@
         <p:spPr>
           <a:xfrm>
             <a:off x="762000" y="952500"/>
-            <a:ext cx="8763000" cy="1722078"/>
+            <a:ext cx="7524750" cy="1831804"/>
           </a:xfrm>
           <a:prstGeom prst="rect">
             <a:avLst/>
@@ -5797,7 +5900,7 @@
               </a:lnSpc>
             </a:pPr>
             <a:r>
-              <a:rPr sz="6000" b="1" i="0">
+              <a:rPr sz="6400" b="1" i="0">
                 <a:solidFill>
                   <a:srgbClr val="22371F"/>
                 </a:solidFill>
@@ -5808,15 +5911,39 @@
           </a:p>
         </p:txBody>
       </p:sp>
-      <p:sp>
-        <p:nvSpPr>
-          <p:cNvPr id="3" name="Rectangle 2"/>
+      <p:pic>
+        <p:nvPicPr>
+          <p:cNvPr id="3" name="Picture 2" descr="icon-compost-thermometer-green.png"/>
+          <p:cNvPicPr>
+            <a:picLocks noChangeAspect="1"/>
+          </p:cNvPicPr>
+          <p:nvPr/>
+        </p:nvPicPr>
+        <p:blipFill>
+          <a:blip r:embed="rId3"/>
+          <a:stretch>
+            <a:fillRect/>
+          </a:stretch>
+        </p:blipFill>
+        <p:spPr>
+          <a:xfrm>
+            <a:off x="8572500" y="990600"/>
+            <a:ext cx="1047610" cy="1143000"/>
+          </a:xfrm>
+          <a:prstGeom prst="rect">
+            <a:avLst/>
+          </a:prstGeom>
+        </p:spPr>
+      </p:pic>
+      <p:sp>
+        <p:nvSpPr>
+          <p:cNvPr id="4" name="Rectangle 3"/>
           <p:cNvSpPr/>
           <p:nvPr/>
         </p:nvSpPr>
         <p:spPr>
           <a:xfrm>
-            <a:off x="762000" y="2903178"/>
+            <a:off x="762000" y="3012904"/>
             <a:ext cx="38100" cy="1562062"/>
           </a:xfrm>
           <a:prstGeom prst="rect">
@@ -5854,13 +5981,13 @@
       </p:sp>
       <p:sp>
         <p:nvSpPr>
-          <p:cNvPr id="4" name="TextBox 3"/>
+          <p:cNvPr id="5" name="TextBox 4"/>
           <p:cNvSpPr txBox="1"/>
           <p:nvPr/>
         </p:nvSpPr>
         <p:spPr>
           <a:xfrm>
-            <a:off x="1028700" y="2903178"/>
+            <a:off x="1028700" y="3012904"/>
             <a:ext cx="8496300" cy="1562062"/>
           </a:xfrm>
           <a:prstGeom prst="rect">
@@ -5902,13 +6029,13 @@
       </p:sp>
       <p:sp>
         <p:nvSpPr>
-          <p:cNvPr id="5" name="Rectangle 4"/>
+          <p:cNvPr id="6" name="Rectangle 5"/>
           <p:cNvSpPr/>
           <p:nvPr/>
         </p:nvSpPr>
         <p:spPr>
           <a:xfrm>
-            <a:off x="762000" y="4731941"/>
+            <a:off x="762000" y="4841666"/>
             <a:ext cx="38100" cy="1562062"/>
           </a:xfrm>
           <a:prstGeom prst="rect">
@@ -5946,13 +6073,13 @@
       </p:sp>
       <p:sp>
         <p:nvSpPr>
-          <p:cNvPr id="6" name="TextBox 5"/>
+          <p:cNvPr id="7" name="TextBox 6"/>
           <p:cNvSpPr txBox="1"/>
           <p:nvPr/>
         </p:nvSpPr>
         <p:spPr>
           <a:xfrm>
-            <a:off x="1028700" y="4731941"/>
+            <a:off x="1028700" y="4841666"/>
             <a:ext cx="8496300" cy="1562062"/>
           </a:xfrm>
           <a:prstGeom prst="rect">
@@ -5994,22 +6121,22 @@
       </p:sp>
       <p:pic>
         <p:nvPicPr>
-          <p:cNvPr id="7" name="Picture 6" descr="4472647454875267762.jpg"/>
+          <p:cNvPr id="8" name="Picture 7" descr="7039527272668188277.jpg"/>
           <p:cNvPicPr>
             <a:picLocks noChangeAspect="1"/>
           </p:cNvPicPr>
           <p:nvPr/>
         </p:nvPicPr>
         <p:blipFill>
-          <a:blip r:embed="rId3"/>
+          <a:blip r:embed="rId4"/>
           <a:stretch>
             <a:fillRect/>
           </a:stretch>
         </p:blipFill>
         <p:spPr>
           <a:xfrm>
-            <a:off x="762000" y="6751204"/>
-            <a:ext cx="8763000" cy="4488295"/>
+            <a:off x="762000" y="6860929"/>
+            <a:ext cx="8763000" cy="4378570"/>
           </a:xfrm>
           <a:prstGeom prst="rect">
             <a:avLst/>
@@ -6018,7 +6145,7 @@
       </p:pic>
       <p:sp>
         <p:nvSpPr>
-          <p:cNvPr id="8" name="TextBox 7"/>
+          <p:cNvPr id="9" name="TextBox 8"/>
           <p:cNvSpPr txBox="1"/>
           <p:nvPr/>
         </p:nvSpPr>
@@ -6050,14 +6177,14 @@
                 </a:solidFill>
                 <a:latin typeface="Source Sans 3"/>
               </a:rPr>
-              <a:t>Photo: Roberto Catarinicchia on Unsplash</a:t>
-            </a:r>
-          </a:p>
-        </p:txBody>
-      </p:sp>
-      <p:sp>
-        <p:nvSpPr>
-          <p:cNvPr id="9" name="TextBox 8"/>
+              <a:t>Photo: Frank Thiemonge on Unsplash</a:t>
+            </a:r>
+          </a:p>
+        </p:txBody>
+      </p:sp>
+      <p:sp>
+        <p:nvSpPr>
+          <p:cNvPr id="10" name="TextBox 9"/>
           <p:cNvSpPr txBox="1"/>
           <p:nvPr/>
         </p:nvSpPr>
@@ -6098,14 +6225,14 @@
       </p:sp>
       <p:pic>
         <p:nvPicPr>
-          <p:cNvPr id="10" name="Picture 9" descr="foundation-logo-color.png"/>
+          <p:cNvPr id="11" name="Picture 10" descr="foundation-logo-color.png"/>
           <p:cNvPicPr>
             <a:picLocks noChangeAspect="1"/>
           </p:cNvPicPr>
           <p:nvPr/>
         </p:nvPicPr>
         <p:blipFill>
-          <a:blip r:embed="rId4"/>
+          <a:blip r:embed="rId5"/>
           <a:stretch>
             <a:fillRect/>
           </a:stretch>

</xml_diff>

<commit_message>
World Animal Day v2: 10 slides, bold photo-and-Deep-Green style, copy unchanged and split across slides; trifold comparison sheet removed
Co-Authored-By: Claude Opus 5.5 <noreply@anthropic.com>
Claude-Session: https://claude.ai/code/session_014HGzAbxBh54nuyJHG7tse8
</commit_message>
<xml_diff>
--- a/templates/posts/october/04-10-2026-sun-ig-world-animal-day-v2.pptx
+++ b/templates/posts/october/04-10-2026-sun-ig-world-animal-day-v2.pptx
@@ -12,6 +12,9 @@
     <p:sldId id="260" r:id="rId12"/>
     <p:sldId id="261" r:id="rId13"/>
     <p:sldId id="262" r:id="rId14"/>
+    <p:sldId id="263" r:id="rId15"/>
+    <p:sldId id="264" r:id="rId16"/>
+    <p:sldId id="265" r:id="rId17"/>
   </p:sldIdLst>
   <p:sldSz cx="10287000" cy="12858750" type="screen4x3"/>
   <p:notesSz cx="6858000" cy="9144000"/>
@@ -508,7 +511,77 @@
           <a:lstStyle/>
           <a:p>
             <a:r>
-              <a:t>Cover. Trifold-style v2. Sources: Soil Food Web School, Compost Manual: [LINK FROM CARLA]. Soil Food Web School, BioComplete Compost, Lecture 4: Thermophilic Composting (Part 2): https://pt.soilfoodweb.com/?p=2067. Miller et al. (2015). Ascariasis in humans and pigs on small-scale farms, Maine, USA, 2010 to 2013. Emerging Infectious Diseases, 21(2): https://doi.org/10.3201/eid2102.140048. USDA NRCS and Fairbanks Soil and Water Conservation District (2005). Composting Dog Waste: https://www.epa.gov/system/files/documents/2022-11/Composting-Dog-Waste-Booklet-Alaska.pdf. CDC (2025). About Toxoplasmosis: https://www.cdc.gov/toxoplasmosis/about/index.html. Course: https://school.soilfoodweb.com/bundles/advanced-biocomplete-compost-production Photo cow.jpg: Diana Shchurova on Unsplash, https://unsplash.com/photos/a-brown-and-white-cow-standing-on-top-of-a-grass-covered-field-tDRZNFrz9yA.</a:t>
+              <a:t>Cover. Sources: Soil Food Web School, Compost Manual: [LINK FROM CARLA]. Soil Food Web School, BioComplete Compost, Lecture 4: Thermophilic Composting (Part 2): https://pt.soilfoodweb.com/?p=2067. Miller et al. (2015). Ascariasis in humans and pigs on small-scale farms, Maine, USA, 2010 to 2013. Emerging Infectious Diseases, 21(2): https://doi.org/10.3201/eid2102.140048. USDA NRCS and Fairbanks Soil and Water Conservation District (2005). Composting Dog Waste: https://www.epa.gov/system/files/documents/2022-11/Composting-Dog-Waste-Booklet-Alaska.pdf. CDC (2025). About Toxoplasmosis: https://www.cdc.gov/toxoplasmosis/about/index.html. Course: https://school.soilfoodweb.com/bundles/advanced-biocomplete-compost-production Photo cow.jpg: Diana Shchurova on Unsplash, https://unsplash.com/photos/a-brown-and-white-cow-standing-on-top-of-a-grass-covered-field-tDRZNFrz9yA.</a:t>
+            </a:r>
+          </a:p>
+        </p:txBody>
+      </p:sp>
+      <p:sp>
+        <p:nvSpPr>
+          <p:cNvPr id="4" name="Slide Number Placeholder 3"/>
+          <p:cNvSpPr>
+            <a:spLocks noGrp="1"/>
+          </p:cNvSpPr>
+          <p:nvPr>
+            <p:ph type="sldNum" idx="5" sz="quarter"/>
+          </p:nvPr>
+        </p:nvSpPr>
+        <p:spPr/>
+      </p:sp>
+    </p:spTree>
+  </p:cSld>
+  <p:clrMapOvr>
+    <a:masterClrMapping/>
+  </p:clrMapOvr>
+</p:notes>
+</file>
+
+<file path=ppt/notesSlides/notesSlide10.xml><?xml version="1.0" encoding="utf-8"?>
+<p:notes xmlns:a="http://schemas.openxmlformats.org/drawingml/2006/main" xmlns:p="http://schemas.openxmlformats.org/presentationml/2006/main" xmlns:r="http://schemas.openxmlformats.org/officeDocument/2006/relationships">
+  <p:cSld>
+    <p:spTree>
+      <p:nvGrpSpPr>
+        <p:cNvPr id="1" name=""/>
+        <p:cNvGrpSpPr/>
+        <p:nvPr/>
+      </p:nvGrpSpPr>
+      <p:grpSpPr>
+        <a:xfrm>
+          <a:off x="0" y="0"/>
+          <a:ext cx="0" cy="0"/>
+          <a:chOff x="0" y="0"/>
+          <a:chExt cx="0" cy="0"/>
+        </a:xfrm>
+      </p:grpSpPr>
+      <p:sp>
+        <p:nvSpPr>
+          <p:cNvPr id="2" name="Slide Image Placeholder 1"/>
+          <p:cNvSpPr>
+            <a:spLocks noGrp="1"/>
+          </p:cNvSpPr>
+          <p:nvPr>
+            <p:ph type="sldImg" idx="2"/>
+          </p:nvPr>
+        </p:nvSpPr>
+        <p:spPr/>
+      </p:sp>
+      <p:sp>
+        <p:nvSpPr>
+          <p:cNvPr id="3" name="Notes Placeholder 2"/>
+          <p:cNvSpPr>
+            <a:spLocks noGrp="1"/>
+          </p:cNvSpPr>
+          <p:nvPr>
+            <p:ph type="body" idx="3" sz="quarter"/>
+          </p:nvPr>
+        </p:nvSpPr>
+        <p:spPr/>
+        <p:txBody>
+          <a:bodyPr/>
+          <a:lstStyle/>
+          <a:p>
+            <a:r>
+              <a:t>Closing. Course: https://school.soilfoodweb.com/bundles/advanced-biocomplete-compost-production</a:t>
             </a:r>
           </a:p>
         </p:txBody>
@@ -578,7 +651,7 @@
           <a:lstStyle/>
           <a:p>
             <a:r>
-              <a:t>Three feedstock tiles with line icons from assets/icons/ (generated with flux-2-pro, no photos on this slide).</a:t>
+              <a:t>Feedstocks, text.</a:t>
             </a:r>
           </a:p>
         </p:txBody>
@@ -648,7 +721,7 @@
           <a:lstStyle/>
           <a:p>
             <a:r>
-              <a:t>Plant-eaters and poultry. Photo rabbit.jpg: Adrian Pereira on Unsplash, https://unsplash.com/photos/brown-hare-on-grass-field-cIH81koe-ao. Photo goat.jpg: Maxime Agnelli on Unsplash, https://unsplash.com/photos/selective-focus-photography-of-brown-goat-during-daytime-bhD6TGRjnWc. Photo sheep.jpg: Sam Carter on Unsplash, https://unsplash.com/photos/white-sheep-on-green-grass-during-daytime-GHOiyov2TSQ. Photo alpaca.jpg: Maksim Samuilionak on Unsplash, https://unsplash.com/photos/a-close-up-of-a-fluffy-alpacas-head-DyABRVYb4b8. Photo guinea-pig.jpg: Jack Catalano on Unsplash, https://unsplash.com/photos/brown-and-white-guinea-pig-eating-carrot-q1pw1dOW0_0. Photo horse.jpg: Roger Starnes Sr on Unsplash, https://unsplash.com/photos/a-brown-horse-grazes-peacefully-in-a-sunny-green-field-3w1VfQHm_Lc. Photo cow.jpg: Diana Shchurova on Unsplash, https://unsplash.com/photos/a-brown-and-white-cow-standing-on-top-of-a-grass-covered-field-tDRZNFrz9yA. Photo chicken.jpg: sippakorn yamkasikorn on Unsplash, https://unsplash.com/photos/white-and-brown-chicken-on-green-grass-field-during-daytime-wWIK8hnESnY.</a:t>
+              <a:t>Feedstocks, the recipe as one bar (widths 10, 30, 60 percent). Icons: assets/icons/.</a:t>
             </a:r>
           </a:p>
         </p:txBody>
@@ -718,7 +791,7 @@
           <a:lstStyle/>
           <a:p>
             <a:r>
-              <a:t>Pig. Photo pig.jpg: Pauline Bernfeld on Unsplash, https://unsplash.com/photos/black-pig-in-blue-wooden-cage-S99OqS453go.</a:t>
+              <a:t>Plant-eaters and poultry. Photo rabbit.jpg: Adrian Pereira on Unsplash, https://unsplash.com/photos/brown-hare-on-grass-field-cIH81koe-ao. Photo goat.jpg: Maxime Agnelli on Unsplash, https://unsplash.com/photos/selective-focus-photography-of-brown-goat-during-daytime-bhD6TGRjnWc. Photo sheep.jpg: Sam Carter on Unsplash, https://unsplash.com/photos/white-sheep-on-green-grass-during-daytime-GHOiyov2TSQ. Photo alpaca.jpg: Maksim Samuilionak on Unsplash, https://unsplash.com/photos/a-close-up-of-a-fluffy-alpacas-head-DyABRVYb4b8. Photo guinea-pig.jpg: Jack Catalano on Unsplash, https://unsplash.com/photos/brown-and-white-guinea-pig-eating-carrot-q1pw1dOW0_0. Photo horse.jpg: Roger Starnes Sr on Unsplash, https://unsplash.com/photos/a-brown-horse-grazes-peacefully-in-a-sunny-green-field-3w1VfQHm_Lc. Photo cow.jpg: Diana Shchurova on Unsplash, https://unsplash.com/photos/a-brown-and-white-cow-standing-on-top-of-a-grass-covered-field-tDRZNFrz9yA. Photo chicken.jpg: sippakorn yamkasikorn on Unsplash, https://unsplash.com/photos/white-and-brown-chicken-on-green-grass-field-during-daytime-wWIK8hnESnY.</a:t>
             </a:r>
           </a:p>
         </p:txBody>
@@ -788,7 +861,7 @@
           <a:lstStyle/>
           <a:p>
             <a:r>
-              <a:t>Dog and cat. Photo dog.jpg: iridial on Unsplash, https://unsplash.com/photos/border-collie-lying-in-green-grass-GmgYWfGTWPA. Photo cat.jpg: Sean Foster on Unsplash, https://unsplash.com/photos/an-orange-cat-laying-on-top-of-a-wooden-floor-19eq09rpv-M.</a:t>
+              <a:t>Pig. Photo pig.jpg: Pauline Bernfeld on Unsplash, https://unsplash.com/photos/black-pig-in-blue-wooden-cage-S99OqS453go.</a:t>
             </a:r>
           </a:p>
         </p:txBody>
@@ -858,7 +931,7 @@
           <a:lstStyle/>
           <a:p>
             <a:r>
-              <a:t>Two panels with a Food Web Green rule on the left edge, then the compost bin photo from the first version. Thermometer icon: assets/icons/icon-compost-thermometer-green.png. Photo compost-4.jpg: Frank Thiemonge on Unsplash, https://unsplash.com/photos/a-couple-of-wooden-boxes-filled-with-dirt-GXEPGA3k7N0.</a:t>
+              <a:t>Dog and cat, part 1. Photo dog.jpg: iridial on Unsplash, https://unsplash.com/photos/border-collie-lying-in-green-grass-GmgYWfGTWPA.</a:t>
             </a:r>
           </a:p>
         </p:txBody>
@@ -928,7 +1001,147 @@
           <a:lstStyle/>
           <a:p>
             <a:r>
-              <a:t>Closing. Course: https://school.soilfoodweb.com/bundles/advanced-biocomplete-compost-production</a:t>
+              <a:t>Dog and cat, part 2. Photo cat.jpg: Sean Foster on Unsplash, https://unsplash.com/photos/an-orange-cat-laying-on-top-of-a-wooden-floor-19eq09rpv-M.</a:t>
+            </a:r>
+          </a:p>
+        </p:txBody>
+      </p:sp>
+      <p:sp>
+        <p:nvSpPr>
+          <p:cNvPr id="4" name="Slide Number Placeholder 3"/>
+          <p:cNvSpPr>
+            <a:spLocks noGrp="1"/>
+          </p:cNvSpPr>
+          <p:nvPr>
+            <p:ph type="sldNum" idx="5" sz="quarter"/>
+          </p:nvPr>
+        </p:nvSpPr>
+        <p:spPr/>
+      </p:sp>
+    </p:spTree>
+  </p:cSld>
+  <p:clrMapOvr>
+    <a:masterClrMapping/>
+  </p:clrMapOvr>
+</p:notes>
+</file>
+
+<file path=ppt/notesSlides/notesSlide8.xml><?xml version="1.0" encoding="utf-8"?>
+<p:notes xmlns:a="http://schemas.openxmlformats.org/drawingml/2006/main" xmlns:p="http://schemas.openxmlformats.org/presentationml/2006/main" xmlns:r="http://schemas.openxmlformats.org/officeDocument/2006/relationships">
+  <p:cSld>
+    <p:spTree>
+      <p:nvGrpSpPr>
+        <p:cNvPr id="1" name=""/>
+        <p:cNvGrpSpPr/>
+        <p:nvPr/>
+      </p:nvGrpSpPr>
+      <p:grpSpPr>
+        <a:xfrm>
+          <a:off x="0" y="0"/>
+          <a:ext cx="0" cy="0"/>
+          <a:chOff x="0" y="0"/>
+          <a:chExt cx="0" cy="0"/>
+        </a:xfrm>
+      </p:grpSpPr>
+      <p:sp>
+        <p:nvSpPr>
+          <p:cNvPr id="2" name="Slide Image Placeholder 1"/>
+          <p:cNvSpPr>
+            <a:spLocks noGrp="1"/>
+          </p:cNvSpPr>
+          <p:nvPr>
+            <p:ph type="sldImg" idx="2"/>
+          </p:nvPr>
+        </p:nvSpPr>
+        <p:spPr/>
+      </p:sp>
+      <p:sp>
+        <p:nvSpPr>
+          <p:cNvPr id="3" name="Notes Placeholder 2"/>
+          <p:cNvSpPr>
+            <a:spLocks noGrp="1"/>
+          </p:cNvSpPr>
+          <p:nvPr>
+            <p:ph type="body" idx="3" sz="quarter"/>
+          </p:nvPr>
+        </p:nvSpPr>
+        <p:spPr/>
+        <p:txBody>
+          <a:bodyPr/>
+          <a:lstStyle/>
+          <a:p>
+            <a:r>
+              <a:t>Slow or hot, part 1. Photo compost-2.jpg: Edward Howell on Unsplash, https://unsplash.com/photos/dried-leaves-on-ground-beside-wooden-fence-v7G32kVgM84.</a:t>
+            </a:r>
+          </a:p>
+        </p:txBody>
+      </p:sp>
+      <p:sp>
+        <p:nvSpPr>
+          <p:cNvPr id="4" name="Slide Number Placeholder 3"/>
+          <p:cNvSpPr>
+            <a:spLocks noGrp="1"/>
+          </p:cNvSpPr>
+          <p:nvPr>
+            <p:ph type="sldNum" idx="5" sz="quarter"/>
+          </p:nvPr>
+        </p:nvSpPr>
+        <p:spPr/>
+      </p:sp>
+    </p:spTree>
+  </p:cSld>
+  <p:clrMapOvr>
+    <a:masterClrMapping/>
+  </p:clrMapOvr>
+</p:notes>
+</file>
+
+<file path=ppt/notesSlides/notesSlide9.xml><?xml version="1.0" encoding="utf-8"?>
+<p:notes xmlns:a="http://schemas.openxmlformats.org/drawingml/2006/main" xmlns:p="http://schemas.openxmlformats.org/presentationml/2006/main" xmlns:r="http://schemas.openxmlformats.org/officeDocument/2006/relationships">
+  <p:cSld>
+    <p:spTree>
+      <p:nvGrpSpPr>
+        <p:cNvPr id="1" name=""/>
+        <p:cNvGrpSpPr/>
+        <p:nvPr/>
+      </p:nvGrpSpPr>
+      <p:grpSpPr>
+        <a:xfrm>
+          <a:off x="0" y="0"/>
+          <a:ext cx="0" cy="0"/>
+          <a:chOff x="0" y="0"/>
+          <a:chExt cx="0" cy="0"/>
+        </a:xfrm>
+      </p:grpSpPr>
+      <p:sp>
+        <p:nvSpPr>
+          <p:cNvPr id="2" name="Slide Image Placeholder 1"/>
+          <p:cNvSpPr>
+            <a:spLocks noGrp="1"/>
+          </p:cNvSpPr>
+          <p:nvPr>
+            <p:ph type="sldImg" idx="2"/>
+          </p:nvPr>
+        </p:nvSpPr>
+        <p:spPr/>
+      </p:sp>
+      <p:sp>
+        <p:nvSpPr>
+          <p:cNvPr id="3" name="Notes Placeholder 2"/>
+          <p:cNvSpPr>
+            <a:spLocks noGrp="1"/>
+          </p:cNvSpPr>
+          <p:nvPr>
+            <p:ph type="body" idx="3" sz="quarter"/>
+          </p:nvPr>
+        </p:nvSpPr>
+        <p:spPr/>
+        <p:txBody>
+          <a:bodyPr/>
+          <a:lstStyle/>
+          <a:p>
+            <a:r>
+              <a:t>Slow or hot, part 2. Thermometer icon: assets/icons/. Photo compost-4.jpg: Frank Thiemonge on Unsplash, https://unsplash.com/photos/a-couple-of-wooden-boxes-filled-with-dirt-GXEPGA3k7N0.</a:t>
             </a:r>
           </a:p>
         </p:txBody>
@@ -3936,7 +4149,7 @@
       <p:grpSpPr/>
       <p:pic>
         <p:nvPicPr>
-          <p:cNvPr id="2" name="Picture 1" descr="369434124111978967.jpg"/>
+          <p:cNvPr id="2" name="Picture 1" descr="3188314740401158450.jpg"/>
           <p:cNvPicPr>
             <a:picLocks noChangeAspect="1"/>
           </p:cNvPicPr>
@@ -4012,7 +4225,7 @@
         </p:nvSpPr>
         <p:spPr>
           <a:xfrm>
-            <a:off x="762000" y="7096125"/>
+            <a:off x="762000" y="7000875"/>
             <a:ext cx="8763000" cy="3333750"/>
           </a:xfrm>
           <a:prstGeom prst="rect">
@@ -4051,7 +4264,7 @@
         </p:nvSpPr>
         <p:spPr>
           <a:xfrm>
-            <a:off x="762000" y="10620375"/>
+            <a:off x="762000" y="10858500"/>
             <a:ext cx="8763000" cy="476250"/>
           </a:xfrm>
           <a:prstGeom prst="rect">
@@ -4141,6 +4354,178 @@
           <a:xfrm>
             <a:off x="8667750" y="11326032"/>
             <a:ext cx="857250" cy="770717"/>
+          </a:xfrm>
+          <a:prstGeom prst="rect">
+            <a:avLst/>
+          </a:prstGeom>
+        </p:spPr>
+      </p:pic>
+    </p:spTree>
+  </p:cSld>
+  <p:clrMapOvr>
+    <a:masterClrMapping/>
+  </p:clrMapOvr>
+</p:sld>
+</file>
+
+<file path=ppt/slides/slide10.xml><?xml version="1.0" encoding="utf-8"?>
+<p:sld xmlns:a="http://schemas.openxmlformats.org/drawingml/2006/main" xmlns:p="http://schemas.openxmlformats.org/presentationml/2006/main" xmlns:r="http://schemas.openxmlformats.org/officeDocument/2006/relationships">
+  <p:cSld>
+    <p:bg>
+      <p:bgPr>
+        <a:solidFill>
+          <a:srgbClr val="22371F"/>
+        </a:solidFill>
+        <a:effectLst/>
+      </p:bgPr>
+    </p:bg>
+    <p:spTree>
+      <p:nvGrpSpPr>
+        <p:cNvPr id="1" name=""/>
+        <p:cNvGrpSpPr/>
+        <p:nvPr/>
+      </p:nvGrpSpPr>
+      <p:grpSpPr/>
+      <p:sp>
+        <p:nvSpPr>
+          <p:cNvPr id="2" name="TextBox 1"/>
+          <p:cNvSpPr txBox="1"/>
+          <p:nvPr/>
+        </p:nvSpPr>
+        <p:spPr>
+          <a:xfrm>
+            <a:off x="762000" y="1905000"/>
+            <a:ext cx="8763000" cy="3048000"/>
+          </a:xfrm>
+          <a:prstGeom prst="rect">
+            <a:avLst/>
+          </a:prstGeom>
+          <a:noFill/>
+        </p:spPr>
+        <p:txBody>
+          <a:bodyPr wrap="square" lIns="0" rIns="0" tIns="0" bIns="0" anchor="t">
+            <a:spAutoFit/>
+          </a:bodyPr>
+          <a:lstStyle/>
+          <a:p>
+            <a:pPr algn="l">
+              <a:lnSpc>
+                <a:spcPct val="105000"/>
+              </a:lnSpc>
+            </a:pPr>
+            <a:r>
+              <a:rPr sz="7200" b="1" i="0">
+                <a:solidFill>
+                  <a:srgbClr val="F4F1EA"/>
+                </a:solidFill>
+                <a:latin typeface="Montserrat"/>
+              </a:rPr>
+              <a:t>Learn to build the pile with us.</a:t>
+            </a:r>
+          </a:p>
+        </p:txBody>
+      </p:sp>
+      <p:sp>
+        <p:nvSpPr>
+          <p:cNvPr id="3" name="Rectangle 2"/>
+          <p:cNvSpPr/>
+          <p:nvPr/>
+        </p:nvSpPr>
+        <p:spPr>
+          <a:xfrm>
+            <a:off x="762000" y="5143500"/>
+            <a:ext cx="1143000" cy="38100"/>
+          </a:xfrm>
+          <a:prstGeom prst="rect">
+            <a:avLst/>
+          </a:prstGeom>
+          <a:solidFill>
+            <a:srgbClr val="C9A227"/>
+          </a:solidFill>
+          <a:ln>
+            <a:noFill/>
+          </a:ln>
+          <a:effectLst/>
+        </p:spPr>
+        <p:style>
+          <a:lnRef idx="1">
+            <a:schemeClr val="accent1"/>
+          </a:lnRef>
+          <a:fillRef idx="3">
+            <a:schemeClr val="accent1"/>
+          </a:fillRef>
+          <a:effectRef idx="2">
+            <a:schemeClr val="accent1"/>
+          </a:effectRef>
+          <a:fontRef idx="minor">
+            <a:schemeClr val="lt1"/>
+          </a:fontRef>
+        </p:style>
+        <p:txBody>
+          <a:bodyPr rtlCol="0" anchor="ctr"/>
+          <a:lstStyle/>
+          <a:p>
+            <a:pPr algn="ctr"/>
+          </a:p>
+        </p:txBody>
+      </p:sp>
+      <p:sp>
+        <p:nvSpPr>
+          <p:cNvPr id="4" name="TextBox 3"/>
+          <p:cNvSpPr txBox="1"/>
+          <p:nvPr/>
+        </p:nvSpPr>
+        <p:spPr>
+          <a:xfrm>
+            <a:off x="762000" y="5524500"/>
+            <a:ext cx="8763000" cy="1143000"/>
+          </a:xfrm>
+          <a:prstGeom prst="rect">
+            <a:avLst/>
+          </a:prstGeom>
+          <a:noFill/>
+        </p:spPr>
+        <p:txBody>
+          <a:bodyPr wrap="square" lIns="0" rIns="0" tIns="0" bIns="0" anchor="t">
+            <a:spAutoFit/>
+          </a:bodyPr>
+          <a:lstStyle/>
+          <a:p>
+            <a:pPr algn="l">
+              <a:lnSpc>
+                <a:spcPct val="130000"/>
+              </a:lnSpc>
+            </a:pPr>
+            <a:r>
+              <a:rPr sz="3200" b="0" i="0">
+                <a:solidFill>
+                  <a:srgbClr val="F4F1EA"/>
+                </a:solidFill>
+                <a:latin typeface="Source Sans 3"/>
+              </a:rPr>
+              <a:t>Advanced BioComplete Compost Production, at the Soil Food Web School. Link in bio.</a:t>
+            </a:r>
+          </a:p>
+        </p:txBody>
+      </p:sp>
+      <p:pic>
+        <p:nvPicPr>
+          <p:cNvPr id="5" name="Picture 4" descr="foundation-logo-white.png"/>
+          <p:cNvPicPr>
+            <a:picLocks noChangeAspect="1"/>
+          </p:cNvPicPr>
+          <p:nvPr/>
+        </p:nvPicPr>
+        <p:blipFill>
+          <a:blip r:embed="rId3"/>
+          <a:stretch>
+            <a:fillRect/>
+          </a:stretch>
+        </p:blipFill>
+        <p:spPr>
+          <a:xfrm>
+            <a:off x="4000500" y="9688001"/>
+            <a:ext cx="2286000" cy="2055246"/>
           </a:xfrm>
           <a:prstGeom prst="rect">
             <a:avLst/>
@@ -4161,7 +4546,7 @@
     <p:bg>
       <p:bgPr>
         <a:solidFill>
-          <a:srgbClr val="F4F1EA"/>
+          <a:srgbClr val="22371F"/>
         </a:solidFill>
         <a:effectLst/>
       </p:bgPr>
@@ -4173,131 +4558,9 @@
         <p:nvPr/>
       </p:nvGrpSpPr>
       <p:grpSpPr/>
-      <p:sp>
-        <p:nvSpPr>
-          <p:cNvPr id="2" name="TextBox 1"/>
-          <p:cNvSpPr txBox="1"/>
-          <p:nvPr/>
-        </p:nvSpPr>
-        <p:spPr>
-          <a:xfrm>
-            <a:off x="762000" y="952500"/>
-            <a:ext cx="8763000" cy="2709606"/>
-          </a:xfrm>
-          <a:prstGeom prst="rect">
-            <a:avLst/>
-          </a:prstGeom>
-          <a:noFill/>
-        </p:spPr>
-        <p:txBody>
-          <a:bodyPr wrap="square" lIns="0" rIns="0" tIns="0" bIns="0" anchor="t">
-            <a:spAutoFit/>
-          </a:bodyPr>
-          <a:lstStyle/>
-          <a:p>
-            <a:pPr algn="l">
-              <a:lnSpc>
-                <a:spcPct val="105000"/>
-              </a:lnSpc>
-            </a:pPr>
-            <a:r>
-              <a:rPr sz="6400" b="1" i="0">
-                <a:solidFill>
-                  <a:srgbClr val="22371F"/>
-                </a:solidFill>
-                <a:latin typeface="Montserrat"/>
-              </a:rPr>
-              <a:t>Manure: a high-nitrogen feedstock</a:t>
-            </a:r>
-          </a:p>
-        </p:txBody>
-      </p:sp>
-      <p:sp>
-        <p:nvSpPr>
-          <p:cNvPr id="3" name="TextBox 2"/>
-          <p:cNvSpPr txBox="1"/>
-          <p:nvPr/>
-        </p:nvSpPr>
-        <p:spPr>
-          <a:xfrm>
-            <a:off x="762000" y="3067050"/>
-            <a:ext cx="8763000" cy="3429000"/>
-          </a:xfrm>
-          <a:prstGeom prst="rect">
-            <a:avLst/>
-          </a:prstGeom>
-          <a:noFill/>
-        </p:spPr>
-        <p:txBody>
-          <a:bodyPr wrap="square" lIns="0" rIns="0" tIns="0" bIns="0" anchor="t">
-            <a:spAutoFit/>
-          </a:bodyPr>
-          <a:lstStyle/>
-          <a:p>
-            <a:pPr algn="l">
-              <a:lnSpc>
-                <a:spcPct val="130000"/>
-              </a:lnSpc>
-            </a:pPr>
-            <a:r>
-              <a:rPr sz="3200" b="0" i="0">
-                <a:solidFill>
-                  <a:srgbClr val="333130"/>
-                </a:solidFill>
-                <a:latin typeface="Source Sans 3"/>
-              </a:rPr>
-              <a:t>A Soil Food Web thermophilic compost recipe combines three feedstocks: high-nitrogen material such as manure (about 10% in summer), green plant material (about 30%) and woody material (about 60%). Bedding, such as straw or wood shavings, counts toward the woody share.</a:t>
-            </a:r>
-          </a:p>
-        </p:txBody>
-      </p:sp>
-      <p:sp>
-        <p:nvSpPr>
-          <p:cNvPr id="4" name="Rectangle 3"/>
-          <p:cNvSpPr/>
-          <p:nvPr/>
-        </p:nvSpPr>
-        <p:spPr>
-          <a:xfrm>
-            <a:off x="762000" y="7620000"/>
-            <a:ext cx="2717800" cy="2190750"/>
-          </a:xfrm>
-          <a:prstGeom prst="rect">
-            <a:avLst/>
-          </a:prstGeom>
-          <a:noFill/>
-          <a:ln w="19050">
-            <a:solidFill>
-              <a:srgbClr val="4F3433"/>
-            </a:solidFill>
-          </a:ln>
-          <a:effectLst/>
-        </p:spPr>
-        <p:style>
-          <a:lnRef idx="1">
-            <a:schemeClr val="accent1"/>
-          </a:lnRef>
-          <a:fillRef idx="3">
-            <a:schemeClr val="accent1"/>
-          </a:fillRef>
-          <a:effectRef idx="2">
-            <a:schemeClr val="accent1"/>
-          </a:effectRef>
-          <a:fontRef idx="minor">
-            <a:schemeClr val="lt1"/>
-          </a:fontRef>
-        </p:style>
-        <p:txBody>
-          <a:bodyPr rtlCol="0" anchor="ctr"/>
-          <a:lstStyle/>
-          <a:p>
-            <a:pPr algn="ctr"/>
-          </a:p>
-        </p:txBody>
-      </p:sp>
       <p:pic>
         <p:nvPicPr>
-          <p:cNvPr id="5" name="Picture 4" descr="icon-manure-fork-deep.png"/>
+          <p:cNvPr id="2" name="Picture 1" descr="icon-manure-fork-cream.png"/>
           <p:cNvPicPr>
             <a:picLocks noChangeAspect="1"/>
           </p:cNvPicPr>
@@ -4311,8 +4574,8 @@
         </p:blipFill>
         <p:spPr>
           <a:xfrm>
-            <a:off x="1502898" y="8096250"/>
-            <a:ext cx="1236002" cy="1238250"/>
+            <a:off x="762000" y="1428750"/>
+            <a:ext cx="1426156" cy="1428750"/>
           </a:xfrm>
           <a:prstGeom prst="rect">
             <a:avLst/>
@@ -4321,14 +4584,14 @@
       </p:pic>
       <p:sp>
         <p:nvSpPr>
-          <p:cNvPr id="6" name="TextBox 5"/>
+          <p:cNvPr id="3" name="TextBox 2"/>
           <p:cNvSpPr txBox="1"/>
           <p:nvPr/>
         </p:nvSpPr>
         <p:spPr>
           <a:xfrm>
-            <a:off x="609600" y="9963150"/>
-            <a:ext cx="3022600" cy="342900"/>
+            <a:off x="762000" y="3429000"/>
+            <a:ext cx="8763000" cy="2709606"/>
           </a:xfrm>
           <a:prstGeom prst="rect">
             <a:avLst/>
@@ -4341,70 +4604,106 @@
           </a:bodyPr>
           <a:lstStyle/>
           <a:p>
-            <a:pPr algn="ctr">
+            <a:pPr algn="l">
+              <a:lnSpc>
+                <a:spcPct val="105000"/>
+              </a:lnSpc>
+            </a:pPr>
+            <a:r>
+              <a:rPr sz="6400" b="1" i="0">
+                <a:solidFill>
+                  <a:srgbClr val="F4F1EA"/>
+                </a:solidFill>
+                <a:latin typeface="Montserrat"/>
+              </a:rPr>
+              <a:t>Manure: a high-nitrogen feedstock</a:t>
+            </a:r>
+          </a:p>
+        </p:txBody>
+      </p:sp>
+      <p:sp>
+        <p:nvSpPr>
+          <p:cNvPr id="4" name="TextBox 3"/>
+          <p:cNvSpPr txBox="1"/>
+          <p:nvPr/>
+        </p:nvSpPr>
+        <p:spPr>
+          <a:xfrm>
+            <a:off x="762000" y="6424356"/>
+            <a:ext cx="8763000" cy="4321704"/>
+          </a:xfrm>
+          <a:prstGeom prst="rect">
+            <a:avLst/>
+          </a:prstGeom>
+          <a:noFill/>
+        </p:spPr>
+        <p:txBody>
+          <a:bodyPr wrap="square" lIns="0" rIns="0" tIns="0" bIns="0" anchor="t">
+            <a:spAutoFit/>
+          </a:bodyPr>
+          <a:lstStyle/>
+          <a:p>
+            <a:pPr algn="l">
+              <a:lnSpc>
+                <a:spcPct val="130000"/>
+              </a:lnSpc>
+            </a:pPr>
+            <a:r>
+              <a:rPr sz="3200" b="0" i="0">
+                <a:solidFill>
+                  <a:srgbClr val="F4F1EA"/>
+                </a:solidFill>
+                <a:latin typeface="Source Sans 3"/>
+              </a:rPr>
+              <a:t>A Soil Food Web thermophilic compost recipe combines three feedstocks: high-nitrogen material such as manure (about 10% in summer), green plant material (about 30%) and woody material (about 60%). Bedding, such as straw or wood shavings, counts toward the woody share.</a:t>
+            </a:r>
+          </a:p>
+        </p:txBody>
+      </p:sp>
+      <p:sp>
+        <p:nvSpPr>
+          <p:cNvPr id="5" name="TextBox 4"/>
+          <p:cNvSpPr txBox="1"/>
+          <p:nvPr/>
+        </p:nvSpPr>
+        <p:spPr>
+          <a:xfrm>
+            <a:off x="762000" y="12192000"/>
+            <a:ext cx="7429500" cy="228600"/>
+          </a:xfrm>
+          <a:prstGeom prst="rect">
+            <a:avLst/>
+          </a:prstGeom>
+          <a:noFill/>
+        </p:spPr>
+        <p:txBody>
+          <a:bodyPr wrap="square" lIns="0" rIns="0" tIns="0" bIns="0" anchor="t">
+            <a:spAutoFit/>
+          </a:bodyPr>
+          <a:lstStyle/>
+          <a:p>
+            <a:pPr algn="l">
               <a:lnSpc>
                 <a:spcPct val="120000"/>
               </a:lnSpc>
             </a:pPr>
             <a:r>
-              <a:rPr sz="2200" b="1" i="0">
+              <a:rPr sz="1400" b="0" i="0">
                 <a:solidFill>
-                  <a:srgbClr val="22371F"/>
+                  <a:srgbClr val="F4F1EA">
+                    <a:alpha val="70000"/>
+                  </a:srgbClr>
                 </a:solidFill>
-                <a:latin typeface="Montserrat"/>
+                <a:latin typeface="Source Sans 3"/>
               </a:rPr>
-              <a:t>High nitrogen, 10%</a:t>
-            </a:r>
-          </a:p>
-        </p:txBody>
-      </p:sp>
-      <p:sp>
-        <p:nvSpPr>
-          <p:cNvPr id="7" name="Rectangle 6"/>
-          <p:cNvSpPr/>
-          <p:nvPr/>
-        </p:nvSpPr>
-        <p:spPr>
-          <a:xfrm>
-            <a:off x="3784600" y="7620000"/>
-            <a:ext cx="2717800" cy="2190750"/>
-          </a:xfrm>
-          <a:prstGeom prst="rect">
-            <a:avLst/>
-          </a:prstGeom>
-          <a:noFill/>
-          <a:ln w="19050">
-            <a:solidFill>
-              <a:srgbClr val="4F3433"/>
-            </a:solidFill>
-          </a:ln>
-          <a:effectLst/>
-        </p:spPr>
-        <p:style>
-          <a:lnRef idx="1">
-            <a:schemeClr val="accent1"/>
-          </a:lnRef>
-          <a:fillRef idx="3">
-            <a:schemeClr val="accent1"/>
-          </a:fillRef>
-          <a:effectRef idx="2">
-            <a:schemeClr val="accent1"/>
-          </a:effectRef>
-          <a:fontRef idx="minor">
-            <a:schemeClr val="lt1"/>
-          </a:fontRef>
-        </p:style>
-        <p:txBody>
-          <a:bodyPr rtlCol="0" anchor="ctr"/>
-          <a:lstStyle/>
-          <a:p>
-            <a:pPr algn="ctr"/>
+              <a:t>Soil Food Web School, BioComplete Compost, Lecture 4</a:t>
+            </a:r>
           </a:p>
         </p:txBody>
       </p:sp>
       <p:pic>
         <p:nvPicPr>
-          <p:cNvPr id="8" name="Picture 7" descr="icon-leaf-deep.png"/>
+          <p:cNvPr id="6" name="Picture 5" descr="foundation-logo-white.png"/>
           <p:cNvPicPr>
             <a:picLocks noChangeAspect="1"/>
           </p:cNvPicPr>
@@ -4418,218 +4717,7 @@
         </p:blipFill>
         <p:spPr>
           <a:xfrm>
-            <a:off x="4687755" y="8096250"/>
-            <a:ext cx="911489" cy="1238250"/>
-          </a:xfrm>
-          <a:prstGeom prst="rect">
-            <a:avLst/>
-          </a:prstGeom>
-        </p:spPr>
-      </p:pic>
-      <p:sp>
-        <p:nvSpPr>
-          <p:cNvPr id="9" name="TextBox 8"/>
-          <p:cNvSpPr txBox="1"/>
-          <p:nvPr/>
-        </p:nvSpPr>
-        <p:spPr>
-          <a:xfrm>
-            <a:off x="3632200" y="9963150"/>
-            <a:ext cx="3022600" cy="342900"/>
-          </a:xfrm>
-          <a:prstGeom prst="rect">
-            <a:avLst/>
-          </a:prstGeom>
-          <a:noFill/>
-        </p:spPr>
-        <p:txBody>
-          <a:bodyPr wrap="square" lIns="0" rIns="0" tIns="0" bIns="0" anchor="t">
-            <a:spAutoFit/>
-          </a:bodyPr>
-          <a:lstStyle/>
-          <a:p>
-            <a:pPr algn="ctr">
-              <a:lnSpc>
-                <a:spcPct val="120000"/>
-              </a:lnSpc>
-            </a:pPr>
-            <a:r>
-              <a:rPr sz="2200" b="1" i="0">
-                <a:solidFill>
-                  <a:srgbClr val="22371F"/>
-                </a:solidFill>
-                <a:latin typeface="Montserrat"/>
-              </a:rPr>
-              <a:t>Green, 30%</a:t>
-            </a:r>
-          </a:p>
-        </p:txBody>
-      </p:sp>
-      <p:sp>
-        <p:nvSpPr>
-          <p:cNvPr id="10" name="Rectangle 9"/>
-          <p:cNvSpPr/>
-          <p:nvPr/>
-        </p:nvSpPr>
-        <p:spPr>
-          <a:xfrm>
-            <a:off x="6807200" y="7620000"/>
-            <a:ext cx="2717800" cy="2190750"/>
-          </a:xfrm>
-          <a:prstGeom prst="rect">
-            <a:avLst/>
-          </a:prstGeom>
-          <a:noFill/>
-          <a:ln w="19050">
-            <a:solidFill>
-              <a:srgbClr val="4F3433"/>
-            </a:solidFill>
-          </a:ln>
-          <a:effectLst/>
-        </p:spPr>
-        <p:style>
-          <a:lnRef idx="1">
-            <a:schemeClr val="accent1"/>
-          </a:lnRef>
-          <a:fillRef idx="3">
-            <a:schemeClr val="accent1"/>
-          </a:fillRef>
-          <a:effectRef idx="2">
-            <a:schemeClr val="accent1"/>
-          </a:effectRef>
-          <a:fontRef idx="minor">
-            <a:schemeClr val="lt1"/>
-          </a:fontRef>
-        </p:style>
-        <p:txBody>
-          <a:bodyPr rtlCol="0" anchor="ctr"/>
-          <a:lstStyle/>
-          <a:p>
-            <a:pPr algn="ctr"/>
-          </a:p>
-        </p:txBody>
-      </p:sp>
-      <p:pic>
-        <p:nvPicPr>
-          <p:cNvPr id="11" name="Picture 10" descr="icon-wood-log-deep.png"/>
-          <p:cNvPicPr>
-            <a:picLocks noChangeAspect="1"/>
-          </p:cNvPicPr>
-          <p:nvPr/>
-        </p:nvPicPr>
-        <p:blipFill>
-          <a:blip r:embed="rId5"/>
-          <a:stretch>
-            <a:fillRect/>
-          </a:stretch>
-        </p:blipFill>
-        <p:spPr>
-          <a:xfrm>
-            <a:off x="7172130" y="8096250"/>
-            <a:ext cx="1987938" cy="1238250"/>
-          </a:xfrm>
-          <a:prstGeom prst="rect">
-            <a:avLst/>
-          </a:prstGeom>
-        </p:spPr>
-      </p:pic>
-      <p:sp>
-        <p:nvSpPr>
-          <p:cNvPr id="12" name="TextBox 11"/>
-          <p:cNvSpPr txBox="1"/>
-          <p:nvPr/>
-        </p:nvSpPr>
-        <p:spPr>
-          <a:xfrm>
-            <a:off x="6654800" y="9963150"/>
-            <a:ext cx="3022600" cy="342900"/>
-          </a:xfrm>
-          <a:prstGeom prst="rect">
-            <a:avLst/>
-          </a:prstGeom>
-          <a:noFill/>
-        </p:spPr>
-        <p:txBody>
-          <a:bodyPr wrap="square" lIns="0" rIns="0" tIns="0" bIns="0" anchor="t">
-            <a:spAutoFit/>
-          </a:bodyPr>
-          <a:lstStyle/>
-          <a:p>
-            <a:pPr algn="ctr">
-              <a:lnSpc>
-                <a:spcPct val="120000"/>
-              </a:lnSpc>
-            </a:pPr>
-            <a:r>
-              <a:rPr sz="2200" b="1" i="0">
-                <a:solidFill>
-                  <a:srgbClr val="22371F"/>
-                </a:solidFill>
-                <a:latin typeface="Montserrat"/>
-              </a:rPr>
-              <a:t>Woody, 60%</a:t>
-            </a:r>
-          </a:p>
-        </p:txBody>
-      </p:sp>
-      <p:sp>
-        <p:nvSpPr>
-          <p:cNvPr id="13" name="TextBox 12"/>
-          <p:cNvSpPr txBox="1"/>
-          <p:nvPr/>
-        </p:nvSpPr>
-        <p:spPr>
-          <a:xfrm>
-            <a:off x="762000" y="12001500"/>
-            <a:ext cx="7524750" cy="228600"/>
-          </a:xfrm>
-          <a:prstGeom prst="rect">
-            <a:avLst/>
-          </a:prstGeom>
-          <a:noFill/>
-        </p:spPr>
-        <p:txBody>
-          <a:bodyPr wrap="square" lIns="0" rIns="0" tIns="0" bIns="0" anchor="t">
-            <a:spAutoFit/>
-          </a:bodyPr>
-          <a:lstStyle/>
-          <a:p>
-            <a:pPr algn="l">
-              <a:lnSpc>
-                <a:spcPct val="120000"/>
-              </a:lnSpc>
-            </a:pPr>
-            <a:r>
-              <a:rPr sz="1400" b="0" i="0">
-                <a:solidFill>
-                  <a:srgbClr val="333130">
-                    <a:alpha val="70000"/>
-                  </a:srgbClr>
-                </a:solidFill>
-                <a:latin typeface="Source Sans 3"/>
-              </a:rPr>
-              <a:t>Soil Food Web School, BioComplete Compost, Lecture 4</a:t>
-            </a:r>
-          </a:p>
-        </p:txBody>
-      </p:sp>
-      <p:pic>
-        <p:nvPicPr>
-          <p:cNvPr id="14" name="Picture 13" descr="foundation-logo-color.png"/>
-          <p:cNvPicPr>
-            <a:picLocks noChangeAspect="1"/>
-          </p:cNvPicPr>
-          <p:nvPr/>
-        </p:nvPicPr>
-        <p:blipFill>
-          <a:blip r:embed="rId6"/>
-          <a:stretch>
-            <a:fillRect/>
-          </a:stretch>
-        </p:blipFill>
-        <p:spPr>
-          <a:xfrm>
-            <a:off x="8667750" y="11326032"/>
+            <a:off x="8667750" y="11516532"/>
             <a:ext cx="857250" cy="770717"/>
           </a:xfrm>
           <a:prstGeom prst="rect">
@@ -4651,7 +4739,7 @@
     <p:bg>
       <p:bgPr>
         <a:solidFill>
-          <a:srgbClr val="F4F1EA"/>
+          <a:srgbClr val="22371F"/>
         </a:solidFill>
         <a:effectLst/>
       </p:bgPr>
@@ -4665,7 +4753,7 @@
       <p:grpSpPr/>
       <p:pic>
         <p:nvPicPr>
-          <p:cNvPr id="2" name="Picture 1" descr="546581237659234887.jpg"/>
+          <p:cNvPr id="2" name="Picture 1" descr="icon-manure-fork-cream.png"/>
           <p:cNvPicPr>
             <a:picLocks noChangeAspect="1"/>
           </p:cNvPicPr>
@@ -4679,192 +4767,24 @@
         </p:blipFill>
         <p:spPr>
           <a:xfrm>
-            <a:off x="762000" y="762000"/>
-            <a:ext cx="2133600" cy="2133600"/>
+            <a:off x="762000" y="1619250"/>
+            <a:ext cx="1045848" cy="1047750"/>
           </a:xfrm>
           <a:prstGeom prst="rect">
             <a:avLst/>
           </a:prstGeom>
         </p:spPr>
       </p:pic>
-      <p:pic>
-        <p:nvPicPr>
-          <p:cNvPr id="3" name="Picture 2" descr="4765233650621933955.jpg"/>
-          <p:cNvPicPr>
-            <a:picLocks noChangeAspect="1"/>
-          </p:cNvPicPr>
-          <p:nvPr/>
-        </p:nvPicPr>
-        <p:blipFill>
-          <a:blip r:embed="rId4"/>
-          <a:stretch>
-            <a:fillRect/>
-          </a:stretch>
-        </p:blipFill>
-        <p:spPr>
-          <a:xfrm>
-            <a:off x="2971800" y="762000"/>
-            <a:ext cx="2133600" cy="2133600"/>
-          </a:xfrm>
-          <a:prstGeom prst="rect">
-            <a:avLst/>
-          </a:prstGeom>
-        </p:spPr>
-      </p:pic>
-      <p:pic>
-        <p:nvPicPr>
-          <p:cNvPr id="4" name="Picture 3" descr="8140497641940442800.jpg"/>
-          <p:cNvPicPr>
-            <a:picLocks noChangeAspect="1"/>
-          </p:cNvPicPr>
-          <p:nvPr/>
-        </p:nvPicPr>
-        <p:blipFill>
-          <a:blip r:embed="rId5"/>
-          <a:stretch>
-            <a:fillRect/>
-          </a:stretch>
-        </p:blipFill>
-        <p:spPr>
-          <a:xfrm>
-            <a:off x="5181600" y="762000"/>
-            <a:ext cx="2133600" cy="2133600"/>
-          </a:xfrm>
-          <a:prstGeom prst="rect">
-            <a:avLst/>
-          </a:prstGeom>
-        </p:spPr>
-      </p:pic>
-      <p:pic>
-        <p:nvPicPr>
-          <p:cNvPr id="5" name="Picture 4" descr="2694705189190117772.jpg"/>
-          <p:cNvPicPr>
-            <a:picLocks noChangeAspect="1"/>
-          </p:cNvPicPr>
-          <p:nvPr/>
-        </p:nvPicPr>
-        <p:blipFill>
-          <a:blip r:embed="rId6"/>
-          <a:stretch>
-            <a:fillRect/>
-          </a:stretch>
-        </p:blipFill>
-        <p:spPr>
-          <a:xfrm>
-            <a:off x="7391400" y="762000"/>
-            <a:ext cx="2133600" cy="2133600"/>
-          </a:xfrm>
-          <a:prstGeom prst="rect">
-            <a:avLst/>
-          </a:prstGeom>
-        </p:spPr>
-      </p:pic>
-      <p:pic>
-        <p:nvPicPr>
-          <p:cNvPr id="6" name="Picture 5" descr="7636371598321208956.jpg"/>
-          <p:cNvPicPr>
-            <a:picLocks noChangeAspect="1"/>
-          </p:cNvPicPr>
-          <p:nvPr/>
-        </p:nvPicPr>
-        <p:blipFill>
-          <a:blip r:embed="rId7"/>
-          <a:stretch>
-            <a:fillRect/>
-          </a:stretch>
-        </p:blipFill>
-        <p:spPr>
-          <a:xfrm>
-            <a:off x="762000" y="2971800"/>
-            <a:ext cx="2133600" cy="2133600"/>
-          </a:xfrm>
-          <a:prstGeom prst="rect">
-            <a:avLst/>
-          </a:prstGeom>
-        </p:spPr>
-      </p:pic>
-      <p:pic>
-        <p:nvPicPr>
-          <p:cNvPr id="7" name="Picture 6" descr="9172219671786454266.jpg"/>
-          <p:cNvPicPr>
-            <a:picLocks noChangeAspect="1"/>
-          </p:cNvPicPr>
-          <p:nvPr/>
-        </p:nvPicPr>
-        <p:blipFill>
-          <a:blip r:embed="rId8"/>
-          <a:stretch>
-            <a:fillRect/>
-          </a:stretch>
-        </p:blipFill>
-        <p:spPr>
-          <a:xfrm>
-            <a:off x="2971800" y="2971800"/>
-            <a:ext cx="2133600" cy="2133600"/>
-          </a:xfrm>
-          <a:prstGeom prst="rect">
-            <a:avLst/>
-          </a:prstGeom>
-        </p:spPr>
-      </p:pic>
-      <p:pic>
-        <p:nvPicPr>
-          <p:cNvPr id="8" name="Picture 7" descr="5633042366447472140.jpg"/>
-          <p:cNvPicPr>
-            <a:picLocks noChangeAspect="1"/>
-          </p:cNvPicPr>
-          <p:nvPr/>
-        </p:nvPicPr>
-        <p:blipFill>
-          <a:blip r:embed="rId9"/>
-          <a:stretch>
-            <a:fillRect/>
-          </a:stretch>
-        </p:blipFill>
-        <p:spPr>
-          <a:xfrm>
-            <a:off x="5181600" y="2971800"/>
-            <a:ext cx="2133600" cy="2133600"/>
-          </a:xfrm>
-          <a:prstGeom prst="rect">
-            <a:avLst/>
-          </a:prstGeom>
-        </p:spPr>
-      </p:pic>
-      <p:pic>
-        <p:nvPicPr>
-          <p:cNvPr id="9" name="Picture 8" descr="5841509971010880559.jpg"/>
-          <p:cNvPicPr>
-            <a:picLocks noChangeAspect="1"/>
-          </p:cNvPicPr>
-          <p:nvPr/>
-        </p:nvPicPr>
-        <p:blipFill>
-          <a:blip r:embed="rId10"/>
-          <a:stretch>
-            <a:fillRect/>
-          </a:stretch>
-        </p:blipFill>
-        <p:spPr>
-          <a:xfrm>
-            <a:off x="7391400" y="2971800"/>
-            <a:ext cx="2133600" cy="2133600"/>
-          </a:xfrm>
-          <a:prstGeom prst="rect">
-            <a:avLst/>
-          </a:prstGeom>
-        </p:spPr>
-      </p:pic>
-      <p:sp>
-        <p:nvSpPr>
-          <p:cNvPr id="10" name="TextBox 9"/>
+      <p:sp>
+        <p:nvSpPr>
+          <p:cNvPr id="3" name="TextBox 2"/>
           <p:cNvSpPr txBox="1"/>
           <p:nvPr/>
         </p:nvSpPr>
         <p:spPr>
           <a:xfrm>
-            <a:off x="762000" y="5219700"/>
-            <a:ext cx="8763000" cy="457200"/>
+            <a:off x="2667000" y="1809750"/>
+            <a:ext cx="6858000" cy="666750"/>
           </a:xfrm>
           <a:prstGeom prst="rect">
             <a:avLst/>
@@ -4872,7 +4792,7 @@
           <a:noFill/>
         </p:spPr>
         <p:txBody>
-          <a:bodyPr wrap="square" lIns="0" rIns="0" tIns="0" bIns="0" anchor="t">
+          <a:bodyPr wrap="square" lIns="0" rIns="0" tIns="0" bIns="0" anchor="ctr">
             <a:spAutoFit/>
           </a:bodyPr>
           <a:lstStyle/>
@@ -4883,33 +4803,35 @@
               </a:lnSpc>
             </a:pPr>
             <a:r>
-              <a:rPr sz="1400" b="0" i="0">
+              <a:rPr sz="4000" b="1" i="0">
                 <a:solidFill>
-                  <a:srgbClr val="6A665C"/>
+                  <a:srgbClr val="F4F1EA"/>
                 </a:solidFill>
-                <a:latin typeface="Source Sans 3"/>
+                <a:latin typeface="Montserrat"/>
               </a:rPr>
-              <a:t>Photo: Adrian Pereira, Maxime Agnelli, Sam Carter, Maksim Samuilionak, Jack Catalano, Roger Starnes Sr, Diana Shchurova, sippakorn yamkasikorn on Unsplash</a:t>
-            </a:r>
-          </a:p>
-        </p:txBody>
-      </p:sp>
-      <p:sp>
-        <p:nvSpPr>
-          <p:cNvPr id="11" name="Rectangle 10"/>
+              <a:t>High nitrogen, 10%</a:t>
+            </a:r>
+          </a:p>
+        </p:txBody>
+      </p:sp>
+      <p:sp>
+        <p:nvSpPr>
+          <p:cNvPr id="4" name="Rectangle 3"/>
           <p:cNvSpPr/>
           <p:nvPr/>
         </p:nvSpPr>
         <p:spPr>
           <a:xfrm>
-            <a:off x="762000" y="5905500"/>
-            <a:ext cx="1812768" cy="419100"/>
+            <a:off x="762000" y="3048000"/>
+            <a:ext cx="8763000" cy="323850"/>
           </a:xfrm>
           <a:prstGeom prst="rect">
             <a:avLst/>
           </a:prstGeom>
           <a:solidFill>
-            <a:srgbClr val="156826"/>
+            <a:srgbClr val="F4F1EA">
+              <a:alpha val="15000"/>
+            </a:srgbClr>
           </a:solidFill>
           <a:ln>
             <a:noFill/>
@@ -4938,24 +4860,68 @@
           </a:p>
         </p:txBody>
       </p:sp>
+      <p:sp>
+        <p:nvSpPr>
+          <p:cNvPr id="5" name="Rectangle 4"/>
+          <p:cNvSpPr/>
+          <p:nvPr/>
+        </p:nvSpPr>
+        <p:spPr>
+          <a:xfrm>
+            <a:off x="762000" y="3048000"/>
+            <a:ext cx="876300" cy="323850"/>
+          </a:xfrm>
+          <a:prstGeom prst="rect">
+            <a:avLst/>
+          </a:prstGeom>
+          <a:solidFill>
+            <a:srgbClr val="C9A227"/>
+          </a:solidFill>
+          <a:ln>
+            <a:noFill/>
+          </a:ln>
+          <a:effectLst/>
+        </p:spPr>
+        <p:style>
+          <a:lnRef idx="1">
+            <a:schemeClr val="accent1"/>
+          </a:lnRef>
+          <a:fillRef idx="3">
+            <a:schemeClr val="accent1"/>
+          </a:fillRef>
+          <a:effectRef idx="2">
+            <a:schemeClr val="accent1"/>
+          </a:effectRef>
+          <a:fontRef idx="minor">
+            <a:schemeClr val="lt1"/>
+          </a:fontRef>
+        </p:style>
+        <p:txBody>
+          <a:bodyPr rtlCol="0" anchor="ctr"/>
+          <a:lstStyle/>
+          <a:p>
+            <a:pPr algn="ctr"/>
+          </a:p>
+        </p:txBody>
+      </p:sp>
       <p:pic>
         <p:nvPicPr>
-          <p:cNvPr id="12" name="Picture 11" descr="icon-check-mark-cream.png"/>
+          <p:cNvPr id="6" name="Picture 5" descr="icon-leaf-cream.png"/>
           <p:cNvPicPr>
             <a:picLocks noChangeAspect="1"/>
           </p:cNvPicPr>
           <p:nvPr/>
         </p:nvPicPr>
         <p:blipFill>
-          <a:blip r:embed="rId11"/>
+          <a:blip r:embed="rId4"/>
           <a:stretch>
             <a:fillRect/>
           </a:stretch>
         </p:blipFill>
         <p:spPr>
           <a:xfrm>
-            <a:off x="914400" y="6000750"/>
-            <a:ext cx="282022" cy="228600"/>
+            <a:off x="762000" y="4476750"/>
+            <a:ext cx="771260" cy="1047750"/>
           </a:xfrm>
           <a:prstGeom prst="rect">
             <a:avLst/>
@@ -4964,14 +4930,14 @@
       </p:pic>
       <p:sp>
         <p:nvSpPr>
-          <p:cNvPr id="13" name="TextBox 12"/>
+          <p:cNvPr id="7" name="TextBox 6"/>
           <p:cNvSpPr txBox="1"/>
           <p:nvPr/>
         </p:nvSpPr>
         <p:spPr>
           <a:xfrm>
-            <a:off x="1238250" y="5905500"/>
-            <a:ext cx="1336518" cy="419100"/>
+            <a:off x="2667000" y="4667250"/>
+            <a:ext cx="6858000" cy="666750"/>
           </a:xfrm>
           <a:prstGeom prst="rect">
             <a:avLst/>
@@ -4990,27 +4956,141 @@
               </a:lnSpc>
             </a:pPr>
             <a:r>
-              <a:rPr sz="1800" b="1" i="0" spc="200">
+              <a:rPr sz="4000" b="1" i="0">
                 <a:solidFill>
                   <a:srgbClr val="F4F1EA"/>
                 </a:solidFill>
                 <a:latin typeface="Montserrat"/>
               </a:rPr>
-              <a:t>GOES IN</a:t>
-            </a:r>
-          </a:p>
-        </p:txBody>
-      </p:sp>
-      <p:sp>
-        <p:nvSpPr>
-          <p:cNvPr id="14" name="TextBox 13"/>
+              <a:t>Green, 30%</a:t>
+            </a:r>
+          </a:p>
+        </p:txBody>
+      </p:sp>
+      <p:sp>
+        <p:nvSpPr>
+          <p:cNvPr id="8" name="Rectangle 7"/>
+          <p:cNvSpPr/>
+          <p:nvPr/>
+        </p:nvSpPr>
+        <p:spPr>
+          <a:xfrm>
+            <a:off x="762000" y="5905500"/>
+            <a:ext cx="8763000" cy="323850"/>
+          </a:xfrm>
+          <a:prstGeom prst="rect">
+            <a:avLst/>
+          </a:prstGeom>
+          <a:solidFill>
+            <a:srgbClr val="F4F1EA">
+              <a:alpha val="15000"/>
+            </a:srgbClr>
+          </a:solidFill>
+          <a:ln>
+            <a:noFill/>
+          </a:ln>
+          <a:effectLst/>
+        </p:spPr>
+        <p:style>
+          <a:lnRef idx="1">
+            <a:schemeClr val="accent1"/>
+          </a:lnRef>
+          <a:fillRef idx="3">
+            <a:schemeClr val="accent1"/>
+          </a:fillRef>
+          <a:effectRef idx="2">
+            <a:schemeClr val="accent1"/>
+          </a:effectRef>
+          <a:fontRef idx="minor">
+            <a:schemeClr val="lt1"/>
+          </a:fontRef>
+        </p:style>
+        <p:txBody>
+          <a:bodyPr rtlCol="0" anchor="ctr"/>
+          <a:lstStyle/>
+          <a:p>
+            <a:pPr algn="ctr"/>
+          </a:p>
+        </p:txBody>
+      </p:sp>
+      <p:sp>
+        <p:nvSpPr>
+          <p:cNvPr id="9" name="Rectangle 8"/>
+          <p:cNvSpPr/>
+          <p:nvPr/>
+        </p:nvSpPr>
+        <p:spPr>
+          <a:xfrm>
+            <a:off x="762000" y="5905500"/>
+            <a:ext cx="2628900" cy="323850"/>
+          </a:xfrm>
+          <a:prstGeom prst="rect">
+            <a:avLst/>
+          </a:prstGeom>
+          <a:solidFill>
+            <a:srgbClr val="156826"/>
+          </a:solidFill>
+          <a:ln>
+            <a:noFill/>
+          </a:ln>
+          <a:effectLst/>
+        </p:spPr>
+        <p:style>
+          <a:lnRef idx="1">
+            <a:schemeClr val="accent1"/>
+          </a:lnRef>
+          <a:fillRef idx="3">
+            <a:schemeClr val="accent1"/>
+          </a:fillRef>
+          <a:effectRef idx="2">
+            <a:schemeClr val="accent1"/>
+          </a:effectRef>
+          <a:fontRef idx="minor">
+            <a:schemeClr val="lt1"/>
+          </a:fontRef>
+        </p:style>
+        <p:txBody>
+          <a:bodyPr rtlCol="0" anchor="ctr"/>
+          <a:lstStyle/>
+          <a:p>
+            <a:pPr algn="ctr"/>
+          </a:p>
+        </p:txBody>
+      </p:sp>
+      <p:pic>
+        <p:nvPicPr>
+          <p:cNvPr id="10" name="Picture 9" descr="icon-wood-log-cream.png"/>
+          <p:cNvPicPr>
+            <a:picLocks noChangeAspect="1"/>
+          </p:cNvPicPr>
+          <p:nvPr/>
+        </p:nvPicPr>
+        <p:blipFill>
+          <a:blip r:embed="rId5"/>
+          <a:stretch>
+            <a:fillRect/>
+          </a:stretch>
+        </p:blipFill>
+        <p:spPr>
+          <a:xfrm>
+            <a:off x="762000" y="7334250"/>
+            <a:ext cx="1682102" cy="1047750"/>
+          </a:xfrm>
+          <a:prstGeom prst="rect">
+            <a:avLst/>
+          </a:prstGeom>
+        </p:spPr>
+      </p:pic>
+      <p:sp>
+        <p:nvSpPr>
+          <p:cNvPr id="11" name="TextBox 10"/>
           <p:cNvSpPr txBox="1"/>
           <p:nvPr/>
         </p:nvSpPr>
         <p:spPr>
           <a:xfrm>
-            <a:off x="762000" y="6496050"/>
-            <a:ext cx="8763000" cy="1722078"/>
+            <a:off x="2667000" y="7524750"/>
+            <a:ext cx="6858000" cy="666750"/>
           </a:xfrm>
           <a:prstGeom prst="rect">
             <a:avLst/>
@@ -5018,85 +5098,7 @@
           <a:noFill/>
         </p:spPr>
         <p:txBody>
-          <a:bodyPr wrap="square" lIns="0" rIns="0" tIns="0" bIns="0" anchor="t">
-            <a:spAutoFit/>
-          </a:bodyPr>
-          <a:lstStyle/>
-          <a:p>
-            <a:pPr algn="l">
-              <a:lnSpc>
-                <a:spcPct val="105000"/>
-              </a:lnSpc>
-            </a:pPr>
-            <a:r>
-              <a:rPr sz="6000" b="1" i="0">
-                <a:solidFill>
-                  <a:srgbClr val="22371F"/>
-                </a:solidFill>
-                <a:latin typeface="Montserrat"/>
-              </a:rPr>
-              <a:t>Plant-eaters and poultry</a:t>
-            </a:r>
-          </a:p>
-        </p:txBody>
-      </p:sp>
-      <p:sp>
-        <p:nvSpPr>
-          <p:cNvPr id="15" name="TextBox 14"/>
-          <p:cNvSpPr txBox="1"/>
-          <p:nvPr/>
-        </p:nvSpPr>
-        <p:spPr>
-          <a:xfrm>
-            <a:off x="762000" y="8332428"/>
-            <a:ext cx="8763000" cy="2476500"/>
-          </a:xfrm>
-          <a:prstGeom prst="rect">
-            <a:avLst/>
-          </a:prstGeom>
-          <a:noFill/>
-        </p:spPr>
-        <p:txBody>
-          <a:bodyPr wrap="square" lIns="0" rIns="0" tIns="0" bIns="0" anchor="t">
-            <a:spAutoFit/>
-          </a:bodyPr>
-          <a:lstStyle/>
-          <a:p>
-            <a:pPr algn="l">
-              <a:lnSpc>
-                <a:spcPct val="130000"/>
-              </a:lnSpc>
-            </a:pPr>
-            <a:r>
-              <a:rPr sz="3000" b="0" i="0">
-                <a:solidFill>
-                  <a:srgbClr val="333130"/>
-                </a:solidFill>
-                <a:latin typeface="Source Sans 3"/>
-              </a:rPr>
-              <a:t>Rabbit, goat, sheep, alpaca, guinea pig, horse, cow and chicken. Their manure is a great high-nitrogen ingredient. Use it fresh, or dry it and store it until you build the pile.</a:t>
-            </a:r>
-          </a:p>
-        </p:txBody>
-      </p:sp>
-      <p:sp>
-        <p:nvSpPr>
-          <p:cNvPr id="16" name="TextBox 15"/>
-          <p:cNvSpPr txBox="1"/>
-          <p:nvPr/>
-        </p:nvSpPr>
-        <p:spPr>
-          <a:xfrm>
-            <a:off x="762000" y="12001500"/>
-            <a:ext cx="7524750" cy="228600"/>
-          </a:xfrm>
-          <a:prstGeom prst="rect">
-            <a:avLst/>
-          </a:prstGeom>
-          <a:noFill/>
-        </p:spPr>
-        <p:txBody>
-          <a:bodyPr wrap="square" lIns="0" rIns="0" tIns="0" bIns="0" anchor="t">
+          <a:bodyPr wrap="square" lIns="0" rIns="0" tIns="0" bIns="0" anchor="ctr">
             <a:spAutoFit/>
           </a:bodyPr>
           <a:lstStyle/>
@@ -5107,36 +5109,165 @@
               </a:lnSpc>
             </a:pPr>
             <a:r>
+              <a:rPr sz="4000" b="1" i="0">
+                <a:solidFill>
+                  <a:srgbClr val="F4F1EA"/>
+                </a:solidFill>
+                <a:latin typeface="Montserrat"/>
+              </a:rPr>
+              <a:t>Woody, 60%</a:t>
+            </a:r>
+          </a:p>
+        </p:txBody>
+      </p:sp>
+      <p:sp>
+        <p:nvSpPr>
+          <p:cNvPr id="12" name="Rectangle 11"/>
+          <p:cNvSpPr/>
+          <p:nvPr/>
+        </p:nvSpPr>
+        <p:spPr>
+          <a:xfrm>
+            <a:off x="762000" y="8763000"/>
+            <a:ext cx="8763000" cy="323850"/>
+          </a:xfrm>
+          <a:prstGeom prst="rect">
+            <a:avLst/>
+          </a:prstGeom>
+          <a:solidFill>
+            <a:srgbClr val="F4F1EA">
+              <a:alpha val="15000"/>
+            </a:srgbClr>
+          </a:solidFill>
+          <a:ln>
+            <a:noFill/>
+          </a:ln>
+          <a:effectLst/>
+        </p:spPr>
+        <p:style>
+          <a:lnRef idx="1">
+            <a:schemeClr val="accent1"/>
+          </a:lnRef>
+          <a:fillRef idx="3">
+            <a:schemeClr val="accent1"/>
+          </a:fillRef>
+          <a:effectRef idx="2">
+            <a:schemeClr val="accent1"/>
+          </a:effectRef>
+          <a:fontRef idx="minor">
+            <a:schemeClr val="lt1"/>
+          </a:fontRef>
+        </p:style>
+        <p:txBody>
+          <a:bodyPr rtlCol="0" anchor="ctr"/>
+          <a:lstStyle/>
+          <a:p>
+            <a:pPr algn="ctr"/>
+          </a:p>
+        </p:txBody>
+      </p:sp>
+      <p:sp>
+        <p:nvSpPr>
+          <p:cNvPr id="13" name="Rectangle 12"/>
+          <p:cNvSpPr/>
+          <p:nvPr/>
+        </p:nvSpPr>
+        <p:spPr>
+          <a:xfrm>
+            <a:off x="762000" y="8763000"/>
+            <a:ext cx="5257800" cy="323850"/>
+          </a:xfrm>
+          <a:prstGeom prst="rect">
+            <a:avLst/>
+          </a:prstGeom>
+          <a:solidFill>
+            <a:srgbClr val="F4F1EA"/>
+          </a:solidFill>
+          <a:ln>
+            <a:noFill/>
+          </a:ln>
+          <a:effectLst/>
+        </p:spPr>
+        <p:style>
+          <a:lnRef idx="1">
+            <a:schemeClr val="accent1"/>
+          </a:lnRef>
+          <a:fillRef idx="3">
+            <a:schemeClr val="accent1"/>
+          </a:fillRef>
+          <a:effectRef idx="2">
+            <a:schemeClr val="accent1"/>
+          </a:effectRef>
+          <a:fontRef idx="minor">
+            <a:schemeClr val="lt1"/>
+          </a:fontRef>
+        </p:style>
+        <p:txBody>
+          <a:bodyPr rtlCol="0" anchor="ctr"/>
+          <a:lstStyle/>
+          <a:p>
+            <a:pPr algn="ctr"/>
+          </a:p>
+        </p:txBody>
+      </p:sp>
+      <p:sp>
+        <p:nvSpPr>
+          <p:cNvPr id="14" name="TextBox 13"/>
+          <p:cNvSpPr txBox="1"/>
+          <p:nvPr/>
+        </p:nvSpPr>
+        <p:spPr>
+          <a:xfrm>
+            <a:off x="762000" y="12192000"/>
+            <a:ext cx="7429500" cy="228600"/>
+          </a:xfrm>
+          <a:prstGeom prst="rect">
+            <a:avLst/>
+          </a:prstGeom>
+          <a:noFill/>
+        </p:spPr>
+        <p:txBody>
+          <a:bodyPr wrap="square" lIns="0" rIns="0" tIns="0" bIns="0" anchor="t">
+            <a:spAutoFit/>
+          </a:bodyPr>
+          <a:lstStyle/>
+          <a:p>
+            <a:pPr algn="l">
+              <a:lnSpc>
+                <a:spcPct val="120000"/>
+              </a:lnSpc>
+            </a:pPr>
+            <a:r>
               <a:rPr sz="1400" b="0" i="0">
                 <a:solidFill>
-                  <a:srgbClr val="333130">
+                  <a:srgbClr val="F4F1EA">
                     <a:alpha val="70000"/>
                   </a:srgbClr>
                 </a:solidFill>
                 <a:latin typeface="Source Sans 3"/>
               </a:rPr>
-              <a:t>Soil Food Web School, Compost Manual</a:t>
+              <a:t>Soil Food Web School, BioComplete Compost, Lecture 4</a:t>
             </a:r>
           </a:p>
         </p:txBody>
       </p:sp>
       <p:pic>
         <p:nvPicPr>
-          <p:cNvPr id="17" name="Picture 16" descr="foundation-logo-color.png"/>
+          <p:cNvPr id="15" name="Picture 14" descr="foundation-logo-white.png"/>
           <p:cNvPicPr>
             <a:picLocks noChangeAspect="1"/>
           </p:cNvPicPr>
           <p:nvPr/>
         </p:nvPicPr>
         <p:blipFill>
-          <a:blip r:embed="rId12"/>
+          <a:blip r:embed="rId6"/>
           <a:stretch>
             <a:fillRect/>
           </a:stretch>
         </p:blipFill>
         <p:spPr>
           <a:xfrm>
-            <a:off x="8667750" y="11326032"/>
+            <a:off x="8667750" y="11516532"/>
             <a:ext cx="857250" cy="770717"/>
           </a:xfrm>
           <a:prstGeom prst="rect">
@@ -5158,7 +5289,7 @@
     <p:bg>
       <p:bgPr>
         <a:solidFill>
-          <a:srgbClr val="F4F1EA"/>
+          <a:srgbClr val="22371F"/>
         </a:solidFill>
         <a:effectLst/>
       </p:bgPr>
@@ -5172,7 +5303,7 @@
       <p:grpSpPr/>
       <p:pic>
         <p:nvPicPr>
-          <p:cNvPr id="2" name="Picture 1" descr="7221287059627112604.jpg"/>
+          <p:cNvPr id="2" name="Picture 1" descr="6284106477514029212.jpg"/>
           <p:cNvPicPr>
             <a:picLocks noChangeAspect="1"/>
           </p:cNvPicPr>
@@ -5186,24 +5317,192 @@
         </p:blipFill>
         <p:spPr>
           <a:xfrm>
-            <a:off x="762000" y="762000"/>
-            <a:ext cx="8763000" cy="5715000"/>
+            <a:off x="0" y="0"/>
+            <a:ext cx="2514600" cy="2514600"/>
           </a:xfrm>
           <a:prstGeom prst="rect">
             <a:avLst/>
           </a:prstGeom>
         </p:spPr>
       </p:pic>
-      <p:sp>
-        <p:nvSpPr>
-          <p:cNvPr id="3" name="TextBox 2"/>
+      <p:pic>
+        <p:nvPicPr>
+          <p:cNvPr id="3" name="Picture 2" descr="1144354356172924792.jpg"/>
+          <p:cNvPicPr>
+            <a:picLocks noChangeAspect="1"/>
+          </p:cNvPicPr>
+          <p:nvPr/>
+        </p:nvPicPr>
+        <p:blipFill>
+          <a:blip r:embed="rId4"/>
+          <a:stretch>
+            <a:fillRect/>
+          </a:stretch>
+        </p:blipFill>
+        <p:spPr>
+          <a:xfrm>
+            <a:off x="2590800" y="0"/>
+            <a:ext cx="2514600" cy="2514600"/>
+          </a:xfrm>
+          <a:prstGeom prst="rect">
+            <a:avLst/>
+          </a:prstGeom>
+        </p:spPr>
+      </p:pic>
+      <p:pic>
+        <p:nvPicPr>
+          <p:cNvPr id="4" name="Picture 3" descr="1755564328169200639.jpg"/>
+          <p:cNvPicPr>
+            <a:picLocks noChangeAspect="1"/>
+          </p:cNvPicPr>
+          <p:nvPr/>
+        </p:nvPicPr>
+        <p:blipFill>
+          <a:blip r:embed="rId5"/>
+          <a:stretch>
+            <a:fillRect/>
+          </a:stretch>
+        </p:blipFill>
+        <p:spPr>
+          <a:xfrm>
+            <a:off x="5181600" y="0"/>
+            <a:ext cx="2514600" cy="2514600"/>
+          </a:xfrm>
+          <a:prstGeom prst="rect">
+            <a:avLst/>
+          </a:prstGeom>
+        </p:spPr>
+      </p:pic>
+      <p:pic>
+        <p:nvPicPr>
+          <p:cNvPr id="5" name="Picture 4" descr="8714548284258820098.jpg"/>
+          <p:cNvPicPr>
+            <a:picLocks noChangeAspect="1"/>
+          </p:cNvPicPr>
+          <p:nvPr/>
+        </p:nvPicPr>
+        <p:blipFill>
+          <a:blip r:embed="rId6"/>
+          <a:stretch>
+            <a:fillRect/>
+          </a:stretch>
+        </p:blipFill>
+        <p:spPr>
+          <a:xfrm>
+            <a:off x="7772400" y="0"/>
+            <a:ext cx="2514600" cy="2514600"/>
+          </a:xfrm>
+          <a:prstGeom prst="rect">
+            <a:avLst/>
+          </a:prstGeom>
+        </p:spPr>
+      </p:pic>
+      <p:pic>
+        <p:nvPicPr>
+          <p:cNvPr id="6" name="Picture 5" descr="486322804598397402.jpg"/>
+          <p:cNvPicPr>
+            <a:picLocks noChangeAspect="1"/>
+          </p:cNvPicPr>
+          <p:nvPr/>
+        </p:nvPicPr>
+        <p:blipFill>
+          <a:blip r:embed="rId7"/>
+          <a:stretch>
+            <a:fillRect/>
+          </a:stretch>
+        </p:blipFill>
+        <p:spPr>
+          <a:xfrm>
+            <a:off x="0" y="2590800"/>
+            <a:ext cx="2514600" cy="2514600"/>
+          </a:xfrm>
+          <a:prstGeom prst="rect">
+            <a:avLst/>
+          </a:prstGeom>
+        </p:spPr>
+      </p:pic>
+      <p:pic>
+        <p:nvPicPr>
+          <p:cNvPr id="7" name="Picture 6" descr="705502393350176899.jpg"/>
+          <p:cNvPicPr>
+            <a:picLocks noChangeAspect="1"/>
+          </p:cNvPicPr>
+          <p:nvPr/>
+        </p:nvPicPr>
+        <p:blipFill>
+          <a:blip r:embed="rId8"/>
+          <a:stretch>
+            <a:fillRect/>
+          </a:stretch>
+        </p:blipFill>
+        <p:spPr>
+          <a:xfrm>
+            <a:off x="2590800" y="2590800"/>
+            <a:ext cx="2514600" cy="2514600"/>
+          </a:xfrm>
+          <a:prstGeom prst="rect">
+            <a:avLst/>
+          </a:prstGeom>
+        </p:spPr>
+      </p:pic>
+      <p:pic>
+        <p:nvPicPr>
+          <p:cNvPr id="8" name="Picture 7" descr="4228659823346108929.jpg"/>
+          <p:cNvPicPr>
+            <a:picLocks noChangeAspect="1"/>
+          </p:cNvPicPr>
+          <p:nvPr/>
+        </p:nvPicPr>
+        <p:blipFill>
+          <a:blip r:embed="rId9"/>
+          <a:stretch>
+            <a:fillRect/>
+          </a:stretch>
+        </p:blipFill>
+        <p:spPr>
+          <a:xfrm>
+            <a:off x="5181600" y="2590800"/>
+            <a:ext cx="2514600" cy="2514600"/>
+          </a:xfrm>
+          <a:prstGeom prst="rect">
+            <a:avLst/>
+          </a:prstGeom>
+        </p:spPr>
+      </p:pic>
+      <p:pic>
+        <p:nvPicPr>
+          <p:cNvPr id="9" name="Picture 8" descr="4842180892687044427.jpg"/>
+          <p:cNvPicPr>
+            <a:picLocks noChangeAspect="1"/>
+          </p:cNvPicPr>
+          <p:nvPr/>
+        </p:nvPicPr>
+        <p:blipFill>
+          <a:blip r:embed="rId10"/>
+          <a:stretch>
+            <a:fillRect/>
+          </a:stretch>
+        </p:blipFill>
+        <p:spPr>
+          <a:xfrm>
+            <a:off x="7772400" y="2590800"/>
+            <a:ext cx="2514600" cy="2514600"/>
+          </a:xfrm>
+          <a:prstGeom prst="rect">
+            <a:avLst/>
+          </a:prstGeom>
+        </p:spPr>
+      </p:pic>
+      <p:sp>
+        <p:nvSpPr>
+          <p:cNvPr id="10" name="TextBox 9"/>
           <p:cNvSpPr txBox="1"/>
           <p:nvPr/>
         </p:nvSpPr>
         <p:spPr>
           <a:xfrm>
-            <a:off x="762000" y="6591300"/>
-            <a:ext cx="8763000" cy="228600"/>
+            <a:off x="762000" y="5219700"/>
+            <a:ext cx="8763000" cy="457200"/>
           </a:xfrm>
           <a:prstGeom prst="rect">
             <a:avLst/>
@@ -5224,31 +5523,33 @@
             <a:r>
               <a:rPr sz="1400" b="0" i="0">
                 <a:solidFill>
-                  <a:srgbClr val="6A665C"/>
+                  <a:srgbClr val="F4F1EA">
+                    <a:alpha val="70000"/>
+                  </a:srgbClr>
                 </a:solidFill>
                 <a:latin typeface="Source Sans 3"/>
               </a:rPr>
-              <a:t>Photo: Pauline Bernfeld on Unsplash</a:t>
-            </a:r>
-          </a:p>
-        </p:txBody>
-      </p:sp>
-      <p:sp>
-        <p:nvSpPr>
-          <p:cNvPr id="4" name="Rectangle 3"/>
+              <a:t>Photo: Adrian Pereira, Maxime Agnelli, Sam Carter, Maksim Samuilionak, Jack Catalano, Roger Starnes Sr, Diana Shchurova, sippakorn yamkasikorn on Unsplash</a:t>
+            </a:r>
+          </a:p>
+        </p:txBody>
+      </p:sp>
+      <p:sp>
+        <p:nvSpPr>
+          <p:cNvPr id="11" name="Rectangle 10"/>
           <p:cNvSpPr/>
           <p:nvPr/>
         </p:nvSpPr>
         <p:spPr>
           <a:xfrm>
-            <a:off x="762000" y="7048500"/>
-            <a:ext cx="2827727" cy="419100"/>
+            <a:off x="762000" y="5829300"/>
+            <a:ext cx="1888968" cy="457200"/>
           </a:xfrm>
           <a:prstGeom prst="rect">
             <a:avLst/>
           </a:prstGeom>
           <a:solidFill>
-            <a:srgbClr val="C9A227"/>
+            <a:srgbClr val="156826"/>
           </a:solidFill>
           <a:ln>
             <a:noFill/>
@@ -5279,22 +5580,22 @@
       </p:sp>
       <p:pic>
         <p:nvPicPr>
-          <p:cNvPr id="5" name="Picture 4" descr="icon-flame-deep.png"/>
+          <p:cNvPr id="12" name="Picture 11" descr="icon-check-mark-cream.png"/>
           <p:cNvPicPr>
             <a:picLocks noChangeAspect="1"/>
           </p:cNvPicPr>
           <p:nvPr/>
         </p:nvPicPr>
         <p:blipFill>
-          <a:blip r:embed="rId4"/>
+          <a:blip r:embed="rId11"/>
           <a:stretch>
             <a:fillRect/>
           </a:stretch>
         </p:blipFill>
         <p:spPr>
           <a:xfrm>
-            <a:off x="914400" y="7143750"/>
-            <a:ext cx="169528" cy="228600"/>
+            <a:off x="933450" y="5934075"/>
+            <a:ext cx="305524" cy="247650"/>
           </a:xfrm>
           <a:prstGeom prst="rect">
             <a:avLst/>
@@ -5303,14 +5604,14 @@
       </p:pic>
       <p:sp>
         <p:nvSpPr>
-          <p:cNvPr id="6" name="TextBox 5"/>
+          <p:cNvPr id="13" name="TextBox 12"/>
           <p:cNvSpPr txBox="1"/>
           <p:nvPr/>
         </p:nvSpPr>
         <p:spPr>
           <a:xfrm>
-            <a:off x="1238250" y="7048500"/>
-            <a:ext cx="2351477" cy="419100"/>
+            <a:off x="1295400" y="5829300"/>
+            <a:ext cx="1355568" cy="457200"/>
           </a:xfrm>
           <a:prstGeom prst="rect">
             <a:avLst/>
@@ -5331,25 +5632,25 @@
             <a:r>
               <a:rPr sz="1800" b="1" i="0" spc="200">
                 <a:solidFill>
-                  <a:srgbClr val="22371F"/>
+                  <a:srgbClr val="F4F1EA"/>
                 </a:solidFill>
                 <a:latin typeface="Montserrat"/>
               </a:rPr>
-              <a:t>HOT PILE ONLY</a:t>
-            </a:r>
-          </a:p>
-        </p:txBody>
-      </p:sp>
-      <p:sp>
-        <p:nvSpPr>
-          <p:cNvPr id="7" name="TextBox 6"/>
+              <a:t>GOES IN</a:t>
+            </a:r>
+          </a:p>
+        </p:txBody>
+      </p:sp>
+      <p:sp>
+        <p:nvSpPr>
+          <p:cNvPr id="14" name="TextBox 13"/>
           <p:cNvSpPr txBox="1"/>
           <p:nvPr/>
         </p:nvSpPr>
         <p:spPr>
           <a:xfrm>
-            <a:off x="762000" y="7639050"/>
-            <a:ext cx="8763000" cy="899139"/>
+            <a:off x="762000" y="6457950"/>
+            <a:ext cx="8763000" cy="1722078"/>
           </a:xfrm>
           <a:prstGeom prst="rect">
             <a:avLst/>
@@ -5370,25 +5671,25 @@
             <a:r>
               <a:rPr sz="6000" b="1" i="0">
                 <a:solidFill>
-                  <a:srgbClr val="22371F"/>
+                  <a:srgbClr val="F4F1EA"/>
                 </a:solidFill>
                 <a:latin typeface="Montserrat"/>
               </a:rPr>
-              <a:t>Pig</a:t>
-            </a:r>
-          </a:p>
-        </p:txBody>
-      </p:sp>
-      <p:sp>
-        <p:nvSpPr>
-          <p:cNvPr id="8" name="TextBox 7"/>
+              <a:t>Plant-eaters and poultry</a:t>
+            </a:r>
+          </a:p>
+        </p:txBody>
+      </p:sp>
+      <p:sp>
+        <p:nvSpPr>
+          <p:cNvPr id="15" name="TextBox 14"/>
           <p:cNvSpPr txBox="1"/>
           <p:nvPr/>
         </p:nvSpPr>
         <p:spPr>
           <a:xfrm>
-            <a:off x="762000" y="8633439"/>
-            <a:ext cx="8763000" cy="2286000"/>
+            <a:off x="762000" y="8256228"/>
+            <a:ext cx="8763000" cy="2571688"/>
           </a:xfrm>
           <a:prstGeom prst="rect">
             <a:avLst/>
@@ -5409,25 +5710,25 @@
             <a:r>
               <a:rPr sz="3000" b="0" i="0">
                 <a:solidFill>
-                  <a:srgbClr val="333130"/>
+                  <a:srgbClr val="F4F1EA"/>
                 </a:solidFill>
                 <a:latin typeface="Source Sans 3"/>
               </a:rPr>
-              <a:t>Pig roundworm can infect people. Pig manure goes into a pile that completes the thermophilic requirements, and raw pig manure stays away from produce.</a:t>
-            </a:r>
-          </a:p>
-        </p:txBody>
-      </p:sp>
-      <p:sp>
-        <p:nvSpPr>
-          <p:cNvPr id="9" name="TextBox 8"/>
+              <a:t>Rabbit, goat, sheep, alpaca, guinea pig, horse, cow and chicken. Their manure is a great high-nitrogen ingredient. Use it fresh, or dry it and store it until you build the pile.</a:t>
+            </a:r>
+          </a:p>
+        </p:txBody>
+      </p:sp>
+      <p:sp>
+        <p:nvSpPr>
+          <p:cNvPr id="16" name="TextBox 15"/>
           <p:cNvSpPr txBox="1"/>
           <p:nvPr/>
         </p:nvSpPr>
         <p:spPr>
           <a:xfrm>
-            <a:off x="762000" y="12001500"/>
-            <a:ext cx="7524750" cy="228600"/>
+            <a:off x="762000" y="12192000"/>
+            <a:ext cx="7429500" cy="228600"/>
           </a:xfrm>
           <a:prstGeom prst="rect">
             <a:avLst/>
@@ -5448,34 +5749,34 @@
             <a:r>
               <a:rPr sz="1400" b="0" i="0">
                 <a:solidFill>
-                  <a:srgbClr val="333130">
+                  <a:srgbClr val="F4F1EA">
                     <a:alpha val="70000"/>
                   </a:srgbClr>
                 </a:solidFill>
                 <a:latin typeface="Source Sans 3"/>
               </a:rPr>
-              <a:t>Miller et al. 2015, Emerging Infectious Diseases</a:t>
+              <a:t>Soil Food Web School, Compost Manual</a:t>
             </a:r>
           </a:p>
         </p:txBody>
       </p:sp>
       <p:pic>
         <p:nvPicPr>
-          <p:cNvPr id="10" name="Picture 9" descr="foundation-logo-color.png"/>
+          <p:cNvPr id="17" name="Picture 16" descr="foundation-logo-white.png"/>
           <p:cNvPicPr>
             <a:picLocks noChangeAspect="1"/>
           </p:cNvPicPr>
           <p:nvPr/>
         </p:nvPicPr>
         <p:blipFill>
-          <a:blip r:embed="rId5"/>
+          <a:blip r:embed="rId12"/>
           <a:stretch>
             <a:fillRect/>
           </a:stretch>
         </p:blipFill>
         <p:spPr>
           <a:xfrm>
-            <a:off x="8667750" y="11326032"/>
+            <a:off x="8667750" y="11516532"/>
             <a:ext cx="857250" cy="770717"/>
           </a:xfrm>
           <a:prstGeom prst="rect">
@@ -5497,7 +5798,7 @@
     <p:bg>
       <p:bgPr>
         <a:solidFill>
-          <a:srgbClr val="F4F1EA"/>
+          <a:srgbClr val="22371F"/>
         </a:solidFill>
         <a:effectLst/>
       </p:bgPr>
@@ -5511,7 +5812,7 @@
       <p:grpSpPr/>
       <p:pic>
         <p:nvPicPr>
-          <p:cNvPr id="2" name="Picture 1" descr="6960754871847846390.jpg"/>
+          <p:cNvPr id="2" name="Picture 1" descr="4102147720830019452.jpg"/>
           <p:cNvPicPr>
             <a:picLocks noChangeAspect="1"/>
           </p:cNvPicPr>
@@ -5525,47 +5826,23 @@
         </p:blipFill>
         <p:spPr>
           <a:xfrm>
-            <a:off x="762000" y="762000"/>
-            <a:ext cx="4305300" cy="4000500"/>
+            <a:off x="0" y="0"/>
+            <a:ext cx="10287000" cy="6667500"/>
           </a:xfrm>
           <a:prstGeom prst="rect">
             <a:avLst/>
           </a:prstGeom>
         </p:spPr>
       </p:pic>
-      <p:pic>
-        <p:nvPicPr>
-          <p:cNvPr id="3" name="Picture 2" descr="647277320321288501.jpg"/>
-          <p:cNvPicPr>
-            <a:picLocks noChangeAspect="1"/>
-          </p:cNvPicPr>
-          <p:nvPr/>
-        </p:nvPicPr>
-        <p:blipFill>
-          <a:blip r:embed="rId4"/>
-          <a:stretch>
-            <a:fillRect/>
-          </a:stretch>
-        </p:blipFill>
-        <p:spPr>
-          <a:xfrm>
-            <a:off x="5219700" y="762000"/>
-            <a:ext cx="4305300" cy="4000500"/>
-          </a:xfrm>
-          <a:prstGeom prst="rect">
-            <a:avLst/>
-          </a:prstGeom>
-        </p:spPr>
-      </p:pic>
-      <p:sp>
-        <p:nvSpPr>
-          <p:cNvPr id="4" name="TextBox 3"/>
+      <p:sp>
+        <p:nvSpPr>
+          <p:cNvPr id="3" name="TextBox 2"/>
           <p:cNvSpPr txBox="1"/>
           <p:nvPr/>
         </p:nvSpPr>
         <p:spPr>
           <a:xfrm>
-            <a:off x="762000" y="4876800"/>
+            <a:off x="762000" y="6781800"/>
             <a:ext cx="8763000" cy="228600"/>
           </a:xfrm>
           <a:prstGeom prst="rect">
@@ -5579,7 +5856,7 @@
           </a:bodyPr>
           <a:lstStyle/>
           <a:p>
-            <a:pPr algn="l">
+            <a:pPr algn="r">
               <a:lnSpc>
                 <a:spcPct val="120000"/>
               </a:lnSpc>
@@ -5587,31 +5864,33 @@
             <a:r>
               <a:rPr sz="1400" b="0" i="0">
                 <a:solidFill>
-                  <a:srgbClr val="6A665C"/>
+                  <a:srgbClr val="F4F1EA">
+                    <a:alpha val="70000"/>
+                  </a:srgbClr>
                 </a:solidFill>
                 <a:latin typeface="Source Sans 3"/>
               </a:rPr>
-              <a:t>Photo: iridial, Sean Foster on Unsplash</a:t>
-            </a:r>
-          </a:p>
-        </p:txBody>
-      </p:sp>
-      <p:sp>
-        <p:nvSpPr>
-          <p:cNvPr id="5" name="Rectangle 4"/>
+              <a:t>Photo: Pauline Bernfeld on Unsplash</a:t>
+            </a:r>
+          </a:p>
+        </p:txBody>
+      </p:sp>
+      <p:sp>
+        <p:nvSpPr>
+          <p:cNvPr id="4" name="Rectangle 3"/>
           <p:cNvSpPr/>
           <p:nvPr/>
         </p:nvSpPr>
         <p:spPr>
           <a:xfrm>
-            <a:off x="762000" y="5295900"/>
-            <a:ext cx="2151087" cy="419100"/>
+            <a:off x="762000" y="7239000"/>
+            <a:ext cx="2903927" cy="457200"/>
           </a:xfrm>
           <a:prstGeom prst="rect">
             <a:avLst/>
           </a:prstGeom>
           <a:solidFill>
-            <a:srgbClr val="B23A2E"/>
+            <a:srgbClr val="C9A227"/>
           </a:solidFill>
           <a:ln>
             <a:noFill/>
@@ -5642,7 +5921,189 @@
       </p:sp>
       <p:pic>
         <p:nvPicPr>
-          <p:cNvPr id="6" name="Picture 5" descr="icon-crossed-circle-cream.png"/>
+          <p:cNvPr id="5" name="Picture 4" descr="icon-flame-deep.png"/>
+          <p:cNvPicPr>
+            <a:picLocks noChangeAspect="1"/>
+          </p:cNvPicPr>
+          <p:nvPr/>
+        </p:nvPicPr>
+        <p:blipFill>
+          <a:blip r:embed="rId4"/>
+          <a:stretch>
+            <a:fillRect/>
+          </a:stretch>
+        </p:blipFill>
+        <p:spPr>
+          <a:xfrm>
+            <a:off x="933450" y="7343775"/>
+            <a:ext cx="183655" cy="247650"/>
+          </a:xfrm>
+          <a:prstGeom prst="rect">
+            <a:avLst/>
+          </a:prstGeom>
+        </p:spPr>
+      </p:pic>
+      <p:sp>
+        <p:nvSpPr>
+          <p:cNvPr id="6" name="TextBox 5"/>
+          <p:cNvSpPr txBox="1"/>
+          <p:nvPr/>
+        </p:nvSpPr>
+        <p:spPr>
+          <a:xfrm>
+            <a:off x="1295400" y="7239000"/>
+            <a:ext cx="2370527" cy="457200"/>
+          </a:xfrm>
+          <a:prstGeom prst="rect">
+            <a:avLst/>
+          </a:prstGeom>
+          <a:noFill/>
+        </p:spPr>
+        <p:txBody>
+          <a:bodyPr wrap="square" lIns="0" rIns="0" tIns="0" bIns="0" anchor="ctr">
+            <a:spAutoFit/>
+          </a:bodyPr>
+          <a:lstStyle/>
+          <a:p>
+            <a:pPr algn="l">
+              <a:lnSpc>
+                <a:spcPct val="120000"/>
+              </a:lnSpc>
+            </a:pPr>
+            <a:r>
+              <a:rPr sz="1800" b="1" i="0" spc="200">
+                <a:solidFill>
+                  <a:srgbClr val="22371F"/>
+                </a:solidFill>
+                <a:latin typeface="Montserrat"/>
+              </a:rPr>
+              <a:t>HOT PILE ONLY</a:t>
+            </a:r>
+          </a:p>
+        </p:txBody>
+      </p:sp>
+      <p:sp>
+        <p:nvSpPr>
+          <p:cNvPr id="7" name="TextBox 6"/>
+          <p:cNvSpPr txBox="1"/>
+          <p:nvPr/>
+        </p:nvSpPr>
+        <p:spPr>
+          <a:xfrm>
+            <a:off x="762000" y="7867650"/>
+            <a:ext cx="8763000" cy="899139"/>
+          </a:xfrm>
+          <a:prstGeom prst="rect">
+            <a:avLst/>
+          </a:prstGeom>
+          <a:noFill/>
+        </p:spPr>
+        <p:txBody>
+          <a:bodyPr wrap="square" lIns="0" rIns="0" tIns="0" bIns="0" anchor="t">
+            <a:spAutoFit/>
+          </a:bodyPr>
+          <a:lstStyle/>
+          <a:p>
+            <a:pPr algn="l">
+              <a:lnSpc>
+                <a:spcPct val="105000"/>
+              </a:lnSpc>
+            </a:pPr>
+            <a:r>
+              <a:rPr sz="6000" b="1" i="0">
+                <a:solidFill>
+                  <a:srgbClr val="F4F1EA"/>
+                </a:solidFill>
+                <a:latin typeface="Montserrat"/>
+              </a:rPr>
+              <a:t>Pig</a:t>
+            </a:r>
+          </a:p>
+        </p:txBody>
+      </p:sp>
+      <p:sp>
+        <p:nvSpPr>
+          <p:cNvPr id="8" name="TextBox 7"/>
+          <p:cNvSpPr txBox="1"/>
+          <p:nvPr/>
+        </p:nvSpPr>
+        <p:spPr>
+          <a:xfrm>
+            <a:off x="762000" y="8842989"/>
+            <a:ext cx="8763000" cy="2076400"/>
+          </a:xfrm>
+          <a:prstGeom prst="rect">
+            <a:avLst/>
+          </a:prstGeom>
+          <a:noFill/>
+        </p:spPr>
+        <p:txBody>
+          <a:bodyPr wrap="square" lIns="0" rIns="0" tIns="0" bIns="0" anchor="t">
+            <a:spAutoFit/>
+          </a:bodyPr>
+          <a:lstStyle/>
+          <a:p>
+            <a:pPr algn="l">
+              <a:lnSpc>
+                <a:spcPct val="130000"/>
+              </a:lnSpc>
+            </a:pPr>
+            <a:r>
+              <a:rPr sz="3000" b="0" i="0">
+                <a:solidFill>
+                  <a:srgbClr val="F4F1EA"/>
+                </a:solidFill>
+                <a:latin typeface="Source Sans 3"/>
+              </a:rPr>
+              <a:t>Pig roundworm can infect people. Pig manure goes into a pile that completes the thermophilic requirements, and raw pig manure stays away from produce.</a:t>
+            </a:r>
+          </a:p>
+        </p:txBody>
+      </p:sp>
+      <p:sp>
+        <p:nvSpPr>
+          <p:cNvPr id="9" name="TextBox 8"/>
+          <p:cNvSpPr txBox="1"/>
+          <p:nvPr/>
+        </p:nvSpPr>
+        <p:spPr>
+          <a:xfrm>
+            <a:off x="762000" y="12192000"/>
+            <a:ext cx="7429500" cy="228600"/>
+          </a:xfrm>
+          <a:prstGeom prst="rect">
+            <a:avLst/>
+          </a:prstGeom>
+          <a:noFill/>
+        </p:spPr>
+        <p:txBody>
+          <a:bodyPr wrap="square" lIns="0" rIns="0" tIns="0" bIns="0" anchor="t">
+            <a:spAutoFit/>
+          </a:bodyPr>
+          <a:lstStyle/>
+          <a:p>
+            <a:pPr algn="l">
+              <a:lnSpc>
+                <a:spcPct val="120000"/>
+              </a:lnSpc>
+            </a:pPr>
+            <a:r>
+              <a:rPr sz="1400" b="0" i="0">
+                <a:solidFill>
+                  <a:srgbClr val="F4F1EA">
+                    <a:alpha val="70000"/>
+                  </a:srgbClr>
+                </a:solidFill>
+                <a:latin typeface="Source Sans 3"/>
+              </a:rPr>
+              <a:t>Miller et al. 2015, Emerging Infectious Diseases</a:t>
+            </a:r>
+          </a:p>
+        </p:txBody>
+      </p:sp>
+      <p:pic>
+        <p:nvPicPr>
+          <p:cNvPr id="10" name="Picture 9" descr="foundation-logo-white.png"/>
           <p:cNvPicPr>
             <a:picLocks noChangeAspect="1"/>
           </p:cNvPicPr>
@@ -5656,189 +6117,7 @@
         </p:blipFill>
         <p:spPr>
           <a:xfrm>
-            <a:off x="914400" y="5391150"/>
-            <a:ext cx="229022" cy="228600"/>
-          </a:xfrm>
-          <a:prstGeom prst="rect">
-            <a:avLst/>
-          </a:prstGeom>
-        </p:spPr>
-      </p:pic>
-      <p:sp>
-        <p:nvSpPr>
-          <p:cNvPr id="7" name="TextBox 6"/>
-          <p:cNvSpPr txBox="1"/>
-          <p:nvPr/>
-        </p:nvSpPr>
-        <p:spPr>
-          <a:xfrm>
-            <a:off x="1238250" y="5295900"/>
-            <a:ext cx="1674837" cy="419100"/>
-          </a:xfrm>
-          <a:prstGeom prst="rect">
-            <a:avLst/>
-          </a:prstGeom>
-          <a:noFill/>
-        </p:spPr>
-        <p:txBody>
-          <a:bodyPr wrap="square" lIns="0" rIns="0" tIns="0" bIns="0" anchor="ctr">
-            <a:spAutoFit/>
-          </a:bodyPr>
-          <a:lstStyle/>
-          <a:p>
-            <a:pPr algn="l">
-              <a:lnSpc>
-                <a:spcPct val="120000"/>
-              </a:lnSpc>
-            </a:pPr>
-            <a:r>
-              <a:rPr sz="1800" b="1" i="0" spc="200">
-                <a:solidFill>
-                  <a:srgbClr val="F4F1EA"/>
-                </a:solidFill>
-                <a:latin typeface="Montserrat"/>
-              </a:rPr>
-              <a:t>STAYS OUT</a:t>
-            </a:r>
-          </a:p>
-        </p:txBody>
-      </p:sp>
-      <p:sp>
-        <p:nvSpPr>
-          <p:cNvPr id="8" name="TextBox 7"/>
-          <p:cNvSpPr txBox="1"/>
-          <p:nvPr/>
-        </p:nvSpPr>
-        <p:spPr>
-          <a:xfrm>
-            <a:off x="762000" y="5886450"/>
-            <a:ext cx="8763000" cy="899139"/>
-          </a:xfrm>
-          <a:prstGeom prst="rect">
-            <a:avLst/>
-          </a:prstGeom>
-          <a:noFill/>
-        </p:spPr>
-        <p:txBody>
-          <a:bodyPr wrap="square" lIns="0" rIns="0" tIns="0" bIns="0" anchor="t">
-            <a:spAutoFit/>
-          </a:bodyPr>
-          <a:lstStyle/>
-          <a:p>
-            <a:pPr algn="l">
-              <a:lnSpc>
-                <a:spcPct val="105000"/>
-              </a:lnSpc>
-            </a:pPr>
-            <a:r>
-              <a:rPr sz="6000" b="1" i="0">
-                <a:solidFill>
-                  <a:srgbClr val="22371F"/>
-                </a:solidFill>
-                <a:latin typeface="Montserrat"/>
-              </a:rPr>
-              <a:t>Dog and cat</a:t>
-            </a:r>
-          </a:p>
-        </p:txBody>
-      </p:sp>
-      <p:sp>
-        <p:nvSpPr>
-          <p:cNvPr id="9" name="TextBox 8"/>
-          <p:cNvSpPr txBox="1"/>
-          <p:nvPr/>
-        </p:nvSpPr>
-        <p:spPr>
-          <a:xfrm>
-            <a:off x="762000" y="6880839"/>
-            <a:ext cx="8763000" cy="3619500"/>
-          </a:xfrm>
-          <a:prstGeom prst="rect">
-            <a:avLst/>
-          </a:prstGeom>
-          <a:noFill/>
-        </p:spPr>
-        <p:txBody>
-          <a:bodyPr wrap="square" lIns="0" rIns="0" tIns="0" bIns="0" anchor="t">
-            <a:spAutoFit/>
-          </a:bodyPr>
-          <a:lstStyle/>
-          <a:p>
-            <a:pPr algn="l">
-              <a:lnSpc>
-                <a:spcPct val="130000"/>
-              </a:lnSpc>
-            </a:pPr>
-            <a:r>
-              <a:rPr sz="3000" b="0" i="0">
-                <a:solidFill>
-                  <a:srgbClr val="333130"/>
-                </a:solidFill>
-                <a:latin typeface="Source Sans 3"/>
-              </a:rPr>
-              <a:t>Dog feces can carry roundworm (Toxocara) eggs. If swallowed, the larvae can migrate to the liver, lungs and eyes. Cat feces can carry Toxoplasma gondii, which people can also pick up from contaminated soil. USDA advises against using dog waste compost on food crops, even after hot composting, and against composting cat waste or litter at all.</a:t>
-            </a:r>
-          </a:p>
-        </p:txBody>
-      </p:sp>
-      <p:sp>
-        <p:nvSpPr>
-          <p:cNvPr id="10" name="TextBox 9"/>
-          <p:cNvSpPr txBox="1"/>
-          <p:nvPr/>
-        </p:nvSpPr>
-        <p:spPr>
-          <a:xfrm>
-            <a:off x="762000" y="12001500"/>
-            <a:ext cx="7524750" cy="228600"/>
-          </a:xfrm>
-          <a:prstGeom prst="rect">
-            <a:avLst/>
-          </a:prstGeom>
-          <a:noFill/>
-        </p:spPr>
-        <p:txBody>
-          <a:bodyPr wrap="square" lIns="0" rIns="0" tIns="0" bIns="0" anchor="t">
-            <a:spAutoFit/>
-          </a:bodyPr>
-          <a:lstStyle/>
-          <a:p>
-            <a:pPr algn="l">
-              <a:lnSpc>
-                <a:spcPct val="120000"/>
-              </a:lnSpc>
-            </a:pPr>
-            <a:r>
-              <a:rPr sz="1400" b="0" i="0">
-                <a:solidFill>
-                  <a:srgbClr val="333130">
-                    <a:alpha val="70000"/>
-                  </a:srgbClr>
-                </a:solidFill>
-                <a:latin typeface="Source Sans 3"/>
-              </a:rPr>
-              <a:t>USDA NRCS 2005; CDC 2025</a:t>
-            </a:r>
-          </a:p>
-        </p:txBody>
-      </p:sp>
-      <p:pic>
-        <p:nvPicPr>
-          <p:cNvPr id="11" name="Picture 10" descr="foundation-logo-color.png"/>
-          <p:cNvPicPr>
-            <a:picLocks noChangeAspect="1"/>
-          </p:cNvPicPr>
-          <p:nvPr/>
-        </p:nvPicPr>
-        <p:blipFill>
-          <a:blip r:embed="rId6"/>
-          <a:stretch>
-            <a:fillRect/>
-          </a:stretch>
-        </p:blipFill>
-        <p:spPr>
-          <a:xfrm>
-            <a:off x="8667750" y="11326032"/>
+            <a:off x="8667750" y="11516532"/>
             <a:ext cx="857250" cy="770717"/>
           </a:xfrm>
           <a:prstGeom prst="rect">
@@ -5860,7 +6139,7 @@
     <p:bg>
       <p:bgPr>
         <a:solidFill>
-          <a:srgbClr val="F4F1EA"/>
+          <a:srgbClr val="22371F"/>
         </a:solidFill>
         <a:effectLst/>
       </p:bgPr>
@@ -5872,48 +6151,9 @@
         <p:nvPr/>
       </p:nvGrpSpPr>
       <p:grpSpPr/>
-      <p:sp>
-        <p:nvSpPr>
-          <p:cNvPr id="2" name="TextBox 1"/>
-          <p:cNvSpPr txBox="1"/>
-          <p:nvPr/>
-        </p:nvSpPr>
-        <p:spPr>
-          <a:xfrm>
-            <a:off x="762000" y="952500"/>
-            <a:ext cx="7524750" cy="1831804"/>
-          </a:xfrm>
-          <a:prstGeom prst="rect">
-            <a:avLst/>
-          </a:prstGeom>
-          <a:noFill/>
-        </p:spPr>
-        <p:txBody>
-          <a:bodyPr wrap="square" lIns="0" rIns="0" tIns="0" bIns="0" anchor="t">
-            <a:spAutoFit/>
-          </a:bodyPr>
-          <a:lstStyle/>
-          <a:p>
-            <a:pPr algn="l">
-              <a:lnSpc>
-                <a:spcPct val="105000"/>
-              </a:lnSpc>
-            </a:pPr>
-            <a:r>
-              <a:rPr sz="6400" b="1" i="0">
-                <a:solidFill>
-                  <a:srgbClr val="22371F"/>
-                </a:solidFill>
-                <a:latin typeface="Montserrat"/>
-              </a:rPr>
-              <a:t>Slow or hot, both work.</a:t>
-            </a:r>
-          </a:p>
-        </p:txBody>
-      </p:sp>
       <p:pic>
         <p:nvPicPr>
-          <p:cNvPr id="3" name="Picture 2" descr="icon-compost-thermometer-green.png"/>
+          <p:cNvPr id="2" name="Picture 1" descr="6022986436313021774.jpg"/>
           <p:cNvPicPr>
             <a:picLocks noChangeAspect="1"/>
           </p:cNvPicPr>
@@ -5927,14 +6167,55 @@
         </p:blipFill>
         <p:spPr>
           <a:xfrm>
-            <a:off x="8572500" y="990600"/>
-            <a:ext cx="1047610" cy="1143000"/>
+            <a:off x="0" y="0"/>
+            <a:ext cx="10287000" cy="6667500"/>
           </a:xfrm>
           <a:prstGeom prst="rect">
             <a:avLst/>
           </a:prstGeom>
         </p:spPr>
       </p:pic>
+      <p:sp>
+        <p:nvSpPr>
+          <p:cNvPr id="3" name="TextBox 2"/>
+          <p:cNvSpPr txBox="1"/>
+          <p:nvPr/>
+        </p:nvSpPr>
+        <p:spPr>
+          <a:xfrm>
+            <a:off x="762000" y="6781800"/>
+            <a:ext cx="8763000" cy="228600"/>
+          </a:xfrm>
+          <a:prstGeom prst="rect">
+            <a:avLst/>
+          </a:prstGeom>
+          <a:noFill/>
+        </p:spPr>
+        <p:txBody>
+          <a:bodyPr wrap="square" lIns="0" rIns="0" tIns="0" bIns="0" anchor="t">
+            <a:spAutoFit/>
+          </a:bodyPr>
+          <a:lstStyle/>
+          <a:p>
+            <a:pPr algn="r">
+              <a:lnSpc>
+                <a:spcPct val="120000"/>
+              </a:lnSpc>
+            </a:pPr>
+            <a:r>
+              <a:rPr sz="1400" b="0" i="0">
+                <a:solidFill>
+                  <a:srgbClr val="F4F1EA">
+                    <a:alpha val="70000"/>
+                  </a:srgbClr>
+                </a:solidFill>
+                <a:latin typeface="Source Sans 3"/>
+              </a:rPr>
+              <a:t>Photo: iridial on Unsplash</a:t>
+            </a:r>
+          </a:p>
+        </p:txBody>
+      </p:sp>
       <p:sp>
         <p:nvSpPr>
           <p:cNvPr id="4" name="Rectangle 3"/>
@@ -5943,14 +6224,14 @@
         </p:nvSpPr>
         <p:spPr>
           <a:xfrm>
-            <a:off x="762000" y="3012904"/>
-            <a:ext cx="38100" cy="1562062"/>
+            <a:off x="762000" y="7239000"/>
+            <a:ext cx="2227287" cy="457200"/>
           </a:xfrm>
           <a:prstGeom prst="rect">
             <a:avLst/>
           </a:prstGeom>
           <a:solidFill>
-            <a:srgbClr val="156826"/>
+            <a:srgbClr val="B23A2E"/>
           </a:solidFill>
           <a:ln>
             <a:noFill/>
@@ -5979,149 +6260,9 @@
           </a:p>
         </p:txBody>
       </p:sp>
-      <p:sp>
-        <p:nvSpPr>
-          <p:cNvPr id="5" name="TextBox 4"/>
-          <p:cNvSpPr txBox="1"/>
-          <p:nvPr/>
-        </p:nvSpPr>
-        <p:spPr>
-          <a:xfrm>
-            <a:off x="1028700" y="3012904"/>
-            <a:ext cx="8496300" cy="1562062"/>
-          </a:xfrm>
-          <a:prstGeom prst="rect">
-            <a:avLst/>
-          </a:prstGeom>
-          <a:noFill/>
-        </p:spPr>
-        <p:txBody>
-          <a:bodyPr wrap="square" lIns="0" rIns="0" tIns="0" bIns="0">
-            <a:spAutoFit/>
-          </a:bodyPr>
-          <a:lstStyle/>
-          <a:p>
-            <a:pPr>
-              <a:lnSpc>
-                <a:spcPct val="130000"/>
-              </a:lnSpc>
-            </a:pPr>
-            <a:r>
-              <a:rPr sz="3000" b="1">
-                <a:solidFill>
-                  <a:srgbClr val="333130"/>
-                </a:solidFill>
-                <a:latin typeface="Montserrat"/>
-              </a:rPr>
-              <a:t>Cold or static pile: </a:t>
-            </a:r>
-            <a:r>
-              <a:rPr sz="3000" b="0">
-                <a:solidFill>
-                  <a:srgbClr val="333130"/>
-                </a:solidFill>
-                <a:latin typeface="Source Sans 3"/>
-              </a:rPr>
-              <a:t>fine for plant-eater and poultry manure, on a longer timeline.</a:t>
-            </a:r>
-          </a:p>
-        </p:txBody>
-      </p:sp>
-      <p:sp>
-        <p:nvSpPr>
-          <p:cNvPr id="6" name="Rectangle 5"/>
-          <p:cNvSpPr/>
-          <p:nvPr/>
-        </p:nvSpPr>
-        <p:spPr>
-          <a:xfrm>
-            <a:off x="762000" y="4841666"/>
-            <a:ext cx="38100" cy="1562062"/>
-          </a:xfrm>
-          <a:prstGeom prst="rect">
-            <a:avLst/>
-          </a:prstGeom>
-          <a:solidFill>
-            <a:srgbClr val="156826"/>
-          </a:solidFill>
-          <a:ln>
-            <a:noFill/>
-          </a:ln>
-          <a:effectLst/>
-        </p:spPr>
-        <p:style>
-          <a:lnRef idx="1">
-            <a:schemeClr val="accent1"/>
-          </a:lnRef>
-          <a:fillRef idx="3">
-            <a:schemeClr val="accent1"/>
-          </a:fillRef>
-          <a:effectRef idx="2">
-            <a:schemeClr val="accent1"/>
-          </a:effectRef>
-          <a:fontRef idx="minor">
-            <a:schemeClr val="lt1"/>
-          </a:fontRef>
-        </p:style>
-        <p:txBody>
-          <a:bodyPr rtlCol="0" anchor="ctr"/>
-          <a:lstStyle/>
-          <a:p>
-            <a:pPr algn="ctr"/>
-          </a:p>
-        </p:txBody>
-      </p:sp>
-      <p:sp>
-        <p:nvSpPr>
-          <p:cNvPr id="7" name="TextBox 6"/>
-          <p:cNvSpPr txBox="1"/>
-          <p:nvPr/>
-        </p:nvSpPr>
-        <p:spPr>
-          <a:xfrm>
-            <a:off x="1028700" y="4841666"/>
-            <a:ext cx="8496300" cy="1562062"/>
-          </a:xfrm>
-          <a:prstGeom prst="rect">
-            <a:avLst/>
-          </a:prstGeom>
-          <a:noFill/>
-        </p:spPr>
-        <p:txBody>
-          <a:bodyPr wrap="square" lIns="0" rIns="0" tIns="0" bIns="0">
-            <a:spAutoFit/>
-          </a:bodyPr>
-          <a:lstStyle/>
-          <a:p>
-            <a:pPr>
-              <a:lnSpc>
-                <a:spcPct val="130000"/>
-              </a:lnSpc>
-            </a:pPr>
-            <a:r>
-              <a:rPr sz="3000" b="1">
-                <a:solidFill>
-                  <a:srgbClr val="333130"/>
-                </a:solidFill>
-                <a:latin typeface="Montserrat"/>
-              </a:rPr>
-              <a:t>Thermophilic pile: </a:t>
-            </a:r>
-            <a:r>
-              <a:rPr sz="3000" b="0">
-                <a:solidFill>
-                  <a:srgbClr val="333130"/>
-                </a:solidFill>
-                <a:latin typeface="Source Sans 3"/>
-              </a:rPr>
-              <a:t>above 55°C (131°F) for 3 days at the center. Turn it so every part passes through the hot center.</a:t>
-            </a:r>
-          </a:p>
-        </p:txBody>
-      </p:sp>
       <p:pic>
         <p:nvPicPr>
-          <p:cNvPr id="8" name="Picture 7" descr="7039527272668188277.jpg"/>
+          <p:cNvPr id="5" name="Picture 4" descr="icon-crossed-circle-cream.png"/>
           <p:cNvPicPr>
             <a:picLocks noChangeAspect="1"/>
           </p:cNvPicPr>
@@ -6135,8 +6276,8 @@
         </p:blipFill>
         <p:spPr>
           <a:xfrm>
-            <a:off x="762000" y="6860929"/>
-            <a:ext cx="8763000" cy="4378570"/>
+            <a:off x="933450" y="7343775"/>
+            <a:ext cx="248107" cy="247650"/>
           </a:xfrm>
           <a:prstGeom prst="rect">
             <a:avLst/>
@@ -6145,14 +6286,14 @@
       </p:pic>
       <p:sp>
         <p:nvSpPr>
-          <p:cNvPr id="9" name="TextBox 8"/>
+          <p:cNvPr id="6" name="TextBox 5"/>
           <p:cNvSpPr txBox="1"/>
           <p:nvPr/>
         </p:nvSpPr>
         <p:spPr>
           <a:xfrm>
-            <a:off x="762000" y="11353800"/>
-            <a:ext cx="8763000" cy="228600"/>
+            <a:off x="1295400" y="7239000"/>
+            <a:ext cx="1693887" cy="457200"/>
           </a:xfrm>
           <a:prstGeom prst="rect">
             <a:avLst/>
@@ -6160,7 +6301,7 @@
           <a:noFill/>
         </p:spPr>
         <p:txBody>
-          <a:bodyPr wrap="square" lIns="0" rIns="0" tIns="0" bIns="0" anchor="t">
+          <a:bodyPr wrap="square" lIns="0" rIns="0" tIns="0" bIns="0" anchor="ctr">
             <a:spAutoFit/>
           </a:bodyPr>
           <a:lstStyle/>
@@ -6171,27 +6312,105 @@
               </a:lnSpc>
             </a:pPr>
             <a:r>
-              <a:rPr sz="1400" b="0" i="0">
+              <a:rPr sz="1800" b="1" i="0" spc="200">
                 <a:solidFill>
-                  <a:srgbClr val="6A665C"/>
+                  <a:srgbClr val="F4F1EA"/>
+                </a:solidFill>
+                <a:latin typeface="Montserrat"/>
+              </a:rPr>
+              <a:t>STAYS OUT</a:t>
+            </a:r>
+          </a:p>
+        </p:txBody>
+      </p:sp>
+      <p:sp>
+        <p:nvSpPr>
+          <p:cNvPr id="7" name="TextBox 6"/>
+          <p:cNvSpPr txBox="1"/>
+          <p:nvPr/>
+        </p:nvSpPr>
+        <p:spPr>
+          <a:xfrm>
+            <a:off x="762000" y="7867650"/>
+            <a:ext cx="8763000" cy="899139"/>
+          </a:xfrm>
+          <a:prstGeom prst="rect">
+            <a:avLst/>
+          </a:prstGeom>
+          <a:noFill/>
+        </p:spPr>
+        <p:txBody>
+          <a:bodyPr wrap="square" lIns="0" rIns="0" tIns="0" bIns="0" anchor="t">
+            <a:spAutoFit/>
+          </a:bodyPr>
+          <a:lstStyle/>
+          <a:p>
+            <a:pPr algn="l">
+              <a:lnSpc>
+                <a:spcPct val="105000"/>
+              </a:lnSpc>
+            </a:pPr>
+            <a:r>
+              <a:rPr sz="6000" b="1" i="0">
+                <a:solidFill>
+                  <a:srgbClr val="F4F1EA"/>
+                </a:solidFill>
+                <a:latin typeface="Montserrat"/>
+              </a:rPr>
+              <a:t>Dog and cat</a:t>
+            </a:r>
+          </a:p>
+        </p:txBody>
+      </p:sp>
+      <p:sp>
+        <p:nvSpPr>
+          <p:cNvPr id="8" name="TextBox 7"/>
+          <p:cNvSpPr txBox="1"/>
+          <p:nvPr/>
+        </p:nvSpPr>
+        <p:spPr>
+          <a:xfrm>
+            <a:off x="762000" y="8842989"/>
+            <a:ext cx="8763000" cy="1581112"/>
+          </a:xfrm>
+          <a:prstGeom prst="rect">
+            <a:avLst/>
+          </a:prstGeom>
+          <a:noFill/>
+        </p:spPr>
+        <p:txBody>
+          <a:bodyPr wrap="square" lIns="0" rIns="0" tIns="0" bIns="0" anchor="t">
+            <a:spAutoFit/>
+          </a:bodyPr>
+          <a:lstStyle/>
+          <a:p>
+            <a:pPr algn="l">
+              <a:lnSpc>
+                <a:spcPct val="130000"/>
+              </a:lnSpc>
+            </a:pPr>
+            <a:r>
+              <a:rPr sz="3000" b="0" i="0">
+                <a:solidFill>
+                  <a:srgbClr val="F4F1EA"/>
                 </a:solidFill>
                 <a:latin typeface="Source Sans 3"/>
               </a:rPr>
-              <a:t>Photo: Frank Thiemonge on Unsplash</a:t>
-            </a:r>
-          </a:p>
-        </p:txBody>
-      </p:sp>
-      <p:sp>
-        <p:nvSpPr>
-          <p:cNvPr id="10" name="TextBox 9"/>
+              <a:t>Dog feces can carry roundworm (Toxocara) eggs. If swallowed, the larvae can migrate to the liver, lungs and eyes.</a:t>
+            </a:r>
+          </a:p>
+        </p:txBody>
+      </p:sp>
+      <p:sp>
+        <p:nvSpPr>
+          <p:cNvPr id="9" name="TextBox 8"/>
           <p:cNvSpPr txBox="1"/>
           <p:nvPr/>
         </p:nvSpPr>
         <p:spPr>
           <a:xfrm>
-            <a:off x="762000" y="12001500"/>
-            <a:ext cx="7524750" cy="228600"/>
+            <a:off x="762000" y="12192000"/>
+            <a:ext cx="7429500" cy="228600"/>
           </a:xfrm>
           <a:prstGeom prst="rect">
             <a:avLst/>
@@ -6212,20 +6431,20 @@
             <a:r>
               <a:rPr sz="1400" b="0" i="0">
                 <a:solidFill>
-                  <a:srgbClr val="333130">
+                  <a:srgbClr val="F4F1EA">
                     <a:alpha val="70000"/>
                   </a:srgbClr>
                 </a:solidFill>
                 <a:latin typeface="Source Sans 3"/>
               </a:rPr>
-              <a:t>Soil Food Web School, Compost Manual</a:t>
+              <a:t>USDA NRCS 2005; CDC 2025</a:t>
             </a:r>
           </a:p>
         </p:txBody>
       </p:sp>
       <p:pic>
         <p:nvPicPr>
-          <p:cNvPr id="11" name="Picture 10" descr="foundation-logo-color.png"/>
+          <p:cNvPr id="10" name="Picture 9" descr="foundation-logo-white.png"/>
           <p:cNvPicPr>
             <a:picLocks noChangeAspect="1"/>
           </p:cNvPicPr>
@@ -6239,7 +6458,7 @@
         </p:blipFill>
         <p:spPr>
           <a:xfrm>
-            <a:off x="8667750" y="11326032"/>
+            <a:off x="8667750" y="11516532"/>
             <a:ext cx="857250" cy="770717"/>
           </a:xfrm>
           <a:prstGeom prst="rect">
@@ -6273,16 +6492,40 @@
         <p:nvPr/>
       </p:nvGrpSpPr>
       <p:grpSpPr/>
-      <p:sp>
-        <p:nvSpPr>
-          <p:cNvPr id="2" name="TextBox 1"/>
+      <p:pic>
+        <p:nvPicPr>
+          <p:cNvPr id="2" name="Picture 1" descr="7772190664404604023.jpg"/>
+          <p:cNvPicPr>
+            <a:picLocks noChangeAspect="1"/>
+          </p:cNvPicPr>
+          <p:nvPr/>
+        </p:nvPicPr>
+        <p:blipFill>
+          <a:blip r:embed="rId3"/>
+          <a:stretch>
+            <a:fillRect/>
+          </a:stretch>
+        </p:blipFill>
+        <p:spPr>
+          <a:xfrm>
+            <a:off x="0" y="0"/>
+            <a:ext cx="10287000" cy="6667500"/>
+          </a:xfrm>
+          <a:prstGeom prst="rect">
+            <a:avLst/>
+          </a:prstGeom>
+        </p:spPr>
+      </p:pic>
+      <p:sp>
+        <p:nvSpPr>
+          <p:cNvPr id="3" name="TextBox 2"/>
           <p:cNvSpPr txBox="1"/>
           <p:nvPr/>
         </p:nvSpPr>
         <p:spPr>
           <a:xfrm>
-            <a:off x="762000" y="1905000"/>
-            <a:ext cx="8763000" cy="3048000"/>
+            <a:off x="762000" y="6781800"/>
+            <a:ext cx="8763000" cy="228600"/>
           </a:xfrm>
           <a:prstGeom prst="rect">
             <a:avLst/>
@@ -6295,39 +6538,41 @@
           </a:bodyPr>
           <a:lstStyle/>
           <a:p>
-            <a:pPr algn="l">
+            <a:pPr algn="r">
               <a:lnSpc>
-                <a:spcPct val="105000"/>
+                <a:spcPct val="120000"/>
               </a:lnSpc>
             </a:pPr>
             <a:r>
-              <a:rPr sz="7200" b="1" i="0">
+              <a:rPr sz="1400" b="0" i="0">
                 <a:solidFill>
-                  <a:srgbClr val="F4F1EA"/>
+                  <a:srgbClr val="F4F1EA">
+                    <a:alpha val="70000"/>
+                  </a:srgbClr>
                 </a:solidFill>
-                <a:latin typeface="Montserrat"/>
+                <a:latin typeface="Source Sans 3"/>
               </a:rPr>
-              <a:t>Learn to build the pile with us.</a:t>
-            </a:r>
-          </a:p>
-        </p:txBody>
-      </p:sp>
-      <p:sp>
-        <p:nvSpPr>
-          <p:cNvPr id="3" name="Rectangle 2"/>
+              <a:t>Photo: Sean Foster on Unsplash</a:t>
+            </a:r>
+          </a:p>
+        </p:txBody>
+      </p:sp>
+      <p:sp>
+        <p:nvSpPr>
+          <p:cNvPr id="4" name="Rectangle 3"/>
           <p:cNvSpPr/>
           <p:nvPr/>
         </p:nvSpPr>
         <p:spPr>
           <a:xfrm>
-            <a:off x="762000" y="5143500"/>
-            <a:ext cx="1143000" cy="38100"/>
+            <a:off x="762000" y="7239000"/>
+            <a:ext cx="2227287" cy="457200"/>
           </a:xfrm>
           <a:prstGeom prst="rect">
             <a:avLst/>
           </a:prstGeom>
           <a:solidFill>
-            <a:srgbClr val="C9A227"/>
+            <a:srgbClr val="B23A2E"/>
           </a:solidFill>
           <a:ln>
             <a:noFill/>
@@ -6356,16 +6601,79 @@
           </a:p>
         </p:txBody>
       </p:sp>
-      <p:sp>
-        <p:nvSpPr>
-          <p:cNvPr id="4" name="TextBox 3"/>
+      <p:pic>
+        <p:nvPicPr>
+          <p:cNvPr id="5" name="Picture 4" descr="icon-crossed-circle-cream.png"/>
+          <p:cNvPicPr>
+            <a:picLocks noChangeAspect="1"/>
+          </p:cNvPicPr>
+          <p:nvPr/>
+        </p:nvPicPr>
+        <p:blipFill>
+          <a:blip r:embed="rId4"/>
+          <a:stretch>
+            <a:fillRect/>
+          </a:stretch>
+        </p:blipFill>
+        <p:spPr>
+          <a:xfrm>
+            <a:off x="933450" y="7343775"/>
+            <a:ext cx="248107" cy="247650"/>
+          </a:xfrm>
+          <a:prstGeom prst="rect">
+            <a:avLst/>
+          </a:prstGeom>
+        </p:spPr>
+      </p:pic>
+      <p:sp>
+        <p:nvSpPr>
+          <p:cNvPr id="6" name="TextBox 5"/>
           <p:cNvSpPr txBox="1"/>
           <p:nvPr/>
         </p:nvSpPr>
         <p:spPr>
           <a:xfrm>
-            <a:off x="762000" y="5524500"/>
-            <a:ext cx="8763000" cy="1143000"/>
+            <a:off x="1295400" y="7239000"/>
+            <a:ext cx="1693887" cy="457200"/>
+          </a:xfrm>
+          <a:prstGeom prst="rect">
+            <a:avLst/>
+          </a:prstGeom>
+          <a:noFill/>
+        </p:spPr>
+        <p:txBody>
+          <a:bodyPr wrap="square" lIns="0" rIns="0" tIns="0" bIns="0" anchor="ctr">
+            <a:spAutoFit/>
+          </a:bodyPr>
+          <a:lstStyle/>
+          <a:p>
+            <a:pPr algn="l">
+              <a:lnSpc>
+                <a:spcPct val="120000"/>
+              </a:lnSpc>
+            </a:pPr>
+            <a:r>
+              <a:rPr sz="1800" b="1" i="0" spc="200">
+                <a:solidFill>
+                  <a:srgbClr val="F4F1EA"/>
+                </a:solidFill>
+                <a:latin typeface="Montserrat"/>
+              </a:rPr>
+              <a:t>STAYS OUT</a:t>
+            </a:r>
+          </a:p>
+        </p:txBody>
+      </p:sp>
+      <p:sp>
+        <p:nvSpPr>
+          <p:cNvPr id="7" name="TextBox 6"/>
+          <p:cNvSpPr txBox="1"/>
+          <p:nvPr/>
+        </p:nvSpPr>
+        <p:spPr>
+          <a:xfrm>
+            <a:off x="762000" y="7962900"/>
+            <a:ext cx="8763000" cy="3066975"/>
           </a:xfrm>
           <a:prstGeom prst="rect">
             <a:avLst/>
@@ -6384,20 +6692,111 @@
               </a:lnSpc>
             </a:pPr>
             <a:r>
-              <a:rPr sz="3200" b="0" i="0">
+              <a:rPr sz="3000" b="0" i="0">
                 <a:solidFill>
                   <a:srgbClr val="F4F1EA"/>
                 </a:solidFill>
                 <a:latin typeface="Source Sans 3"/>
               </a:rPr>
-              <a:t>Advanced BioComplete Compost Production, at the Soil Food Web School. Link in bio.</a:t>
+              <a:t>Cat feces can carry Toxoplasma gondii, which people can also pick up from contaminated soil. USDA advises against using dog waste compost on food crops, even after hot composting, and against composting cat waste or litter at all.</a:t>
+            </a:r>
+          </a:p>
+        </p:txBody>
+      </p:sp>
+      <p:sp>
+        <p:nvSpPr>
+          <p:cNvPr id="8" name="TextBox 7"/>
+          <p:cNvSpPr txBox="1"/>
+          <p:nvPr/>
+        </p:nvSpPr>
+        <p:spPr>
+          <a:xfrm>
+            <a:off x="762000" y="12192000"/>
+            <a:ext cx="7429500" cy="228600"/>
+          </a:xfrm>
+          <a:prstGeom prst="rect">
+            <a:avLst/>
+          </a:prstGeom>
+          <a:noFill/>
+        </p:spPr>
+        <p:txBody>
+          <a:bodyPr wrap="square" lIns="0" rIns="0" tIns="0" bIns="0" anchor="t">
+            <a:spAutoFit/>
+          </a:bodyPr>
+          <a:lstStyle/>
+          <a:p>
+            <a:pPr algn="l">
+              <a:lnSpc>
+                <a:spcPct val="120000"/>
+              </a:lnSpc>
+            </a:pPr>
+            <a:r>
+              <a:rPr sz="1400" b="0" i="0">
+                <a:solidFill>
+                  <a:srgbClr val="F4F1EA">
+                    <a:alpha val="70000"/>
+                  </a:srgbClr>
+                </a:solidFill>
+                <a:latin typeface="Source Sans 3"/>
+              </a:rPr>
+              <a:t>USDA NRCS 2005; CDC 2025</a:t>
             </a:r>
           </a:p>
         </p:txBody>
       </p:sp>
       <p:pic>
         <p:nvPicPr>
-          <p:cNvPr id="5" name="Picture 4" descr="foundation-logo-white.png"/>
+          <p:cNvPr id="9" name="Picture 8" descr="foundation-logo-white.png"/>
+          <p:cNvPicPr>
+            <a:picLocks noChangeAspect="1"/>
+          </p:cNvPicPr>
+          <p:nvPr/>
+        </p:nvPicPr>
+        <p:blipFill>
+          <a:blip r:embed="rId5"/>
+          <a:stretch>
+            <a:fillRect/>
+          </a:stretch>
+        </p:blipFill>
+        <p:spPr>
+          <a:xfrm>
+            <a:off x="8667750" y="11516532"/>
+            <a:ext cx="857250" cy="770717"/>
+          </a:xfrm>
+          <a:prstGeom prst="rect">
+            <a:avLst/>
+          </a:prstGeom>
+        </p:spPr>
+      </p:pic>
+    </p:spTree>
+  </p:cSld>
+  <p:clrMapOvr>
+    <a:masterClrMapping/>
+  </p:clrMapOvr>
+</p:sld>
+</file>
+
+<file path=ppt/slides/slide8.xml><?xml version="1.0" encoding="utf-8"?>
+<p:sld xmlns:a="http://schemas.openxmlformats.org/drawingml/2006/main" xmlns:p="http://schemas.openxmlformats.org/presentationml/2006/main" xmlns:r="http://schemas.openxmlformats.org/officeDocument/2006/relationships">
+  <p:cSld>
+    <p:bg>
+      <p:bgPr>
+        <a:solidFill>
+          <a:srgbClr val="22371F"/>
+        </a:solidFill>
+        <a:effectLst/>
+      </p:bgPr>
+    </p:bg>
+    <p:spTree>
+      <p:nvGrpSpPr>
+        <p:cNvPr id="1" name=""/>
+        <p:cNvGrpSpPr/>
+        <p:nvPr/>
+      </p:nvGrpSpPr>
+      <p:grpSpPr/>
+      <p:pic>
+        <p:nvPicPr>
+          <p:cNvPr id="2" name="Picture 1" descr="5855271457778710851.jpg"/>
           <p:cNvPicPr>
             <a:picLocks noChangeAspect="1"/>
           </p:cNvPicPr>
@@ -6411,8 +6810,556 @@
         </p:blipFill>
         <p:spPr>
           <a:xfrm>
-            <a:off x="4000500" y="9688001"/>
-            <a:ext cx="2286000" cy="2055246"/>
+            <a:off x="0" y="0"/>
+            <a:ext cx="10287000" cy="6667500"/>
+          </a:xfrm>
+          <a:prstGeom prst="rect">
+            <a:avLst/>
+          </a:prstGeom>
+        </p:spPr>
+      </p:pic>
+      <p:sp>
+        <p:nvSpPr>
+          <p:cNvPr id="3" name="TextBox 2"/>
+          <p:cNvSpPr txBox="1"/>
+          <p:nvPr/>
+        </p:nvSpPr>
+        <p:spPr>
+          <a:xfrm>
+            <a:off x="762000" y="6781800"/>
+            <a:ext cx="8763000" cy="228600"/>
+          </a:xfrm>
+          <a:prstGeom prst="rect">
+            <a:avLst/>
+          </a:prstGeom>
+          <a:noFill/>
+        </p:spPr>
+        <p:txBody>
+          <a:bodyPr wrap="square" lIns="0" rIns="0" tIns="0" bIns="0" anchor="t">
+            <a:spAutoFit/>
+          </a:bodyPr>
+          <a:lstStyle/>
+          <a:p>
+            <a:pPr algn="r">
+              <a:lnSpc>
+                <a:spcPct val="120000"/>
+              </a:lnSpc>
+            </a:pPr>
+            <a:r>
+              <a:rPr sz="1400" b="0" i="0">
+                <a:solidFill>
+                  <a:srgbClr val="F4F1EA">
+                    <a:alpha val="70000"/>
+                  </a:srgbClr>
+                </a:solidFill>
+                <a:latin typeface="Source Sans 3"/>
+              </a:rPr>
+              <a:t>Photo: Edward Howell on Unsplash</a:t>
+            </a:r>
+          </a:p>
+        </p:txBody>
+      </p:sp>
+      <p:sp>
+        <p:nvSpPr>
+          <p:cNvPr id="4" name="TextBox 3"/>
+          <p:cNvSpPr txBox="1"/>
+          <p:nvPr/>
+        </p:nvSpPr>
+        <p:spPr>
+          <a:xfrm>
+            <a:off x="762000" y="7239000"/>
+            <a:ext cx="8763000" cy="1722078"/>
+          </a:xfrm>
+          <a:prstGeom prst="rect">
+            <a:avLst/>
+          </a:prstGeom>
+          <a:noFill/>
+        </p:spPr>
+        <p:txBody>
+          <a:bodyPr wrap="square" lIns="0" rIns="0" tIns="0" bIns="0" anchor="t">
+            <a:spAutoFit/>
+          </a:bodyPr>
+          <a:lstStyle/>
+          <a:p>
+            <a:pPr algn="l">
+              <a:lnSpc>
+                <a:spcPct val="105000"/>
+              </a:lnSpc>
+            </a:pPr>
+            <a:r>
+              <a:rPr sz="6000" b="1" i="0">
+                <a:solidFill>
+                  <a:srgbClr val="F4F1EA"/>
+                </a:solidFill>
+                <a:latin typeface="Montserrat"/>
+              </a:rPr>
+              <a:t>Slow or hot, both work.</a:t>
+            </a:r>
+          </a:p>
+        </p:txBody>
+      </p:sp>
+      <p:sp>
+        <p:nvSpPr>
+          <p:cNvPr id="5" name="Rectangle 4"/>
+          <p:cNvSpPr/>
+          <p:nvPr/>
+        </p:nvSpPr>
+        <p:spPr>
+          <a:xfrm>
+            <a:off x="762000" y="9189678"/>
+            <a:ext cx="57150" cy="1047750"/>
+          </a:xfrm>
+          <a:prstGeom prst="rect">
+            <a:avLst/>
+          </a:prstGeom>
+          <a:solidFill>
+            <a:srgbClr val="156826"/>
+          </a:solidFill>
+          <a:ln>
+            <a:noFill/>
+          </a:ln>
+          <a:effectLst/>
+        </p:spPr>
+        <p:style>
+          <a:lnRef idx="1">
+            <a:schemeClr val="accent1"/>
+          </a:lnRef>
+          <a:fillRef idx="3">
+            <a:schemeClr val="accent1"/>
+          </a:fillRef>
+          <a:effectRef idx="2">
+            <a:schemeClr val="accent1"/>
+          </a:effectRef>
+          <a:fontRef idx="minor">
+            <a:schemeClr val="lt1"/>
+          </a:fontRef>
+        </p:style>
+        <p:txBody>
+          <a:bodyPr rtlCol="0" anchor="ctr"/>
+          <a:lstStyle/>
+          <a:p>
+            <a:pPr algn="ctr"/>
+          </a:p>
+        </p:txBody>
+      </p:sp>
+      <p:sp>
+        <p:nvSpPr>
+          <p:cNvPr id="6" name="TextBox 5"/>
+          <p:cNvSpPr txBox="1"/>
+          <p:nvPr/>
+        </p:nvSpPr>
+        <p:spPr>
+          <a:xfrm>
+            <a:off x="1047750" y="9189678"/>
+            <a:ext cx="8477250" cy="1085825"/>
+          </a:xfrm>
+          <a:prstGeom prst="rect">
+            <a:avLst/>
+          </a:prstGeom>
+          <a:noFill/>
+        </p:spPr>
+        <p:txBody>
+          <a:bodyPr wrap="square" lIns="0" rIns="0" tIns="0" bIns="0">
+            <a:spAutoFit/>
+          </a:bodyPr>
+          <a:lstStyle/>
+          <a:p>
+            <a:pPr>
+              <a:lnSpc>
+                <a:spcPct val="130000"/>
+              </a:lnSpc>
+            </a:pPr>
+            <a:r>
+              <a:rPr sz="3000" b="1">
+                <a:solidFill>
+                  <a:srgbClr val="F4F1EA"/>
+                </a:solidFill>
+                <a:latin typeface="Montserrat"/>
+              </a:rPr>
+              <a:t>Cold or static pile: </a:t>
+            </a:r>
+            <a:r>
+              <a:rPr sz="3000" b="0">
+                <a:solidFill>
+                  <a:srgbClr val="F4F1EA"/>
+                </a:solidFill>
+                <a:latin typeface="Source Sans 3"/>
+              </a:rPr>
+              <a:t>fine for plant-eater and poultry manure, on a longer timeline.</a:t>
+            </a:r>
+          </a:p>
+        </p:txBody>
+      </p:sp>
+      <p:sp>
+        <p:nvSpPr>
+          <p:cNvPr id="7" name="TextBox 6"/>
+          <p:cNvSpPr txBox="1"/>
+          <p:nvPr/>
+        </p:nvSpPr>
+        <p:spPr>
+          <a:xfrm>
+            <a:off x="762000" y="12192000"/>
+            <a:ext cx="7429500" cy="228600"/>
+          </a:xfrm>
+          <a:prstGeom prst="rect">
+            <a:avLst/>
+          </a:prstGeom>
+          <a:noFill/>
+        </p:spPr>
+        <p:txBody>
+          <a:bodyPr wrap="square" lIns="0" rIns="0" tIns="0" bIns="0" anchor="t">
+            <a:spAutoFit/>
+          </a:bodyPr>
+          <a:lstStyle/>
+          <a:p>
+            <a:pPr algn="l">
+              <a:lnSpc>
+                <a:spcPct val="120000"/>
+              </a:lnSpc>
+            </a:pPr>
+            <a:r>
+              <a:rPr sz="1400" b="0" i="0">
+                <a:solidFill>
+                  <a:srgbClr val="F4F1EA">
+                    <a:alpha val="70000"/>
+                  </a:srgbClr>
+                </a:solidFill>
+                <a:latin typeface="Source Sans 3"/>
+              </a:rPr>
+              <a:t>Soil Food Web School, Compost Manual</a:t>
+            </a:r>
+          </a:p>
+        </p:txBody>
+      </p:sp>
+      <p:pic>
+        <p:nvPicPr>
+          <p:cNvPr id="8" name="Picture 7" descr="foundation-logo-white.png"/>
+          <p:cNvPicPr>
+            <a:picLocks noChangeAspect="1"/>
+          </p:cNvPicPr>
+          <p:nvPr/>
+        </p:nvPicPr>
+        <p:blipFill>
+          <a:blip r:embed="rId4"/>
+          <a:stretch>
+            <a:fillRect/>
+          </a:stretch>
+        </p:blipFill>
+        <p:spPr>
+          <a:xfrm>
+            <a:off x="8667750" y="11516532"/>
+            <a:ext cx="857250" cy="770717"/>
+          </a:xfrm>
+          <a:prstGeom prst="rect">
+            <a:avLst/>
+          </a:prstGeom>
+        </p:spPr>
+      </p:pic>
+    </p:spTree>
+  </p:cSld>
+  <p:clrMapOvr>
+    <a:masterClrMapping/>
+  </p:clrMapOvr>
+</p:sld>
+</file>
+
+<file path=ppt/slides/slide9.xml><?xml version="1.0" encoding="utf-8"?>
+<p:sld xmlns:a="http://schemas.openxmlformats.org/drawingml/2006/main" xmlns:p="http://schemas.openxmlformats.org/presentationml/2006/main" xmlns:r="http://schemas.openxmlformats.org/officeDocument/2006/relationships">
+  <p:cSld>
+    <p:bg>
+      <p:bgPr>
+        <a:solidFill>
+          <a:srgbClr val="22371F"/>
+        </a:solidFill>
+        <a:effectLst/>
+      </p:bgPr>
+    </p:bg>
+    <p:spTree>
+      <p:nvGrpSpPr>
+        <p:cNvPr id="1" name=""/>
+        <p:cNvGrpSpPr/>
+        <p:nvPr/>
+      </p:nvGrpSpPr>
+      <p:grpSpPr/>
+      <p:pic>
+        <p:nvPicPr>
+          <p:cNvPr id="2" name="Picture 1" descr="8488270156968558901.jpg"/>
+          <p:cNvPicPr>
+            <a:picLocks noChangeAspect="1"/>
+          </p:cNvPicPr>
+          <p:nvPr/>
+        </p:nvPicPr>
+        <p:blipFill>
+          <a:blip r:embed="rId3"/>
+          <a:stretch>
+            <a:fillRect/>
+          </a:stretch>
+        </p:blipFill>
+        <p:spPr>
+          <a:xfrm>
+            <a:off x="0" y="0"/>
+            <a:ext cx="10287000" cy="6667500"/>
+          </a:xfrm>
+          <a:prstGeom prst="rect">
+            <a:avLst/>
+          </a:prstGeom>
+        </p:spPr>
+      </p:pic>
+      <p:sp>
+        <p:nvSpPr>
+          <p:cNvPr id="3" name="TextBox 2"/>
+          <p:cNvSpPr txBox="1"/>
+          <p:nvPr/>
+        </p:nvSpPr>
+        <p:spPr>
+          <a:xfrm>
+            <a:off x="762000" y="6781800"/>
+            <a:ext cx="8763000" cy="228600"/>
+          </a:xfrm>
+          <a:prstGeom prst="rect">
+            <a:avLst/>
+          </a:prstGeom>
+          <a:noFill/>
+        </p:spPr>
+        <p:txBody>
+          <a:bodyPr wrap="square" lIns="0" rIns="0" tIns="0" bIns="0" anchor="t">
+            <a:spAutoFit/>
+          </a:bodyPr>
+          <a:lstStyle/>
+          <a:p>
+            <a:pPr algn="r">
+              <a:lnSpc>
+                <a:spcPct val="120000"/>
+              </a:lnSpc>
+            </a:pPr>
+            <a:r>
+              <a:rPr sz="1400" b="0" i="0">
+                <a:solidFill>
+                  <a:srgbClr val="F4F1EA">
+                    <a:alpha val="70000"/>
+                  </a:srgbClr>
+                </a:solidFill>
+                <a:latin typeface="Source Sans 3"/>
+              </a:rPr>
+              <a:t>Photo: Frank Thiemonge on Unsplash</a:t>
+            </a:r>
+          </a:p>
+        </p:txBody>
+      </p:sp>
+      <p:pic>
+        <p:nvPicPr>
+          <p:cNvPr id="4" name="Picture 3" descr="icon-compost-thermometer-cream.png"/>
+          <p:cNvPicPr>
+            <a:picLocks noChangeAspect="1"/>
+          </p:cNvPicPr>
+          <p:nvPr/>
+        </p:nvPicPr>
+        <p:blipFill>
+          <a:blip r:embed="rId4"/>
+          <a:stretch>
+            <a:fillRect/>
+          </a:stretch>
+        </p:blipFill>
+        <p:spPr>
+          <a:xfrm>
+            <a:off x="8477250" y="7239000"/>
+            <a:ext cx="1047610" cy="1143000"/>
+          </a:xfrm>
+          <a:prstGeom prst="rect">
+            <a:avLst/>
+          </a:prstGeom>
+        </p:spPr>
+      </p:pic>
+      <p:sp>
+        <p:nvSpPr>
+          <p:cNvPr id="5" name="TextBox 4"/>
+          <p:cNvSpPr txBox="1"/>
+          <p:nvPr/>
+        </p:nvSpPr>
+        <p:spPr>
+          <a:xfrm>
+            <a:off x="762000" y="7239000"/>
+            <a:ext cx="7429500" cy="1722078"/>
+          </a:xfrm>
+          <a:prstGeom prst="rect">
+            <a:avLst/>
+          </a:prstGeom>
+          <a:noFill/>
+        </p:spPr>
+        <p:txBody>
+          <a:bodyPr wrap="square" lIns="0" rIns="0" tIns="0" bIns="0" anchor="t">
+            <a:spAutoFit/>
+          </a:bodyPr>
+          <a:lstStyle/>
+          <a:p>
+            <a:pPr algn="l">
+              <a:lnSpc>
+                <a:spcPct val="105000"/>
+              </a:lnSpc>
+            </a:pPr>
+            <a:r>
+              <a:rPr sz="6000" b="1" i="0">
+                <a:solidFill>
+                  <a:srgbClr val="F4F1EA"/>
+                </a:solidFill>
+                <a:latin typeface="Montserrat"/>
+              </a:rPr>
+              <a:t>Slow or hot, both work.</a:t>
+            </a:r>
+          </a:p>
+        </p:txBody>
+      </p:sp>
+      <p:sp>
+        <p:nvSpPr>
+          <p:cNvPr id="6" name="Rectangle 5"/>
+          <p:cNvSpPr/>
+          <p:nvPr/>
+        </p:nvSpPr>
+        <p:spPr>
+          <a:xfrm>
+            <a:off x="762000" y="9189678"/>
+            <a:ext cx="57150" cy="1524000"/>
+          </a:xfrm>
+          <a:prstGeom prst="rect">
+            <a:avLst/>
+          </a:prstGeom>
+          <a:solidFill>
+            <a:srgbClr val="156826"/>
+          </a:solidFill>
+          <a:ln>
+            <a:noFill/>
+          </a:ln>
+          <a:effectLst/>
+        </p:spPr>
+        <p:style>
+          <a:lnRef idx="1">
+            <a:schemeClr val="accent1"/>
+          </a:lnRef>
+          <a:fillRef idx="3">
+            <a:schemeClr val="accent1"/>
+          </a:fillRef>
+          <a:effectRef idx="2">
+            <a:schemeClr val="accent1"/>
+          </a:effectRef>
+          <a:fontRef idx="minor">
+            <a:schemeClr val="lt1"/>
+          </a:fontRef>
+        </p:style>
+        <p:txBody>
+          <a:bodyPr rtlCol="0" anchor="ctr"/>
+          <a:lstStyle/>
+          <a:p>
+            <a:pPr algn="ctr"/>
+          </a:p>
+        </p:txBody>
+      </p:sp>
+      <p:sp>
+        <p:nvSpPr>
+          <p:cNvPr id="7" name="TextBox 6"/>
+          <p:cNvSpPr txBox="1"/>
+          <p:nvPr/>
+        </p:nvSpPr>
+        <p:spPr>
+          <a:xfrm>
+            <a:off x="1047750" y="9189678"/>
+            <a:ext cx="8477250" cy="1581112"/>
+          </a:xfrm>
+          <a:prstGeom prst="rect">
+            <a:avLst/>
+          </a:prstGeom>
+          <a:noFill/>
+        </p:spPr>
+        <p:txBody>
+          <a:bodyPr wrap="square" lIns="0" rIns="0" tIns="0" bIns="0">
+            <a:spAutoFit/>
+          </a:bodyPr>
+          <a:lstStyle/>
+          <a:p>
+            <a:pPr>
+              <a:lnSpc>
+                <a:spcPct val="130000"/>
+              </a:lnSpc>
+            </a:pPr>
+            <a:r>
+              <a:rPr sz="3000" b="1">
+                <a:solidFill>
+                  <a:srgbClr val="F4F1EA"/>
+                </a:solidFill>
+                <a:latin typeface="Montserrat"/>
+              </a:rPr>
+              <a:t>Thermophilic pile: </a:t>
+            </a:r>
+            <a:r>
+              <a:rPr sz="3000" b="0">
+                <a:solidFill>
+                  <a:srgbClr val="F4F1EA"/>
+                </a:solidFill>
+                <a:latin typeface="Source Sans 3"/>
+              </a:rPr>
+              <a:t>above 55°C (131°F) for 3 days at the center. Turn it so every part passes through the hot center.</a:t>
+            </a:r>
+          </a:p>
+        </p:txBody>
+      </p:sp>
+      <p:sp>
+        <p:nvSpPr>
+          <p:cNvPr id="8" name="TextBox 7"/>
+          <p:cNvSpPr txBox="1"/>
+          <p:nvPr/>
+        </p:nvSpPr>
+        <p:spPr>
+          <a:xfrm>
+            <a:off x="762000" y="12192000"/>
+            <a:ext cx="7429500" cy="228600"/>
+          </a:xfrm>
+          <a:prstGeom prst="rect">
+            <a:avLst/>
+          </a:prstGeom>
+          <a:noFill/>
+        </p:spPr>
+        <p:txBody>
+          <a:bodyPr wrap="square" lIns="0" rIns="0" tIns="0" bIns="0" anchor="t">
+            <a:spAutoFit/>
+          </a:bodyPr>
+          <a:lstStyle/>
+          <a:p>
+            <a:pPr algn="l">
+              <a:lnSpc>
+                <a:spcPct val="120000"/>
+              </a:lnSpc>
+            </a:pPr>
+            <a:r>
+              <a:rPr sz="1400" b="0" i="0">
+                <a:solidFill>
+                  <a:srgbClr val="F4F1EA">
+                    <a:alpha val="70000"/>
+                  </a:srgbClr>
+                </a:solidFill>
+                <a:latin typeface="Source Sans 3"/>
+              </a:rPr>
+              <a:t>Soil Food Web School, Compost Manual</a:t>
+            </a:r>
+          </a:p>
+        </p:txBody>
+      </p:sp>
+      <p:pic>
+        <p:nvPicPr>
+          <p:cNvPr id="9" name="Picture 8" descr="foundation-logo-white.png"/>
+          <p:cNvPicPr>
+            <a:picLocks noChangeAspect="1"/>
+          </p:cNvPicPr>
+          <p:nvPr/>
+        </p:nvPicPr>
+        <p:blipFill>
+          <a:blip r:embed="rId5"/>
+          <a:stretch>
+            <a:fillRect/>
+          </a:stretch>
+        </p:blipFill>
+        <p:spPr>
+          <a:xfrm>
+            <a:off x="8667750" y="11516532"/>
+            <a:ext cx="857250" cy="770717"/>
           </a:xfrm>
           <a:prstGeom prst="rect">
             <a:avLst/>

</xml_diff>

<commit_message>
World Animal Day v2: closing slide uses the course name and its copy-deck description instead of the old headline
Co-Authored-By: Claude Opus 5.5 <noreply@anthropic.com>
Claude-Session: https://claude.ai/code/session_014HGzAbxBh54nuyJHG7tse8
</commit_message>
<xml_diff>
--- a/templates/posts/october/04-10-2026-sun-ig-world-animal-day-v2.pptx
+++ b/templates/posts/october/04-10-2026-sun-ig-world-animal-day-v2.pptx
@@ -4149,7 +4149,7 @@
       <p:grpSpPr/>
       <p:pic>
         <p:nvPicPr>
-          <p:cNvPr id="2" name="Picture 1" descr="3188314740401158450.jpg"/>
+          <p:cNvPr id="2" name="Picture 1" descr="4549106575680551216.jpg"/>
           <p:cNvPicPr>
             <a:picLocks noChangeAspect="1"/>
           </p:cNvPicPr>
@@ -4394,8 +4394,8 @@
         </p:nvSpPr>
         <p:spPr>
           <a:xfrm>
-            <a:off x="762000" y="1905000"/>
-            <a:ext cx="8763000" cy="3048000"/>
+            <a:off x="762000" y="1619250"/>
+            <a:ext cx="8763000" cy="3587408"/>
           </a:xfrm>
           <a:prstGeom prst="rect">
             <a:avLst/>
@@ -4414,13 +4414,13 @@
               </a:lnSpc>
             </a:pPr>
             <a:r>
-              <a:rPr sz="7200" b="1" i="0">
+              <a:rPr sz="6400" b="1" i="0">
                 <a:solidFill>
                   <a:srgbClr val="F4F1EA"/>
                 </a:solidFill>
                 <a:latin typeface="Montserrat"/>
               </a:rPr>
-              <a:t>Learn to build the pile with us.</a:t>
+              <a:t>Advanced BioComplete Compost Production</a:t>
             </a:r>
           </a:p>
         </p:txBody>
@@ -4433,7 +4433,7 @@
         </p:nvSpPr>
         <p:spPr>
           <a:xfrm>
-            <a:off x="762000" y="5143500"/>
+            <a:off x="762000" y="6096000"/>
             <a:ext cx="1143000" cy="38100"/>
           </a:xfrm>
           <a:prstGeom prst="rect">
@@ -4477,8 +4477,8 @@
         </p:nvSpPr>
         <p:spPr>
           <a:xfrm>
-            <a:off x="762000" y="5524500"/>
-            <a:ext cx="8763000" cy="1143000"/>
+            <a:off x="762000" y="6477000"/>
+            <a:ext cx="8763000" cy="1680170"/>
           </a:xfrm>
           <a:prstGeom prst="rect">
             <a:avLst/>
@@ -4503,7 +4503,7 @@
                 </a:solidFill>
                 <a:latin typeface="Source Sans 3"/>
               </a:rPr>
-              <a:t>Advanced BioComplete Compost Production, at the Soil Food Web School. Link in bio.</a:t>
+              <a:t>Building and assessing three compost piles that meet biological minimums. At the Soil Food Web School. Link in bio.</a:t>
             </a:r>
           </a:p>
         </p:txBody>
@@ -5303,7 +5303,7 @@
       <p:grpSpPr/>
       <p:pic>
         <p:nvPicPr>
-          <p:cNvPr id="2" name="Picture 1" descr="6284106477514029212.jpg"/>
+          <p:cNvPr id="2" name="Picture 1" descr="8684675481822683666.jpg"/>
           <p:cNvPicPr>
             <a:picLocks noChangeAspect="1"/>
           </p:cNvPicPr>
@@ -5327,7 +5327,7 @@
       </p:pic>
       <p:pic>
         <p:nvPicPr>
-          <p:cNvPr id="3" name="Picture 2" descr="1144354356172924792.jpg"/>
+          <p:cNvPr id="3" name="Picture 2" descr="4818609014556034615.jpg"/>
           <p:cNvPicPr>
             <a:picLocks noChangeAspect="1"/>
           </p:cNvPicPr>
@@ -5351,7 +5351,7 @@
       </p:pic>
       <p:pic>
         <p:nvPicPr>
-          <p:cNvPr id="4" name="Picture 3" descr="1755564328169200639.jpg"/>
+          <p:cNvPr id="4" name="Picture 3" descr="7884999685889186300.jpg"/>
           <p:cNvPicPr>
             <a:picLocks noChangeAspect="1"/>
           </p:cNvPicPr>
@@ -5375,7 +5375,7 @@
       </p:pic>
       <p:pic>
         <p:nvPicPr>
-          <p:cNvPr id="5" name="Picture 4" descr="8714548284258820098.jpg"/>
+          <p:cNvPr id="5" name="Picture 4" descr="7232961000811291792.jpg"/>
           <p:cNvPicPr>
             <a:picLocks noChangeAspect="1"/>
           </p:cNvPicPr>
@@ -5399,7 +5399,7 @@
       </p:pic>
       <p:pic>
         <p:nvPicPr>
-          <p:cNvPr id="6" name="Picture 5" descr="486322804598397402.jpg"/>
+          <p:cNvPr id="6" name="Picture 5" descr="8313124085066336902.jpg"/>
           <p:cNvPicPr>
             <a:picLocks noChangeAspect="1"/>
           </p:cNvPicPr>
@@ -5423,7 +5423,7 @@
       </p:pic>
       <p:pic>
         <p:nvPicPr>
-          <p:cNvPr id="7" name="Picture 6" descr="705502393350176899.jpg"/>
+          <p:cNvPr id="7" name="Picture 6" descr="6916300996393180844.jpg"/>
           <p:cNvPicPr>
             <a:picLocks noChangeAspect="1"/>
           </p:cNvPicPr>
@@ -5447,7 +5447,7 @@
       </p:pic>
       <p:pic>
         <p:nvPicPr>
-          <p:cNvPr id="8" name="Picture 7" descr="4228659823346108929.jpg"/>
+          <p:cNvPr id="8" name="Picture 7" descr="2809481218529070526.jpg"/>
           <p:cNvPicPr>
             <a:picLocks noChangeAspect="1"/>
           </p:cNvPicPr>
@@ -5471,7 +5471,7 @@
       </p:pic>
       <p:pic>
         <p:nvPicPr>
-          <p:cNvPr id="9" name="Picture 8" descr="4842180892687044427.jpg"/>
+          <p:cNvPr id="9" name="Picture 8" descr="356401069179824979.jpg"/>
           <p:cNvPicPr>
             <a:picLocks noChangeAspect="1"/>
           </p:cNvPicPr>
@@ -5812,7 +5812,7 @@
       <p:grpSpPr/>
       <p:pic>
         <p:nvPicPr>
-          <p:cNvPr id="2" name="Picture 1" descr="4102147720830019452.jpg"/>
+          <p:cNvPr id="2" name="Picture 1" descr="8962753842354720273.jpg"/>
           <p:cNvPicPr>
             <a:picLocks noChangeAspect="1"/>
           </p:cNvPicPr>
@@ -6153,7 +6153,7 @@
       <p:grpSpPr/>
       <p:pic>
         <p:nvPicPr>
-          <p:cNvPr id="2" name="Picture 1" descr="6022986436313021774.jpg"/>
+          <p:cNvPr id="2" name="Picture 1" descr="5434546009825580332.jpg"/>
           <p:cNvPicPr>
             <a:picLocks noChangeAspect="1"/>
           </p:cNvPicPr>
@@ -6494,7 +6494,7 @@
       <p:grpSpPr/>
       <p:pic>
         <p:nvPicPr>
-          <p:cNvPr id="2" name="Picture 1" descr="7772190664404604023.jpg"/>
+          <p:cNvPr id="2" name="Picture 1" descr="3344292299206373740.jpg"/>
           <p:cNvPicPr>
             <a:picLocks noChangeAspect="1"/>
           </p:cNvPicPr>
@@ -6796,7 +6796,7 @@
       <p:grpSpPr/>
       <p:pic>
         <p:nvPicPr>
-          <p:cNvPr id="2" name="Picture 1" descr="5855271457778710851.jpg"/>
+          <p:cNvPr id="2" name="Picture 1" descr="7437048142426058951.jpg"/>
           <p:cNvPicPr>
             <a:picLocks noChangeAspect="1"/>
           </p:cNvPicPr>
@@ -7083,7 +7083,7 @@
       <p:grpSpPr/>
       <p:pic>
         <p:nvPicPr>
-          <p:cNvPr id="2" name="Picture 1" descr="8488270156968558901.jpg"/>
+          <p:cNvPr id="2" name="Picture 1" descr="1361381514013476660.jpg"/>
           <p:cNvPicPr>
             <a:picLocks noChangeAspect="1"/>
           </p:cNvPicPr>

</xml_diff>

<commit_message>
World Animal Day v2: brand palette from docs/brand-colors.md (green, cream, brown, tan, sage; gold only on the warning label); brown and cream icon versions
Co-Authored-By: Claude Opus 5.5 <noreply@anthropic.com>
Claude-Session: https://claude.ai/code/session_014HGzAbxBh54nuyJHG7tse8
</commit_message>
<xml_diff>
--- a/templates/posts/october/04-10-2026-sun-ig-world-animal-day-v2.pptx
+++ b/templates/posts/october/04-10-2026-sun-ig-world-animal-day-v2.pptx
@@ -4149,7 +4149,7 @@
       <p:grpSpPr/>
       <p:pic>
         <p:nvPicPr>
-          <p:cNvPr id="2" name="Picture 1" descr="4549106575680551216.jpg"/>
+          <p:cNvPr id="2" name="Picture 1" descr="5835826515524478425.jpg"/>
           <p:cNvPicPr>
             <a:picLocks noChangeAspect="1"/>
           </p:cNvPicPr>
@@ -4186,7 +4186,7 @@
             <a:avLst/>
           </a:prstGeom>
           <a:solidFill>
-            <a:srgbClr val="22371F">
+            <a:srgbClr val="31662F">
               <a:alpha val="40000"/>
             </a:srgbClr>
           </a:solidFill>
@@ -4247,7 +4247,7 @@
             <a:r>
               <a:rPr sz="8000" b="1" i="0">
                 <a:solidFill>
-                  <a:srgbClr val="F4F1EA"/>
+                  <a:srgbClr val="F3F1EA"/>
                 </a:solidFill>
                 <a:latin typeface="Montserrat"/>
               </a:rPr>
@@ -4286,7 +4286,7 @@
             <a:r>
               <a:rPr sz="3000" b="0" i="0">
                 <a:solidFill>
-                  <a:srgbClr val="F4F1EA"/>
+                  <a:srgbClr val="F3F1EA"/>
                 </a:solidFill>
                 <a:latin typeface="Source Sans 3"/>
               </a:rPr>
@@ -4325,7 +4325,7 @@
             <a:r>
               <a:rPr sz="1400" b="0" i="0">
                 <a:solidFill>
-                  <a:srgbClr val="F4F1EA">
+                  <a:srgbClr val="F3F1EA">
                     <a:alpha val="75000"/>
                   </a:srgbClr>
                 </a:solidFill>
@@ -4374,7 +4374,7 @@
     <p:bg>
       <p:bgPr>
         <a:solidFill>
-          <a:srgbClr val="22371F"/>
+          <a:srgbClr val="31662F"/>
         </a:solidFill>
         <a:effectLst/>
       </p:bgPr>
@@ -4416,7 +4416,7 @@
             <a:r>
               <a:rPr sz="6400" b="1" i="0">
                 <a:solidFill>
-                  <a:srgbClr val="F4F1EA"/>
+                  <a:srgbClr val="F3F1EA"/>
                 </a:solidFill>
                 <a:latin typeface="Montserrat"/>
               </a:rPr>
@@ -4440,7 +4440,7 @@
             <a:avLst/>
           </a:prstGeom>
           <a:solidFill>
-            <a:srgbClr val="C9A227"/>
+            <a:srgbClr val="C09D7F"/>
           </a:solidFill>
           <a:ln>
             <a:noFill/>
@@ -4499,7 +4499,7 @@
             <a:r>
               <a:rPr sz="3200" b="0" i="0">
                 <a:solidFill>
-                  <a:srgbClr val="F4F1EA"/>
+                  <a:srgbClr val="F3F1EA"/>
                 </a:solidFill>
                 <a:latin typeface="Source Sans 3"/>
               </a:rPr>
@@ -4546,7 +4546,7 @@
     <p:bg>
       <p:bgPr>
         <a:solidFill>
-          <a:srgbClr val="22371F"/>
+          <a:srgbClr val="31662F"/>
         </a:solidFill>
         <a:effectLst/>
       </p:bgPr>
@@ -4560,7 +4560,7 @@
       <p:grpSpPr/>
       <p:pic>
         <p:nvPicPr>
-          <p:cNvPr id="2" name="Picture 1" descr="icon-manure-fork-cream.png"/>
+          <p:cNvPr id="2" name="Picture 1" descr="icon-manure-fork-brandcream.png"/>
           <p:cNvPicPr>
             <a:picLocks noChangeAspect="1"/>
           </p:cNvPicPr>
@@ -4612,7 +4612,7 @@
             <a:r>
               <a:rPr sz="6400" b="1" i="0">
                 <a:solidFill>
-                  <a:srgbClr val="F4F1EA"/>
+                  <a:srgbClr val="F3F1EA"/>
                 </a:solidFill>
                 <a:latin typeface="Montserrat"/>
               </a:rPr>
@@ -4651,7 +4651,7 @@
             <a:r>
               <a:rPr sz="3200" b="0" i="0">
                 <a:solidFill>
-                  <a:srgbClr val="F4F1EA"/>
+                  <a:srgbClr val="F3F1EA"/>
                 </a:solidFill>
                 <a:latin typeface="Source Sans 3"/>
               </a:rPr>
@@ -4690,7 +4690,7 @@
             <a:r>
               <a:rPr sz="1400" b="0" i="0">
                 <a:solidFill>
-                  <a:srgbClr val="F4F1EA">
+                  <a:srgbClr val="F3F1EA">
                     <a:alpha val="70000"/>
                   </a:srgbClr>
                 </a:solidFill>
@@ -4739,7 +4739,7 @@
     <p:bg>
       <p:bgPr>
         <a:solidFill>
-          <a:srgbClr val="22371F"/>
+          <a:srgbClr val="31662F"/>
         </a:solidFill>
         <a:effectLst/>
       </p:bgPr>
@@ -4753,7 +4753,7 @@
       <p:grpSpPr/>
       <p:pic>
         <p:nvPicPr>
-          <p:cNvPr id="2" name="Picture 1" descr="icon-manure-fork-cream.png"/>
+          <p:cNvPr id="2" name="Picture 1" descr="icon-manure-fork-brandcream.png"/>
           <p:cNvPicPr>
             <a:picLocks noChangeAspect="1"/>
           </p:cNvPicPr>
@@ -4805,7 +4805,7 @@
             <a:r>
               <a:rPr sz="4000" b="1" i="0">
                 <a:solidFill>
-                  <a:srgbClr val="F4F1EA"/>
+                  <a:srgbClr val="F3F1EA"/>
                 </a:solidFill>
                 <a:latin typeface="Montserrat"/>
               </a:rPr>
@@ -4829,7 +4829,7 @@
             <a:avLst/>
           </a:prstGeom>
           <a:solidFill>
-            <a:srgbClr val="F4F1EA">
+            <a:srgbClr val="F3F1EA">
               <a:alpha val="15000"/>
             </a:srgbClr>
           </a:solidFill>
@@ -4875,7 +4875,7 @@
             <a:avLst/>
           </a:prstGeom>
           <a:solidFill>
-            <a:srgbClr val="C9A227"/>
+            <a:srgbClr val="C09D7F"/>
           </a:solidFill>
           <a:ln>
             <a:noFill/>
@@ -4906,7 +4906,7 @@
       </p:sp>
       <p:pic>
         <p:nvPicPr>
-          <p:cNvPr id="6" name="Picture 5" descr="icon-leaf-cream.png"/>
+          <p:cNvPr id="6" name="Picture 5" descr="icon-leaf-brandcream.png"/>
           <p:cNvPicPr>
             <a:picLocks noChangeAspect="1"/>
           </p:cNvPicPr>
@@ -4958,7 +4958,7 @@
             <a:r>
               <a:rPr sz="4000" b="1" i="0">
                 <a:solidFill>
-                  <a:srgbClr val="F4F1EA"/>
+                  <a:srgbClr val="F3F1EA"/>
                 </a:solidFill>
                 <a:latin typeface="Montserrat"/>
               </a:rPr>
@@ -4982,7 +4982,7 @@
             <a:avLst/>
           </a:prstGeom>
           <a:solidFill>
-            <a:srgbClr val="F4F1EA">
+            <a:srgbClr val="F3F1EA">
               <a:alpha val="15000"/>
             </a:srgbClr>
           </a:solidFill>
@@ -5028,7 +5028,7 @@
             <a:avLst/>
           </a:prstGeom>
           <a:solidFill>
-            <a:srgbClr val="156826"/>
+            <a:srgbClr val="B1BCB1"/>
           </a:solidFill>
           <a:ln>
             <a:noFill/>
@@ -5059,7 +5059,7 @@
       </p:sp>
       <p:pic>
         <p:nvPicPr>
-          <p:cNvPr id="10" name="Picture 9" descr="icon-wood-log-cream.png"/>
+          <p:cNvPr id="10" name="Picture 9" descr="icon-wood-log-brandcream.png"/>
           <p:cNvPicPr>
             <a:picLocks noChangeAspect="1"/>
           </p:cNvPicPr>
@@ -5111,7 +5111,7 @@
             <a:r>
               <a:rPr sz="4000" b="1" i="0">
                 <a:solidFill>
-                  <a:srgbClr val="F4F1EA"/>
+                  <a:srgbClr val="F3F1EA"/>
                 </a:solidFill>
                 <a:latin typeface="Montserrat"/>
               </a:rPr>
@@ -5135,7 +5135,7 @@
             <a:avLst/>
           </a:prstGeom>
           <a:solidFill>
-            <a:srgbClr val="F4F1EA">
+            <a:srgbClr val="F3F1EA">
               <a:alpha val="15000"/>
             </a:srgbClr>
           </a:solidFill>
@@ -5181,7 +5181,7 @@
             <a:avLst/>
           </a:prstGeom>
           <a:solidFill>
-            <a:srgbClr val="F4F1EA"/>
+            <a:srgbClr val="F3F1EA"/>
           </a:solidFill>
           <a:ln>
             <a:noFill/>
@@ -5240,7 +5240,7 @@
             <a:r>
               <a:rPr sz="1400" b="0" i="0">
                 <a:solidFill>
-                  <a:srgbClr val="F4F1EA">
+                  <a:srgbClr val="F3F1EA">
                     <a:alpha val="70000"/>
                   </a:srgbClr>
                 </a:solidFill>
@@ -5289,7 +5289,7 @@
     <p:bg>
       <p:bgPr>
         <a:solidFill>
-          <a:srgbClr val="22371F"/>
+          <a:srgbClr val="31662F"/>
         </a:solidFill>
         <a:effectLst/>
       </p:bgPr>
@@ -5303,7 +5303,7 @@
       <p:grpSpPr/>
       <p:pic>
         <p:nvPicPr>
-          <p:cNvPr id="2" name="Picture 1" descr="8684675481822683666.jpg"/>
+          <p:cNvPr id="2" name="Picture 1" descr="6911941987674459904.jpg"/>
           <p:cNvPicPr>
             <a:picLocks noChangeAspect="1"/>
           </p:cNvPicPr>
@@ -5327,7 +5327,7 @@
       </p:pic>
       <p:pic>
         <p:nvPicPr>
-          <p:cNvPr id="3" name="Picture 2" descr="4818609014556034615.jpg"/>
+          <p:cNvPr id="3" name="Picture 2" descr="1291503702506409711.jpg"/>
           <p:cNvPicPr>
             <a:picLocks noChangeAspect="1"/>
           </p:cNvPicPr>
@@ -5351,7 +5351,7 @@
       </p:pic>
       <p:pic>
         <p:nvPicPr>
-          <p:cNvPr id="4" name="Picture 3" descr="7884999685889186300.jpg"/>
+          <p:cNvPr id="4" name="Picture 3" descr="8515591358624607398.jpg"/>
           <p:cNvPicPr>
             <a:picLocks noChangeAspect="1"/>
           </p:cNvPicPr>
@@ -5375,7 +5375,7 @@
       </p:pic>
       <p:pic>
         <p:nvPicPr>
-          <p:cNvPr id="5" name="Picture 4" descr="7232961000811291792.jpg"/>
+          <p:cNvPr id="5" name="Picture 4" descr="4788378761293882730.jpg"/>
           <p:cNvPicPr>
             <a:picLocks noChangeAspect="1"/>
           </p:cNvPicPr>
@@ -5399,7 +5399,7 @@
       </p:pic>
       <p:pic>
         <p:nvPicPr>
-          <p:cNvPr id="6" name="Picture 5" descr="8313124085066336902.jpg"/>
+          <p:cNvPr id="6" name="Picture 5" descr="7473557858597618278.jpg"/>
           <p:cNvPicPr>
             <a:picLocks noChangeAspect="1"/>
           </p:cNvPicPr>
@@ -5423,7 +5423,7 @@
       </p:pic>
       <p:pic>
         <p:nvPicPr>
-          <p:cNvPr id="7" name="Picture 6" descr="6916300996393180844.jpg"/>
+          <p:cNvPr id="7" name="Picture 6" descr="1214270348257068615.jpg"/>
           <p:cNvPicPr>
             <a:picLocks noChangeAspect="1"/>
           </p:cNvPicPr>
@@ -5447,7 +5447,7 @@
       </p:pic>
       <p:pic>
         <p:nvPicPr>
-          <p:cNvPr id="8" name="Picture 7" descr="2809481218529070526.jpg"/>
+          <p:cNvPr id="8" name="Picture 7" descr="1283615763225098772.jpg"/>
           <p:cNvPicPr>
             <a:picLocks noChangeAspect="1"/>
           </p:cNvPicPr>
@@ -5471,7 +5471,7 @@
       </p:pic>
       <p:pic>
         <p:nvPicPr>
-          <p:cNvPr id="9" name="Picture 8" descr="356401069179824979.jpg"/>
+          <p:cNvPr id="9" name="Picture 8" descr="3102190124690147418.jpg"/>
           <p:cNvPicPr>
             <a:picLocks noChangeAspect="1"/>
           </p:cNvPicPr>
@@ -5523,7 +5523,7 @@
             <a:r>
               <a:rPr sz="1400" b="0" i="0">
                 <a:solidFill>
-                  <a:srgbClr val="F4F1EA">
+                  <a:srgbClr val="F3F1EA">
                     <a:alpha val="70000"/>
                   </a:srgbClr>
                 </a:solidFill>
@@ -5549,7 +5549,7 @@
             <a:avLst/>
           </a:prstGeom>
           <a:solidFill>
-            <a:srgbClr val="156826"/>
+            <a:srgbClr val="B1BCB1"/>
           </a:solidFill>
           <a:ln>
             <a:noFill/>
@@ -5580,7 +5580,7 @@
       </p:sp>
       <p:pic>
         <p:nvPicPr>
-          <p:cNvPr id="12" name="Picture 11" descr="icon-check-mark-cream.png"/>
+          <p:cNvPr id="12" name="Picture 11" descr="icon-check-mark-brown.png"/>
           <p:cNvPicPr>
             <a:picLocks noChangeAspect="1"/>
           </p:cNvPicPr>
@@ -5632,7 +5632,7 @@
             <a:r>
               <a:rPr sz="1800" b="1" i="0" spc="200">
                 <a:solidFill>
-                  <a:srgbClr val="F4F1EA"/>
+                  <a:srgbClr val="4C3634"/>
                 </a:solidFill>
                 <a:latin typeface="Montserrat"/>
               </a:rPr>
@@ -5671,7 +5671,7 @@
             <a:r>
               <a:rPr sz="6000" b="1" i="0">
                 <a:solidFill>
-                  <a:srgbClr val="F4F1EA"/>
+                  <a:srgbClr val="F3F1EA"/>
                 </a:solidFill>
                 <a:latin typeface="Montserrat"/>
               </a:rPr>
@@ -5710,7 +5710,7 @@
             <a:r>
               <a:rPr sz="3000" b="0" i="0">
                 <a:solidFill>
-                  <a:srgbClr val="F4F1EA"/>
+                  <a:srgbClr val="F3F1EA"/>
                 </a:solidFill>
                 <a:latin typeface="Source Sans 3"/>
               </a:rPr>
@@ -5749,7 +5749,7 @@
             <a:r>
               <a:rPr sz="1400" b="0" i="0">
                 <a:solidFill>
-                  <a:srgbClr val="F4F1EA">
+                  <a:srgbClr val="F3F1EA">
                     <a:alpha val="70000"/>
                   </a:srgbClr>
                 </a:solidFill>
@@ -5798,7 +5798,7 @@
     <p:bg>
       <p:bgPr>
         <a:solidFill>
-          <a:srgbClr val="22371F"/>
+          <a:srgbClr val="31662F"/>
         </a:solidFill>
         <a:effectLst/>
       </p:bgPr>
@@ -5812,7 +5812,7 @@
       <p:grpSpPr/>
       <p:pic>
         <p:nvPicPr>
-          <p:cNvPr id="2" name="Picture 1" descr="8962753842354720273.jpg"/>
+          <p:cNvPr id="2" name="Picture 1" descr="6059099507751574629.jpg"/>
           <p:cNvPicPr>
             <a:picLocks noChangeAspect="1"/>
           </p:cNvPicPr>
@@ -5864,7 +5864,7 @@
             <a:r>
               <a:rPr sz="1400" b="0" i="0">
                 <a:solidFill>
-                  <a:srgbClr val="F4F1EA">
+                  <a:srgbClr val="F3F1EA">
                     <a:alpha val="70000"/>
                   </a:srgbClr>
                 </a:solidFill>
@@ -5890,7 +5890,7 @@
             <a:avLst/>
           </a:prstGeom>
           <a:solidFill>
-            <a:srgbClr val="C9A227"/>
+            <a:srgbClr val="D39C48"/>
           </a:solidFill>
           <a:ln>
             <a:noFill/>
@@ -5921,7 +5921,7 @@
       </p:sp>
       <p:pic>
         <p:nvPicPr>
-          <p:cNvPr id="5" name="Picture 4" descr="icon-flame-deep.png"/>
+          <p:cNvPr id="5" name="Picture 4" descr="icon-flame-brown.png"/>
           <p:cNvPicPr>
             <a:picLocks noChangeAspect="1"/>
           </p:cNvPicPr>
@@ -5973,7 +5973,7 @@
             <a:r>
               <a:rPr sz="1800" b="1" i="0" spc="200">
                 <a:solidFill>
-                  <a:srgbClr val="22371F"/>
+                  <a:srgbClr val="4C3634"/>
                 </a:solidFill>
                 <a:latin typeface="Montserrat"/>
               </a:rPr>
@@ -6012,7 +6012,7 @@
             <a:r>
               <a:rPr sz="6000" b="1" i="0">
                 <a:solidFill>
-                  <a:srgbClr val="F4F1EA"/>
+                  <a:srgbClr val="F3F1EA"/>
                 </a:solidFill>
                 <a:latin typeface="Montserrat"/>
               </a:rPr>
@@ -6051,7 +6051,7 @@
             <a:r>
               <a:rPr sz="3000" b="0" i="0">
                 <a:solidFill>
-                  <a:srgbClr val="F4F1EA"/>
+                  <a:srgbClr val="F3F1EA"/>
                 </a:solidFill>
                 <a:latin typeface="Source Sans 3"/>
               </a:rPr>
@@ -6090,7 +6090,7 @@
             <a:r>
               <a:rPr sz="1400" b="0" i="0">
                 <a:solidFill>
-                  <a:srgbClr val="F4F1EA">
+                  <a:srgbClr val="F3F1EA">
                     <a:alpha val="70000"/>
                   </a:srgbClr>
                 </a:solidFill>
@@ -6139,7 +6139,7 @@
     <p:bg>
       <p:bgPr>
         <a:solidFill>
-          <a:srgbClr val="22371F"/>
+          <a:srgbClr val="31662F"/>
         </a:solidFill>
         <a:effectLst/>
       </p:bgPr>
@@ -6153,7 +6153,7 @@
       <p:grpSpPr/>
       <p:pic>
         <p:nvPicPr>
-          <p:cNvPr id="2" name="Picture 1" descr="5434546009825580332.jpg"/>
+          <p:cNvPr id="2" name="Picture 1" descr="7679222450807580094.jpg"/>
           <p:cNvPicPr>
             <a:picLocks noChangeAspect="1"/>
           </p:cNvPicPr>
@@ -6205,7 +6205,7 @@
             <a:r>
               <a:rPr sz="1400" b="0" i="0">
                 <a:solidFill>
-                  <a:srgbClr val="F4F1EA">
+                  <a:srgbClr val="F3F1EA">
                     <a:alpha val="70000"/>
                   </a:srgbClr>
                 </a:solidFill>
@@ -6262,7 +6262,7 @@
       </p:sp>
       <p:pic>
         <p:nvPicPr>
-          <p:cNvPr id="5" name="Picture 4" descr="icon-crossed-circle-cream.png"/>
+          <p:cNvPr id="5" name="Picture 4" descr="icon-crossed-circle-brandcream.png"/>
           <p:cNvPicPr>
             <a:picLocks noChangeAspect="1"/>
           </p:cNvPicPr>
@@ -6314,7 +6314,7 @@
             <a:r>
               <a:rPr sz="1800" b="1" i="0" spc="200">
                 <a:solidFill>
-                  <a:srgbClr val="F4F1EA"/>
+                  <a:srgbClr val="F3F1EA"/>
                 </a:solidFill>
                 <a:latin typeface="Montserrat"/>
               </a:rPr>
@@ -6353,7 +6353,7 @@
             <a:r>
               <a:rPr sz="6000" b="1" i="0">
                 <a:solidFill>
-                  <a:srgbClr val="F4F1EA"/>
+                  <a:srgbClr val="F3F1EA"/>
                 </a:solidFill>
                 <a:latin typeface="Montserrat"/>
               </a:rPr>
@@ -6392,7 +6392,7 @@
             <a:r>
               <a:rPr sz="3000" b="0" i="0">
                 <a:solidFill>
-                  <a:srgbClr val="F4F1EA"/>
+                  <a:srgbClr val="F3F1EA"/>
                 </a:solidFill>
                 <a:latin typeface="Source Sans 3"/>
               </a:rPr>
@@ -6431,7 +6431,7 @@
             <a:r>
               <a:rPr sz="1400" b="0" i="0">
                 <a:solidFill>
-                  <a:srgbClr val="F4F1EA">
+                  <a:srgbClr val="F3F1EA">
                     <a:alpha val="70000"/>
                   </a:srgbClr>
                 </a:solidFill>
@@ -6480,7 +6480,7 @@
     <p:bg>
       <p:bgPr>
         <a:solidFill>
-          <a:srgbClr val="22371F"/>
+          <a:srgbClr val="31662F"/>
         </a:solidFill>
         <a:effectLst/>
       </p:bgPr>
@@ -6494,7 +6494,7 @@
       <p:grpSpPr/>
       <p:pic>
         <p:nvPicPr>
-          <p:cNvPr id="2" name="Picture 1" descr="3344292299206373740.jpg"/>
+          <p:cNvPr id="2" name="Picture 1" descr="3841256753744932992.jpg"/>
           <p:cNvPicPr>
             <a:picLocks noChangeAspect="1"/>
           </p:cNvPicPr>
@@ -6546,7 +6546,7 @@
             <a:r>
               <a:rPr sz="1400" b="0" i="0">
                 <a:solidFill>
-                  <a:srgbClr val="F4F1EA">
+                  <a:srgbClr val="F3F1EA">
                     <a:alpha val="70000"/>
                   </a:srgbClr>
                 </a:solidFill>
@@ -6603,7 +6603,7 @@
       </p:sp>
       <p:pic>
         <p:nvPicPr>
-          <p:cNvPr id="5" name="Picture 4" descr="icon-crossed-circle-cream.png"/>
+          <p:cNvPr id="5" name="Picture 4" descr="icon-crossed-circle-brandcream.png"/>
           <p:cNvPicPr>
             <a:picLocks noChangeAspect="1"/>
           </p:cNvPicPr>
@@ -6655,7 +6655,7 @@
             <a:r>
               <a:rPr sz="1800" b="1" i="0" spc="200">
                 <a:solidFill>
-                  <a:srgbClr val="F4F1EA"/>
+                  <a:srgbClr val="F3F1EA"/>
                 </a:solidFill>
                 <a:latin typeface="Montserrat"/>
               </a:rPr>
@@ -6694,7 +6694,7 @@
             <a:r>
               <a:rPr sz="3000" b="0" i="0">
                 <a:solidFill>
-                  <a:srgbClr val="F4F1EA"/>
+                  <a:srgbClr val="F3F1EA"/>
                 </a:solidFill>
                 <a:latin typeface="Source Sans 3"/>
               </a:rPr>
@@ -6733,7 +6733,7 @@
             <a:r>
               <a:rPr sz="1400" b="0" i="0">
                 <a:solidFill>
-                  <a:srgbClr val="F4F1EA">
+                  <a:srgbClr val="F3F1EA">
                     <a:alpha val="70000"/>
                   </a:srgbClr>
                 </a:solidFill>
@@ -6782,7 +6782,7 @@
     <p:bg>
       <p:bgPr>
         <a:solidFill>
-          <a:srgbClr val="22371F"/>
+          <a:srgbClr val="31662F"/>
         </a:solidFill>
         <a:effectLst/>
       </p:bgPr>
@@ -6796,7 +6796,7 @@
       <p:grpSpPr/>
       <p:pic>
         <p:nvPicPr>
-          <p:cNvPr id="2" name="Picture 1" descr="7437048142426058951.jpg"/>
+          <p:cNvPr id="2" name="Picture 1" descr="8128748687846789531.jpg"/>
           <p:cNvPicPr>
             <a:picLocks noChangeAspect="1"/>
           </p:cNvPicPr>
@@ -6848,7 +6848,7 @@
             <a:r>
               <a:rPr sz="1400" b="0" i="0">
                 <a:solidFill>
-                  <a:srgbClr val="F4F1EA">
+                  <a:srgbClr val="F3F1EA">
                     <a:alpha val="70000"/>
                   </a:srgbClr>
                 </a:solidFill>
@@ -6889,7 +6889,7 @@
             <a:r>
               <a:rPr sz="6000" b="1" i="0">
                 <a:solidFill>
-                  <a:srgbClr val="F4F1EA"/>
+                  <a:srgbClr val="F3F1EA"/>
                 </a:solidFill>
                 <a:latin typeface="Montserrat"/>
               </a:rPr>
@@ -6913,7 +6913,7 @@
             <a:avLst/>
           </a:prstGeom>
           <a:solidFill>
-            <a:srgbClr val="156826"/>
+            <a:srgbClr val="B1BCB1"/>
           </a:solidFill>
           <a:ln>
             <a:noFill/>
@@ -6972,7 +6972,7 @@
             <a:r>
               <a:rPr sz="3000" b="1">
                 <a:solidFill>
-                  <a:srgbClr val="F4F1EA"/>
+                  <a:srgbClr val="F3F1EA"/>
                 </a:solidFill>
                 <a:latin typeface="Montserrat"/>
               </a:rPr>
@@ -6981,7 +6981,7 @@
             <a:r>
               <a:rPr sz="3000" b="0">
                 <a:solidFill>
-                  <a:srgbClr val="F4F1EA"/>
+                  <a:srgbClr val="F3F1EA"/>
                 </a:solidFill>
                 <a:latin typeface="Source Sans 3"/>
               </a:rPr>
@@ -7020,7 +7020,7 @@
             <a:r>
               <a:rPr sz="1400" b="0" i="0">
                 <a:solidFill>
-                  <a:srgbClr val="F4F1EA">
+                  <a:srgbClr val="F3F1EA">
                     <a:alpha val="70000"/>
                   </a:srgbClr>
                 </a:solidFill>
@@ -7069,7 +7069,7 @@
     <p:bg>
       <p:bgPr>
         <a:solidFill>
-          <a:srgbClr val="22371F"/>
+          <a:srgbClr val="31662F"/>
         </a:solidFill>
         <a:effectLst/>
       </p:bgPr>
@@ -7083,7 +7083,7 @@
       <p:grpSpPr/>
       <p:pic>
         <p:nvPicPr>
-          <p:cNvPr id="2" name="Picture 1" descr="1361381514013476660.jpg"/>
+          <p:cNvPr id="2" name="Picture 1" descr="5389844344590544122.jpg"/>
           <p:cNvPicPr>
             <a:picLocks noChangeAspect="1"/>
           </p:cNvPicPr>
@@ -7135,7 +7135,7 @@
             <a:r>
               <a:rPr sz="1400" b="0" i="0">
                 <a:solidFill>
-                  <a:srgbClr val="F4F1EA">
+                  <a:srgbClr val="F3F1EA">
                     <a:alpha val="70000"/>
                   </a:srgbClr>
                 </a:solidFill>
@@ -7148,7 +7148,7 @@
       </p:sp>
       <p:pic>
         <p:nvPicPr>
-          <p:cNvPr id="4" name="Picture 3" descr="icon-compost-thermometer-cream.png"/>
+          <p:cNvPr id="4" name="Picture 3" descr="icon-compost-thermometer-brandcream.png"/>
           <p:cNvPicPr>
             <a:picLocks noChangeAspect="1"/>
           </p:cNvPicPr>
@@ -7200,7 +7200,7 @@
             <a:r>
               <a:rPr sz="6000" b="1" i="0">
                 <a:solidFill>
-                  <a:srgbClr val="F4F1EA"/>
+                  <a:srgbClr val="F3F1EA"/>
                 </a:solidFill>
                 <a:latin typeface="Montserrat"/>
               </a:rPr>
@@ -7224,7 +7224,7 @@
             <a:avLst/>
           </a:prstGeom>
           <a:solidFill>
-            <a:srgbClr val="156826"/>
+            <a:srgbClr val="B1BCB1"/>
           </a:solidFill>
           <a:ln>
             <a:noFill/>
@@ -7283,7 +7283,7 @@
             <a:r>
               <a:rPr sz="3000" b="1">
                 <a:solidFill>
-                  <a:srgbClr val="F4F1EA"/>
+                  <a:srgbClr val="F3F1EA"/>
                 </a:solidFill>
                 <a:latin typeface="Montserrat"/>
               </a:rPr>
@@ -7292,7 +7292,7 @@
             <a:r>
               <a:rPr sz="3000" b="0">
                 <a:solidFill>
-                  <a:srgbClr val="F4F1EA"/>
+                  <a:srgbClr val="F3F1EA"/>
                 </a:solidFill>
                 <a:latin typeface="Source Sans 3"/>
               </a:rPr>
@@ -7331,7 +7331,7 @@
             <a:r>
               <a:rPr sz="1400" b="0" i="0">
                 <a:solidFill>
-                  <a:srgbClr val="F4F1EA">
+                  <a:srgbClr val="F3F1EA">
                     <a:alpha val="70000"/>
                   </a:srgbClr>
                 </a:solidFill>

</xml_diff>